<commit_message>
Report and slides: add LightGBM
LightGBM joins every table and chart that compares the regressors: headline
and per-fold tables, error-by-subgroup table and chart, robustness table, and
the methods, interpretation (split-gain shares), comparison and conclusion
text. The report notes that LightGBM is the weakest daily regressor and falls
just below the training mean on the weekly panel. Body still ends on page 7.
</commit_message>
<xml_diff>
--- a/report/Group7_Presentation_DRAFT.pptx
+++ b/report/Group7_Presentation_DRAFT.pptx
@@ -153,9 +153,9 @@
           </c:spPr>
           <c:cat>
             <c:strRef>
-              <c:f>Sheet1!$A$2:$A$5</c:f>
+              <c:f>Sheet1!$A$2:$A$6</c:f>
               <c:strCache>
-                <c:ptCount val="4"/>
+                <c:ptCount val="5"/>
                 <c:pt idx="0">
                   <c:v>KNN</c:v>
                 </c:pt>
@@ -163,9 +163,12 @@
                   <c:v>Random Forest</c:v>
                 </c:pt>
                 <c:pt idx="2">
+                  <c:v>LightGBM</c:v>
+                </c:pt>
+                <c:pt idx="3">
                   <c:v>Ridge</c:v>
                 </c:pt>
-                <c:pt idx="3">
+                <c:pt idx="4">
                   <c:v>Elastic Net</c:v>
                 </c:pt>
               </c:strCache>
@@ -173,10 +176,10 @@
           </c:cat>
           <c:val>
             <c:numRef>
-              <c:f>Sheet1!$B$2:$B$5</c:f>
+              <c:f>Sheet1!$B$2:$B$6</c:f>
               <c:numCache>
                 <c:formatCode>General</c:formatCode>
-                <c:ptCount val="4"/>
+                <c:ptCount val="5"/>
                 <c:pt idx="0">
                   <c:v>0.234</c:v>
                 </c:pt>
@@ -184,9 +187,12 @@
                   <c:v>0.262</c:v>
                 </c:pt>
                 <c:pt idx="2">
+                  <c:v>0.225</c:v>
+                </c:pt>
+                <c:pt idx="3">
                   <c:v>0.266</c:v>
                 </c:pt>
-                <c:pt idx="3">
+                <c:pt idx="4">
                   <c:v>0.254</c:v>
                 </c:pt>
               </c:numCache>
@@ -214,9 +220,9 @@
           </c:spPr>
           <c:cat>
             <c:strRef>
-              <c:f>Sheet1!$A$2:$A$5</c:f>
+              <c:f>Sheet1!$A$2:$A$6</c:f>
               <c:strCache>
-                <c:ptCount val="4"/>
+                <c:ptCount val="5"/>
                 <c:pt idx="0">
                   <c:v>KNN</c:v>
                 </c:pt>
@@ -224,9 +230,12 @@
                   <c:v>Random Forest</c:v>
                 </c:pt>
                 <c:pt idx="2">
+                  <c:v>LightGBM</c:v>
+                </c:pt>
+                <c:pt idx="3">
                   <c:v>Ridge</c:v>
                 </c:pt>
-                <c:pt idx="3">
+                <c:pt idx="4">
                   <c:v>Elastic Net</c:v>
                 </c:pt>
               </c:strCache>
@@ -234,10 +243,10 @@
           </c:cat>
           <c:val>
             <c:numRef>
-              <c:f>Sheet1!$C$2:$C$5</c:f>
+              <c:f>Sheet1!$C$2:$C$6</c:f>
               <c:numCache>
                 <c:formatCode>General</c:formatCode>
-                <c:ptCount val="4"/>
+                <c:ptCount val="5"/>
                 <c:pt idx="0">
                   <c:v>0.235</c:v>
                 </c:pt>
@@ -245,9 +254,12 @@
                   <c:v>0.268</c:v>
                 </c:pt>
                 <c:pt idx="2">
+                  <c:v>0.23</c:v>
+                </c:pt>
+                <c:pt idx="3">
                   <c:v>0.266</c:v>
                 </c:pt>
-                <c:pt idx="3">
+                <c:pt idx="4">
                   <c:v>0.255</c:v>
                 </c:pt>
               </c:numCache>
@@ -545,6 +557,74 @@
               <c:strCache>
                 <c:ptCount val="1"/>
                 <c:pt idx="0">
+                  <c:v>LightGBM</c:v>
+                </c:pt>
+              </c:strCache>
+            </c:strRef>
+          </c:tx>
+          <c:spPr>
+            <a:solidFill>
+              <a:srgbClr val="1BAF7A"/>
+            </a:solidFill>
+          </c:spPr>
+          <c:invertIfNegative val="0"/>
+          <c:cat>
+            <c:strRef>
+              <c:f>Sheet1!$A$2:$A$6</c:f>
+              <c:strCache>
+                <c:ptCount val="5"/>
+                <c:pt idx="0">
+                  <c:v>Fold 1</c:v>
+                </c:pt>
+                <c:pt idx="1">
+                  <c:v>Fold 2</c:v>
+                </c:pt>
+                <c:pt idx="2">
+                  <c:v>Fold 3</c:v>
+                </c:pt>
+                <c:pt idx="3">
+                  <c:v>Fold 4</c:v>
+                </c:pt>
+                <c:pt idx="4">
+                  <c:v>Fold 5</c:v>
+                </c:pt>
+              </c:strCache>
+            </c:strRef>
+          </c:cat>
+          <c:val>
+            <c:numRef>
+              <c:f>Sheet1!$D$2:$D$6</c:f>
+              <c:numCache>
+                <c:formatCode>General</c:formatCode>
+                <c:ptCount val="5"/>
+                <c:pt idx="0">
+                  <c:v>-0.013</c:v>
+                </c:pt>
+                <c:pt idx="1">
+                  <c:v>0.044</c:v>
+                </c:pt>
+                <c:pt idx="2">
+                  <c:v>-0.0</c:v>
+                </c:pt>
+                <c:pt idx="3">
+                  <c:v>-0.005</c:v>
+                </c:pt>
+                <c:pt idx="4">
+                  <c:v>-0.002</c:v>
+                </c:pt>
+              </c:numCache>
+            </c:numRef>
+          </c:val>
+        </c:ser>
+        <c:ser>
+          <c:idx val="3"/>
+          <c:order val="3"/>
+          <c:tx>
+            <c:strRef>
+              <c:f>Sheet1!$E$1</c:f>
+              <c:strCache>
+                <c:ptCount val="1"/>
+                <c:pt idx="0">
                   <c:v>Ridge</c:v>
                 </c:pt>
               </c:strCache>
@@ -581,7 +661,7 @@
           </c:cat>
           <c:val>
             <c:numRef>
-              <c:f>Sheet1!$D$2:$D$6</c:f>
+              <c:f>Sheet1!$E$2:$E$6</c:f>
               <c:numCache>
                 <c:formatCode>General</c:formatCode>
                 <c:ptCount val="5"/>
@@ -605,11 +685,11 @@
           </c:val>
         </c:ser>
         <c:ser>
-          <c:idx val="3"/>
-          <c:order val="3"/>
+          <c:idx val="4"/>
+          <c:order val="4"/>
           <c:tx>
             <c:strRef>
-              <c:f>Sheet1!$E$1</c:f>
+              <c:f>Sheet1!$F$1</c:f>
               <c:strCache>
                 <c:ptCount val="1"/>
                 <c:pt idx="0">
@@ -649,7 +729,7 @@
           </c:cat>
           <c:val>
             <c:numRef>
-              <c:f>Sheet1!$E$2:$E$6</c:f>
+              <c:f>Sheet1!$F$2:$F$6</c:f>
               <c:numCache>
                 <c:formatCode>General</c:formatCode>
                 <c:ptCount val="5"/>
@@ -933,26 +1013,74 @@
             </c:numRef>
           </c:val>
         </c:ser>
-        <c:dLbls>
-          <c:numFmt formatCode="+0.000;-0.000;0" sourceLinked="0"/>
-          <c:txPr>
-            <a:bodyPr/>
-            <a:lstStyle/>
-            <a:p>
-              <a:pPr>
-                <a:defRPr sz="1100"/>
-              </a:pPr>
-            </a:p>
-          </c:txPr>
-          <c:dLblPos val="outEnd"/>
-          <c:showLegendKey val="0"/>
-          <c:showVal val="1"/>
-          <c:showCatName val="0"/>
-          <c:showSerName val="0"/>
-          <c:showPercent val="0"/>
-          <c:showBubbleSize val="0"/>
-          <c:showLeaderLines val="1"/>
-        </c:dLbls>
+        <c:ser>
+          <c:idx val="2"/>
+          <c:order val="2"/>
+          <c:tx>
+            <c:strRef>
+              <c:f>Sheet1!$D$1</c:f>
+              <c:strCache>
+                <c:ptCount val="1"/>
+                <c:pt idx="0">
+                  <c:v>LightGBM</c:v>
+                </c:pt>
+              </c:strCache>
+            </c:strRef>
+          </c:tx>
+          <c:spPr>
+            <a:solidFill>
+              <a:srgbClr val="1BAF7A"/>
+            </a:solidFill>
+          </c:spPr>
+          <c:invertIfNegative val="0"/>
+          <c:cat>
+            <c:strRef>
+              <c:f>Sheet1!$A$2:$A$6</c:f>
+              <c:strCache>
+                <c:ptCount val="5"/>
+                <c:pt idx="0">
+                  <c:v>Unlock &lt;0.5%</c:v>
+                </c:pt>
+                <c:pt idx="1">
+                  <c:v>Unlock 0.5–2%</c:v>
+                </c:pt>
+                <c:pt idx="2">
+                  <c:v>Unlock 2–5%</c:v>
+                </c:pt>
+                <c:pt idx="3">
+                  <c:v>Unlock &gt;5%</c:v>
+                </c:pt>
+                <c:pt idx="4">
+                  <c:v>Cliff ≤14d</c:v>
+                </c:pt>
+              </c:strCache>
+            </c:strRef>
+          </c:cat>
+          <c:val>
+            <c:numRef>
+              <c:f>Sheet1!$D$2:$D$6</c:f>
+              <c:numCache>
+                <c:formatCode>General</c:formatCode>
+                <c:ptCount val="5"/>
+                <c:pt idx="0">
+                  <c:v>-0.0053</c:v>
+                </c:pt>
+                <c:pt idx="1">
+                  <c:v>-0.0049</c:v>
+                </c:pt>
+                <c:pt idx="2">
+                  <c:v>0.0002</c:v>
+                </c:pt>
+                <c:pt idx="3">
+                  <c:v>0.0001</c:v>
+                </c:pt>
+                <c:pt idx="4">
+                  <c:v>-0.0009</c:v>
+                </c:pt>
+              </c:numCache>
+            </c:numRef>
+          </c:val>
+        </c:ser>
         <c:gapWidth val="70"/>
         <c:axId val="-2068027336"/>
         <c:axId val="-2113994440"/>
@@ -1979,7 +2107,7 @@
           <a:p/>
           <a:p>
             <a:r>
-              <a:t>We re-ran the comparison on the weekly panel, on three alternative volatility targets and on the tokens Tokenomist curates by hand, where schedules should be most accurate. The largest gain anywhere is +0.017, for the Random Forest on the curated subsample, still about a tenth of the fold-to-fold spread. Ridge on the Parkinson target is the only case that wins all five folds, by 0.011.</a:t>
+              <a:t>We re-ran the comparison on the weekly panel, on three alternative volatility targets and on the tokens Tokenomist curates by hand, where schedules should be most accurate. The largest gain anywhere is +0.017, for the Random Forest on the curated subsample, still about a tenth of the fold-to-fold spread. Ridge on the Parkinson target is the only case that wins all five folds, by 0.011. LightGBM shows the same picture, and on the small weekly panel it falls just below the training mean.</a:t>
             </a:r>
           </a:p>
         </p:txBody>
@@ -2733,7 +2861,7 @@
           <a:p/>
           <a:p>
             <a:r>
-              <a:t>Each model sees identical rows, folds and features. KNN tests a local, similarity-based view; Random Forest can find non-linear effects and interactions, for example unlocks mattering only in calm markets; Ridge and Elastic Net are strong linear benchmarks, and Elastic Net can drop features entirely; logistic regression re-asks the question as classifying high-volatility events. Note what tuning chose: very large neighbourhoods, large leaves and strong penalties, all signs of a noisy target.</a:t>
+              <a:t>Each model sees identical rows, folds and features. KNN tests a local, similarity-based view; Random Forest can find non-linear effects and interactions, for example unlocks mattering only in calm markets, and LightGBM boosts small trees on the residuals; Ridge and Elastic Net are strong linear benchmarks, and Elastic Net can drop features entirely; logistic regression re-asks the question as classifying high-volatility events. Note what tuning chose: very large neighbourhoods, large leaves and strong penalties, all signs of a noisy target.</a:t>
             </a:r>
           </a:p>
         </p:txBody>
@@ -5999,7 +6127,7 @@
                 </a:solidFill>
                 <a:latin typeface="Calibri"/>
               </a:rPr>
-              <a:t>Walk-forward evidence from 176 tokens and five machine-learning models</a:t>
+              <a:t>Walk-forward evidence from 176 tokens and six machine-learning models</a:t>
             </a:r>
           </a:p>
         </p:txBody>
@@ -6682,7 +6810,7 @@
                 </a:solidFill>
                 <a:latin typeface="Calibri"/>
               </a:rPr>
-              <a:t>Top 5 features are all controls: trailing 30d, 14d, 7d vol, 30d return, token age. Partial dependence on unlock pressure is flat across BTC regimes.</a:t>
+              <a:t>Top 5 RF features are all controls; partial dependence on unlock pressure is flat. LightGBM: controls take 92% of split gain, emission 4%.</a:t>
             </a:r>
           </a:p>
         </p:txBody>
@@ -8046,7 +8174,7 @@
         </p:nvGraphicFramePr>
         <p:xfrm>
           <a:off x="548640" y="1737360"/>
-          <a:ext cx="9601200" cy="4114800"/>
+          <a:ext cx="9326880" cy="4114800"/>
         </p:xfrm>
         <a:graphic>
           <a:graphicData uri="http://schemas.openxmlformats.org/drawingml/2006/table">
@@ -8055,11 +8183,12 @@
                 <a:tableStyleId>{5C22544A-7EE6-4342-B048-85BDC9FD1C3A}</a:tableStyleId>
               </a:tblPr>
               <a:tblGrid>
-                <a:gridCol w="3291840"/>
-                <a:gridCol w="1463040"/>
-                <a:gridCol w="1737360"/>
-                <a:gridCol w="1463040"/>
-                <a:gridCol w="1645920"/>
+                <a:gridCol w="2926080"/>
+                <a:gridCol w="1097280"/>
+                <a:gridCol w="1554480"/>
+                <a:gridCol w="1280160"/>
+                <a:gridCol w="1097280"/>
+                <a:gridCol w="1371600"/>
               </a:tblGrid>
               <a:tr h="587828">
                 <a:tc>
@@ -8069,7 +8198,7 @@
                     <a:p>
                       <a:pPr algn="l"/>
                       <a:r>
-                        <a:rPr sz="1500" b="1">
+                        <a:rPr sz="1400" b="1">
                           <a:solidFill>
                             <a:srgbClr val="FFFFFF"/>
                           </a:solidFill>
@@ -8092,7 +8221,7 @@
                     <a:p>
                       <a:pPr algn="ctr"/>
                       <a:r>
-                        <a:rPr sz="1500" b="1">
+                        <a:rPr sz="1400" b="1">
                           <a:solidFill>
                             <a:srgbClr val="FFFFFF"/>
                           </a:solidFill>
@@ -8115,7 +8244,7 @@
                     <a:p>
                       <a:pPr algn="ctr"/>
                       <a:r>
-                        <a:rPr sz="1500" b="1">
+                        <a:rPr sz="1400" b="1">
                           <a:solidFill>
                             <a:srgbClr val="FFFFFF"/>
                           </a:solidFill>
@@ -8138,7 +8267,30 @@
                     <a:p>
                       <a:pPr algn="ctr"/>
                       <a:r>
-                        <a:rPr sz="1500" b="1">
+                        <a:rPr sz="1400" b="1">
+                          <a:solidFill>
+                            <a:srgbClr val="FFFFFF"/>
+                          </a:solidFill>
+                          <a:latin typeface="Calibri"/>
+                        </a:rPr>
+                        <a:t>LightGBM</a:t>
+                      </a:r>
+                    </a:p>
+                  </a:txBody>
+                  <a:tcPr anchor="ctr">
+                    <a:solidFill>
+                      <a:srgbClr val="141B2D"/>
+                    </a:solidFill>
+                  </a:tcPr>
+                </a:tc>
+                <a:tc>
+                  <a:txBody>
+                    <a:bodyPr/>
+                    <a:lstStyle/>
+                    <a:p>
+                      <a:pPr algn="ctr"/>
+                      <a:r>
+                        <a:rPr sz="1400" b="1">
                           <a:solidFill>
                             <a:srgbClr val="FFFFFF"/>
                           </a:solidFill>
@@ -8161,7 +8313,7 @@
                     <a:p>
                       <a:pPr algn="ctr"/>
                       <a:r>
-                        <a:rPr sz="1500" b="1">
+                        <a:rPr sz="1400" b="1">
                           <a:solidFill>
                             <a:srgbClr val="FFFFFF"/>
                           </a:solidFill>
@@ -8186,7 +8338,7 @@
                     <a:p>
                       <a:pPr algn="l"/>
                       <a:r>
-                        <a:rPr sz="1500" b="0">
+                        <a:rPr sz="1400" b="0">
                           <a:solidFill>
                             <a:srgbClr val="1F2433"/>
                           </a:solidFill>
@@ -8209,7 +8361,7 @@
                     <a:p>
                       <a:pPr algn="ctr"/>
                       <a:r>
-                        <a:rPr sz="1500" b="0">
+                        <a:rPr sz="1400" b="0">
                           <a:solidFill>
                             <a:srgbClr val="1F2433"/>
                           </a:solidFill>
@@ -8232,7 +8384,7 @@
                     <a:p>
                       <a:pPr algn="ctr"/>
                       <a:r>
-                        <a:rPr sz="1500" b="0">
+                        <a:rPr sz="1400" b="0">
                           <a:solidFill>
                             <a:srgbClr val="1F2433"/>
                           </a:solidFill>
@@ -8255,7 +8407,30 @@
                     <a:p>
                       <a:pPr algn="ctr"/>
                       <a:r>
-                        <a:rPr sz="1500" b="0">
+                        <a:rPr sz="1400" b="0">
+                          <a:solidFill>
+                            <a:srgbClr val="1F2433"/>
+                          </a:solidFill>
+                          <a:latin typeface="Calibri"/>
+                        </a:rPr>
+                        <a:t>+0.005</a:t>
+                      </a:r>
+                    </a:p>
+                  </a:txBody>
+                  <a:tcPr anchor="ctr">
+                    <a:solidFill>
+                      <a:srgbClr val="FFFFFF"/>
+                    </a:solidFill>
+                  </a:tcPr>
+                </a:tc>
+                <a:tc>
+                  <a:txBody>
+                    <a:bodyPr/>
+                    <a:lstStyle/>
+                    <a:p>
+                      <a:pPr algn="ctr"/>
+                      <a:r>
+                        <a:rPr sz="1400" b="0">
                           <a:solidFill>
                             <a:srgbClr val="1F2433"/>
                           </a:solidFill>
@@ -8278,7 +8453,7 @@
                     <a:p>
                       <a:pPr algn="ctr"/>
                       <a:r>
-                        <a:rPr sz="1500" b="0">
+                        <a:rPr sz="1400" b="0">
                           <a:solidFill>
                             <a:srgbClr val="1F2433"/>
                           </a:solidFill>
@@ -8303,7 +8478,7 @@
                     <a:p>
                       <a:pPr algn="l"/>
                       <a:r>
-                        <a:rPr sz="1500" b="0">
+                        <a:rPr sz="1400" b="0">
                           <a:solidFill>
                             <a:srgbClr val="1F2433"/>
                           </a:solidFill>
@@ -8326,7 +8501,7 @@
                     <a:p>
                       <a:pPr algn="ctr"/>
                       <a:r>
-                        <a:rPr sz="1500" b="0">
+                        <a:rPr sz="1400" b="0">
                           <a:solidFill>
                             <a:srgbClr val="1F2433"/>
                           </a:solidFill>
@@ -8349,7 +8524,7 @@
                     <a:p>
                       <a:pPr algn="ctr"/>
                       <a:r>
-                        <a:rPr sz="1500" b="0">
+                        <a:rPr sz="1400" b="0">
                           <a:solidFill>
                             <a:srgbClr val="1F2433"/>
                           </a:solidFill>
@@ -8372,7 +8547,30 @@
                     <a:p>
                       <a:pPr algn="ctr"/>
                       <a:r>
-                        <a:rPr sz="1500" b="0">
+                        <a:rPr sz="1400" b="0">
+                          <a:solidFill>
+                            <a:srgbClr val="1F2433"/>
+                          </a:solidFill>
+                          <a:latin typeface="Calibri"/>
+                        </a:rPr>
+                        <a:t>+0.004</a:t>
+                      </a:r>
+                    </a:p>
+                  </a:txBody>
+                  <a:tcPr anchor="ctr">
+                    <a:solidFill>
+                      <a:srgbClr val="F2F4F7"/>
+                    </a:solidFill>
+                  </a:tcPr>
+                </a:tc>
+                <a:tc>
+                  <a:txBody>
+                    <a:bodyPr/>
+                    <a:lstStyle/>
+                    <a:p>
+                      <a:pPr algn="ctr"/>
+                      <a:r>
+                        <a:rPr sz="1400" b="0">
                           <a:solidFill>
                             <a:srgbClr val="1F2433"/>
                           </a:solidFill>
@@ -8395,7 +8593,7 @@
                     <a:p>
                       <a:pPr algn="ctr"/>
                       <a:r>
-                        <a:rPr sz="1500" b="0">
+                        <a:rPr sz="1400" b="0">
                           <a:solidFill>
                             <a:srgbClr val="1F2433"/>
                           </a:solidFill>
@@ -8420,7 +8618,7 @@
                     <a:p>
                       <a:pPr algn="l"/>
                       <a:r>
-                        <a:rPr sz="1500" b="0">
+                        <a:rPr sz="1400" b="0">
                           <a:solidFill>
                             <a:srgbClr val="1F2433"/>
                           </a:solidFill>
@@ -8443,7 +8641,7 @@
                     <a:p>
                       <a:pPr algn="ctr"/>
                       <a:r>
-                        <a:rPr sz="1500" b="0">
+                        <a:rPr sz="1400" b="0">
                           <a:solidFill>
                             <a:srgbClr val="1F2433"/>
                           </a:solidFill>
@@ -8466,7 +8664,7 @@
                     <a:p>
                       <a:pPr algn="ctr"/>
                       <a:r>
-                        <a:rPr sz="1500" b="0">
+                        <a:rPr sz="1400" b="0">
                           <a:solidFill>
                             <a:srgbClr val="1F2433"/>
                           </a:solidFill>
@@ -8489,7 +8687,30 @@
                     <a:p>
                       <a:pPr algn="ctr"/>
                       <a:r>
-                        <a:rPr sz="1500" b="0">
+                        <a:rPr sz="1400" b="0">
+                          <a:solidFill>
+                            <a:srgbClr val="1F2433"/>
+                          </a:solidFill>
+                          <a:latin typeface="Calibri"/>
+                        </a:rPr>
+                        <a:t>+0.013</a:t>
+                      </a:r>
+                    </a:p>
+                  </a:txBody>
+                  <a:tcPr anchor="ctr">
+                    <a:solidFill>
+                      <a:srgbClr val="FFFFFF"/>
+                    </a:solidFill>
+                  </a:tcPr>
+                </a:tc>
+                <a:tc>
+                  <a:txBody>
+                    <a:bodyPr/>
+                    <a:lstStyle/>
+                    <a:p>
+                      <a:pPr algn="ctr"/>
+                      <a:r>
+                        <a:rPr sz="1400" b="0">
                           <a:solidFill>
                             <a:srgbClr val="1F2433"/>
                           </a:solidFill>
@@ -8512,7 +8733,7 @@
                     <a:p>
                       <a:pPr algn="ctr"/>
                       <a:r>
-                        <a:rPr sz="1500" b="0">
+                        <a:rPr sz="1400" b="0">
                           <a:solidFill>
                             <a:srgbClr val="1F2433"/>
                           </a:solidFill>
@@ -8537,7 +8758,7 @@
                     <a:p>
                       <a:pPr algn="l"/>
                       <a:r>
-                        <a:rPr sz="1500" b="0">
+                        <a:rPr sz="1400" b="0">
                           <a:solidFill>
                             <a:srgbClr val="1F2433"/>
                           </a:solidFill>
@@ -8560,7 +8781,7 @@
                     <a:p>
                       <a:pPr algn="ctr"/>
                       <a:r>
-                        <a:rPr sz="1500" b="0">
+                        <a:rPr sz="1400" b="0">
                           <a:solidFill>
                             <a:srgbClr val="1F2433"/>
                           </a:solidFill>
@@ -8583,7 +8804,7 @@
                     <a:p>
                       <a:pPr algn="ctr"/>
                       <a:r>
-                        <a:rPr sz="1500" b="0">
+                        <a:rPr sz="1400" b="0">
                           <a:solidFill>
                             <a:srgbClr val="1F2433"/>
                           </a:solidFill>
@@ -8606,7 +8827,30 @@
                     <a:p>
                       <a:pPr algn="ctr"/>
                       <a:r>
-                        <a:rPr sz="1500" b="0">
+                        <a:rPr sz="1400" b="0">
+                          <a:solidFill>
+                            <a:srgbClr val="1F2433"/>
+                          </a:solidFill>
+                          <a:latin typeface="Calibri"/>
+                        </a:rPr>
+                        <a:t>+0.002</a:t>
+                      </a:r>
+                    </a:p>
+                  </a:txBody>
+                  <a:tcPr anchor="ctr">
+                    <a:solidFill>
+                      <a:srgbClr val="F2F4F7"/>
+                    </a:solidFill>
+                  </a:tcPr>
+                </a:tc>
+                <a:tc>
+                  <a:txBody>
+                    <a:bodyPr/>
+                    <a:lstStyle/>
+                    <a:p>
+                      <a:pPr algn="ctr"/>
+                      <a:r>
+                        <a:rPr sz="1400" b="0">
                           <a:solidFill>
                             <a:srgbClr val="1F2433"/>
                           </a:solidFill>
@@ -8629,7 +8873,7 @@
                     <a:p>
                       <a:pPr algn="ctr"/>
                       <a:r>
-                        <a:rPr sz="1500" b="0">
+                        <a:rPr sz="1400" b="0">
                           <a:solidFill>
                             <a:srgbClr val="1F2433"/>
                           </a:solidFill>
@@ -8654,7 +8898,7 @@
                     <a:p>
                       <a:pPr algn="l"/>
                       <a:r>
-                        <a:rPr sz="1500" b="0">
+                        <a:rPr sz="1400" b="0">
                           <a:solidFill>
                             <a:srgbClr val="1F2433"/>
                           </a:solidFill>
@@ -8677,7 +8921,7 @@
                     <a:p>
                       <a:pPr algn="ctr"/>
                       <a:r>
-                        <a:rPr sz="1500" b="0">
+                        <a:rPr sz="1400" b="0">
                           <a:solidFill>
                             <a:srgbClr val="1F2433"/>
                           </a:solidFill>
@@ -8700,7 +8944,7 @@
                     <a:p>
                       <a:pPr algn="ctr"/>
                       <a:r>
-                        <a:rPr sz="1500" b="0">
+                        <a:rPr sz="1400" b="0">
                           <a:solidFill>
                             <a:srgbClr val="1F2433"/>
                           </a:solidFill>
@@ -8723,7 +8967,30 @@
                     <a:p>
                       <a:pPr algn="ctr"/>
                       <a:r>
-                        <a:rPr sz="1500" b="0">
+                        <a:rPr sz="1400" b="0">
+                          <a:solidFill>
+                            <a:srgbClr val="1F2433"/>
+                          </a:solidFill>
+                          <a:latin typeface="Calibri"/>
+                        </a:rPr>
+                        <a:t>+0.017</a:t>
+                      </a:r>
+                    </a:p>
+                  </a:txBody>
+                  <a:tcPr anchor="ctr">
+                    <a:solidFill>
+                      <a:srgbClr val="FFFFFF"/>
+                    </a:solidFill>
+                  </a:tcPr>
+                </a:tc>
+                <a:tc>
+                  <a:txBody>
+                    <a:bodyPr/>
+                    <a:lstStyle/>
+                    <a:p>
+                      <a:pPr algn="ctr"/>
+                      <a:r>
+                        <a:rPr sz="1400" b="0">
                           <a:solidFill>
                             <a:srgbClr val="1F2433"/>
                           </a:solidFill>
@@ -8746,7 +9013,7 @@
                     <a:p>
                       <a:pPr algn="ctr"/>
                       <a:r>
-                        <a:rPr sz="1500" b="0">
+                        <a:rPr sz="1400" b="0">
                           <a:solidFill>
                             <a:srgbClr val="1F2433"/>
                           </a:solidFill>
@@ -8771,7 +9038,7 @@
                     <a:p>
                       <a:pPr algn="l"/>
                       <a:r>
-                        <a:rPr sz="1500" b="0">
+                        <a:rPr sz="1400" b="0">
                           <a:solidFill>
                             <a:srgbClr val="1F2433"/>
                           </a:solidFill>
@@ -8794,7 +9061,7 @@
                     <a:p>
                       <a:pPr algn="ctr"/>
                       <a:r>
-                        <a:rPr sz="1500" b="0">
+                        <a:rPr sz="1400" b="0">
                           <a:solidFill>
                             <a:srgbClr val="1F2433"/>
                           </a:solidFill>
@@ -8817,7 +9084,7 @@
                     <a:p>
                       <a:pPr algn="ctr"/>
                       <a:r>
-                        <a:rPr sz="1500" b="0">
+                        <a:rPr sz="1400" b="0">
                           <a:solidFill>
                             <a:srgbClr val="1F2433"/>
                           </a:solidFill>
@@ -8840,7 +9107,30 @@
                     <a:p>
                       <a:pPr algn="ctr"/>
                       <a:r>
-                        <a:rPr sz="1500" b="0">
+                        <a:rPr sz="1400" b="0">
+                          <a:solidFill>
+                            <a:srgbClr val="1F2433"/>
+                          </a:solidFill>
+                          <a:latin typeface="Calibri"/>
+                        </a:rPr>
+                        <a:t>+0.009</a:t>
+                      </a:r>
+                    </a:p>
+                  </a:txBody>
+                  <a:tcPr anchor="ctr">
+                    <a:solidFill>
+                      <a:srgbClr val="F2F4F7"/>
+                    </a:solidFill>
+                  </a:tcPr>
+                </a:tc>
+                <a:tc>
+                  <a:txBody>
+                    <a:bodyPr/>
+                    <a:lstStyle/>
+                    <a:p>
+                      <a:pPr algn="ctr"/>
+                      <a:r>
+                        <a:rPr sz="1400" b="0">
                           <a:solidFill>
                             <a:srgbClr val="1F2433"/>
                           </a:solidFill>
@@ -8863,7 +9153,7 @@
                     <a:p>
                       <a:pPr algn="ctr"/>
                       <a:r>
-                        <a:rPr sz="1500" b="0">
+                        <a:rPr sz="1400" b="0">
                           <a:solidFill>
                             <a:srgbClr val="1F2433"/>
                           </a:solidFill>
@@ -8984,7 +9274,7 @@
                 </a:solidFill>
                 <a:latin typeface="Calibri"/>
               </a:rPr>
-              <a:t>largest gain anywhere (RF, curated tokens)</a:t>
+              <a:t>largest gain anywhere (RF curated; LightGBM 30d vol)</a:t>
             </a:r>
           </a:p>
         </p:txBody>
@@ -10170,7 +10460,7 @@
                 </a:solidFill>
                 <a:latin typeface="Cambria"/>
               </a:rPr>
-              <a:t>Five model families agree</a:t>
+              <a:t>Six models agree</a:t>
             </a:r>
           </a:p>
         </p:txBody>
@@ -16008,7 +16298,7 @@
                 </a:solidFill>
                 <a:latin typeface="Cambria"/>
               </a:rPr>
-              <a:t>Five models, one shared harness</a:t>
+              <a:t>Six models, one shared harness</a:t>
             </a:r>
           </a:p>
         </p:txBody>
@@ -16092,7 +16382,7 @@
         <p:spPr>
           <a:xfrm>
             <a:off x="548640" y="1783080"/>
-            <a:ext cx="2084831" cy="4206240"/>
+            <a:ext cx="1719072" cy="4206240"/>
           </a:xfrm>
           <a:prstGeom prst="roundRect">
             <a:avLst>
@@ -16137,8 +16427,8 @@
         </p:nvSpPr>
         <p:spPr>
           <a:xfrm>
-            <a:off x="749808" y="2011680"/>
-            <a:ext cx="1737360" cy="274320"/>
+            <a:off x="722376" y="2011680"/>
+            <a:ext cx="1371600" cy="274320"/>
           </a:xfrm>
           <a:prstGeom prst="rect">
             <a:avLst/>
@@ -16172,8 +16462,8 @@
         </p:nvSpPr>
         <p:spPr>
           <a:xfrm>
-            <a:off x="749808" y="2331720"/>
-            <a:ext cx="1737360" cy="822960"/>
+            <a:off x="722376" y="2331720"/>
+            <a:ext cx="1371600" cy="822960"/>
           </a:xfrm>
           <a:prstGeom prst="rect">
             <a:avLst/>
@@ -16188,7 +16478,7 @@
           <a:p>
             <a:pPr algn="l"/>
             <a:r>
-              <a:rPr sz="2200" b="1" i="0">
+              <a:rPr sz="2000" b="1" i="0">
                 <a:solidFill>
                   <a:srgbClr val="1F2433"/>
                 </a:solidFill>
@@ -16207,8 +16497,8 @@
         </p:nvSpPr>
         <p:spPr>
           <a:xfrm>
-            <a:off x="749808" y="3200400"/>
-            <a:ext cx="1737360" cy="1280160"/>
+            <a:off x="722376" y="3200400"/>
+            <a:ext cx="1371600" cy="1280160"/>
           </a:xfrm>
           <a:prstGeom prst="rect">
             <a:avLst/>
@@ -16223,7 +16513,7 @@
           <a:p>
             <a:pPr algn="l"/>
             <a:r>
-              <a:rPr sz="1500" b="0" i="0">
+              <a:rPr sz="1400" b="0" i="0">
                 <a:solidFill>
                   <a:srgbClr val="6B7280"/>
                 </a:solidFill>
@@ -16242,8 +16532,8 @@
         </p:nvSpPr>
         <p:spPr>
           <a:xfrm>
-            <a:off x="749808" y="4572000"/>
-            <a:ext cx="1737360" cy="1188720"/>
+            <a:off x="722376" y="4572000"/>
+            <a:ext cx="1371600" cy="1188720"/>
           </a:xfrm>
           <a:prstGeom prst="rect">
             <a:avLst/>
@@ -16258,7 +16548,7 @@
           <a:p>
             <a:pPr algn="l"/>
             <a:r>
-              <a:rPr sz="1500" b="1" i="0">
+              <a:rPr sz="1400" b="1" i="0">
                 <a:solidFill>
                   <a:srgbClr val="1F2433"/>
                 </a:solidFill>
@@ -16277,8 +16567,8 @@
         </p:nvSpPr>
         <p:spPr>
           <a:xfrm>
-            <a:off x="2798064" y="1783080"/>
-            <a:ext cx="2084831" cy="4206240"/>
+            <a:off x="2423160" y="1783080"/>
+            <a:ext cx="1719072" cy="4206240"/>
           </a:xfrm>
           <a:prstGeom prst="roundRect">
             <a:avLst>
@@ -16323,8 +16613,8 @@
         </p:nvSpPr>
         <p:spPr>
           <a:xfrm>
-            <a:off x="2999232" y="2011680"/>
-            <a:ext cx="1737360" cy="274320"/>
+            <a:off x="2596896" y="2011680"/>
+            <a:ext cx="1371600" cy="274320"/>
           </a:xfrm>
           <a:prstGeom prst="rect">
             <a:avLst/>
@@ -16358,8 +16648,8 @@
         </p:nvSpPr>
         <p:spPr>
           <a:xfrm>
-            <a:off x="2999232" y="2331720"/>
-            <a:ext cx="1737360" cy="822960"/>
+            <a:off x="2596896" y="2331720"/>
+            <a:ext cx="1371600" cy="822960"/>
           </a:xfrm>
           <a:prstGeom prst="rect">
             <a:avLst/>
@@ -16374,7 +16664,7 @@
           <a:p>
             <a:pPr algn="l"/>
             <a:r>
-              <a:rPr sz="2200" b="1" i="0">
+              <a:rPr sz="2000" b="1" i="0">
                 <a:solidFill>
                   <a:srgbClr val="1F2433"/>
                 </a:solidFill>
@@ -16393,8 +16683,8 @@
         </p:nvSpPr>
         <p:spPr>
           <a:xfrm>
-            <a:off x="2999232" y="3200400"/>
-            <a:ext cx="1737360" cy="1280160"/>
+            <a:off x="2596896" y="3200400"/>
+            <a:ext cx="1371600" cy="1280160"/>
           </a:xfrm>
           <a:prstGeom prst="rect">
             <a:avLst/>
@@ -16409,7 +16699,7 @@
           <a:p>
             <a:pPr algn="l"/>
             <a:r>
-              <a:rPr sz="1500" b="0" i="0">
+              <a:rPr sz="1400" b="0" i="0">
                 <a:solidFill>
                   <a:srgbClr val="6B7280"/>
                 </a:solidFill>
@@ -16428,8 +16718,8 @@
         </p:nvSpPr>
         <p:spPr>
           <a:xfrm>
-            <a:off x="2999232" y="4572000"/>
-            <a:ext cx="1737360" cy="1188720"/>
+            <a:off x="2596896" y="4572000"/>
+            <a:ext cx="1371600" cy="1188720"/>
           </a:xfrm>
           <a:prstGeom prst="rect">
             <a:avLst/>
@@ -16444,7 +16734,7 @@
           <a:p>
             <a:pPr algn="l"/>
             <a:r>
-              <a:rPr sz="1500" b="1" i="0">
+              <a:rPr sz="1400" b="1" i="0">
                 <a:solidFill>
                   <a:srgbClr val="1F2433"/>
                 </a:solidFill>
@@ -16457,14 +16747,14 @@
       </p:sp>
       <p:sp>
         <p:nvSpPr>
-          <p:cNvPr id="16" name="Model card Ridge"/>
+          <p:cNvPr id="16" name="Model card LightGBM"/>
           <p:cNvSpPr/>
           <p:nvPr/>
         </p:nvSpPr>
         <p:spPr>
           <a:xfrm>
-            <a:off x="5047488" y="1783080"/>
-            <a:ext cx="2084831" cy="4206240"/>
+            <a:off x="4297679" y="1783080"/>
+            <a:ext cx="1719072" cy="4206240"/>
           </a:xfrm>
           <a:prstGeom prst="roundRect">
             <a:avLst>
@@ -16509,8 +16799,8 @@
         </p:nvSpPr>
         <p:spPr>
           <a:xfrm>
-            <a:off x="5248655" y="2011680"/>
-            <a:ext cx="1737360" cy="274320"/>
+            <a:off x="4471416" y="2011680"/>
+            <a:ext cx="1371600" cy="274320"/>
           </a:xfrm>
           <a:prstGeom prst="rect">
             <a:avLst/>
@@ -16544,8 +16834,8 @@
         </p:nvSpPr>
         <p:spPr>
           <a:xfrm>
-            <a:off x="5248655" y="2331720"/>
-            <a:ext cx="1737360" cy="822960"/>
+            <a:off x="4471416" y="2331720"/>
+            <a:ext cx="1371600" cy="822960"/>
           </a:xfrm>
           <a:prstGeom prst="rect">
             <a:avLst/>
@@ -16560,13 +16850,13 @@
           <a:p>
             <a:pPr algn="l"/>
             <a:r>
-              <a:rPr sz="2200" b="1" i="0">
+              <a:rPr sz="2000" b="1" i="0">
                 <a:solidFill>
                   <a:srgbClr val="1F2433"/>
                 </a:solidFill>
                 <a:latin typeface="Cambria"/>
               </a:rPr>
-              <a:t>Ridge</a:t>
+              <a:t>LightGBM</a:t>
             </a:r>
           </a:p>
         </p:txBody>
@@ -16579,8 +16869,8 @@
         </p:nvSpPr>
         <p:spPr>
           <a:xfrm>
-            <a:off x="5248655" y="3200400"/>
-            <a:ext cx="1737360" cy="1280160"/>
+            <a:off x="4471416" y="3200400"/>
+            <a:ext cx="1371600" cy="1280160"/>
           </a:xfrm>
           <a:prstGeom prst="rect">
             <a:avLst/>
@@ -16595,13 +16885,13 @@
           <a:p>
             <a:pPr algn="l"/>
             <a:r>
-              <a:rPr sz="1500" b="0" i="0">
+              <a:rPr sz="1400" b="0" i="0">
                 <a:solidFill>
                   <a:srgbClr val="6B7280"/>
                 </a:solidFill>
                 <a:latin typeface="Calibri"/>
               </a:rPr>
-              <a:t>L2 penalty; α from 0.1 to 10⁷</a:t>
+              <a:t>Boosted trees; 200 or 500 trees, 7 or 15 leaves</a:t>
             </a:r>
           </a:p>
         </p:txBody>
@@ -16614,8 +16904,8 @@
         </p:nvSpPr>
         <p:spPr>
           <a:xfrm>
-            <a:off x="5248655" y="4572000"/>
-            <a:ext cx="1737360" cy="1188720"/>
+            <a:off x="4471416" y="4572000"/>
+            <a:ext cx="1371600" cy="1188720"/>
           </a:xfrm>
           <a:prstGeom prst="rect">
             <a:avLst/>
@@ -16630,27 +16920,27 @@
           <a:p>
             <a:pPr algn="l"/>
             <a:r>
-              <a:rPr sz="1500" b="1" i="0">
+              <a:rPr sz="1400" b="1" i="0">
                 <a:solidFill>
                   <a:srgbClr val="1F2433"/>
                 </a:solidFill>
                 <a:latin typeface="Calibri"/>
               </a:rPr>
-              <a:t>Tuned: α = 10⁴–10⁷</a:t>
-            </a:r>
-          </a:p>
-        </p:txBody>
-      </p:sp>
-      <p:sp>
-        <p:nvSpPr>
-          <p:cNvPr id="21" name="Model card Elastic Net"/>
+              <a:t>Tuned: slowest, lr 0.02</a:t>
+            </a:r>
+          </a:p>
+        </p:txBody>
+      </p:sp>
+      <p:sp>
+        <p:nvSpPr>
+          <p:cNvPr id="21" name="Model card Ridge"/>
           <p:cNvSpPr/>
           <p:nvPr/>
         </p:nvSpPr>
         <p:spPr>
           <a:xfrm>
-            <a:off x="7296912" y="1783080"/>
-            <a:ext cx="2084831" cy="4206240"/>
+            <a:off x="6172199" y="1783080"/>
+            <a:ext cx="1719072" cy="4206240"/>
           </a:xfrm>
           <a:prstGeom prst="roundRect">
             <a:avLst>
@@ -16695,8 +16985,8 @@
         </p:nvSpPr>
         <p:spPr>
           <a:xfrm>
-            <a:off x="7498079" y="2011680"/>
-            <a:ext cx="1737360" cy="274320"/>
+            <a:off x="6345936" y="2011680"/>
+            <a:ext cx="1371600" cy="274320"/>
           </a:xfrm>
           <a:prstGeom prst="rect">
             <a:avLst/>
@@ -16730,8 +17020,8 @@
         </p:nvSpPr>
         <p:spPr>
           <a:xfrm>
-            <a:off x="7498079" y="2331720"/>
-            <a:ext cx="1737360" cy="822960"/>
+            <a:off x="6345936" y="2331720"/>
+            <a:ext cx="1371600" cy="822960"/>
           </a:xfrm>
           <a:prstGeom prst="rect">
             <a:avLst/>
@@ -16746,13 +17036,13 @@
           <a:p>
             <a:pPr algn="l"/>
             <a:r>
-              <a:rPr sz="2200" b="1" i="0">
+              <a:rPr sz="2000" b="1" i="0">
                 <a:solidFill>
                   <a:srgbClr val="1F2433"/>
                 </a:solidFill>
                 <a:latin typeface="Cambria"/>
               </a:rPr>
-              <a:t>Elastic Net</a:t>
+              <a:t>Ridge</a:t>
             </a:r>
           </a:p>
         </p:txBody>
@@ -16765,8 +17055,8 @@
         </p:nvSpPr>
         <p:spPr>
           <a:xfrm>
-            <a:off x="7498079" y="3200400"/>
-            <a:ext cx="1737360" cy="1280160"/>
+            <a:off x="6345936" y="3200400"/>
+            <a:ext cx="1371600" cy="1280160"/>
           </a:xfrm>
           <a:prstGeom prst="rect">
             <a:avLst/>
@@ -16781,13 +17071,13 @@
           <a:p>
             <a:pPr algn="l"/>
             <a:r>
-              <a:rPr sz="1500" b="0" i="0">
+              <a:rPr sz="1400" b="0" i="0">
                 <a:solidFill>
                   <a:srgbClr val="6B7280"/>
                 </a:solidFill>
                 <a:latin typeface="Calibri"/>
               </a:rPr>
-              <a:t>L1 + L2, α × l1_ratio grid</a:t>
+              <a:t>L2 penalty; α from 0.1 to 10⁷</a:t>
             </a:r>
           </a:p>
         </p:txBody>
@@ -16800,8 +17090,8 @@
         </p:nvSpPr>
         <p:spPr>
           <a:xfrm>
-            <a:off x="7498079" y="4572000"/>
-            <a:ext cx="1737360" cy="1188720"/>
+            <a:off x="6345936" y="4572000"/>
+            <a:ext cx="1371600" cy="1188720"/>
           </a:xfrm>
           <a:prstGeom prst="rect">
             <a:avLst/>
@@ -16816,27 +17106,27 @@
           <a:p>
             <a:pPr algn="l"/>
             <a:r>
-              <a:rPr sz="1500" b="1" i="0">
+              <a:rPr sz="1400" b="1" i="0">
                 <a:solidFill>
                   <a:srgbClr val="1F2433"/>
                 </a:solidFill>
                 <a:latin typeface="Calibri"/>
               </a:rPr>
-              <a:t>Tuned: all-zero in 2 of 5 folds</a:t>
-            </a:r>
-          </a:p>
-        </p:txBody>
-      </p:sp>
-      <p:sp>
-        <p:nvSpPr>
-          <p:cNvPr id="26" name="Model card Logistic"/>
+              <a:t>Tuned: α = 10⁴–10⁷</a:t>
+            </a:r>
+          </a:p>
+        </p:txBody>
+      </p:sp>
+      <p:sp>
+        <p:nvSpPr>
+          <p:cNvPr id="26" name="Model card Elastic Net"/>
           <p:cNvSpPr/>
           <p:nvPr/>
         </p:nvSpPr>
         <p:spPr>
           <a:xfrm>
-            <a:off x="9546336" y="1783080"/>
-            <a:ext cx="2084831" cy="4206240"/>
+            <a:off x="8046719" y="1783080"/>
+            <a:ext cx="1719072" cy="4206240"/>
           </a:xfrm>
           <a:prstGeom prst="roundRect">
             <a:avLst>
@@ -16844,7 +17134,7 @@
             </a:avLst>
           </a:prstGeom>
           <a:solidFill>
-            <a:srgbClr val="141B2D"/>
+            <a:srgbClr val="F2F4F7"/>
           </a:solidFill>
           <a:ln>
             <a:noFill/>
@@ -16881,8 +17171,8 @@
         </p:nvSpPr>
         <p:spPr>
           <a:xfrm>
-            <a:off x="9747504" y="2011680"/>
-            <a:ext cx="1737360" cy="274320"/>
+            <a:off x="8220455" y="2011680"/>
+            <a:ext cx="1371600" cy="274320"/>
           </a:xfrm>
           <a:prstGeom prst="rect">
             <a:avLst/>
@@ -16903,6 +17193,192 @@
                 </a:solidFill>
                 <a:latin typeface="Calibri"/>
               </a:rPr>
+              <a:t>REGRESSION</a:t>
+            </a:r>
+          </a:p>
+        </p:txBody>
+      </p:sp>
+      <p:sp>
+        <p:nvSpPr>
+          <p:cNvPr id="28" name="TextBox 27"/>
+          <p:cNvSpPr txBox="1"/>
+          <p:nvPr/>
+        </p:nvSpPr>
+        <p:spPr>
+          <a:xfrm>
+            <a:off x="8220455" y="2331720"/>
+            <a:ext cx="1371600" cy="822960"/>
+          </a:xfrm>
+          <a:prstGeom prst="rect">
+            <a:avLst/>
+          </a:prstGeom>
+          <a:noFill/>
+        </p:spPr>
+        <p:txBody>
+          <a:bodyPr wrap="square" lIns="0" rIns="0" tIns="0" bIns="0" anchor="t">
+            <a:spAutoFit/>
+          </a:bodyPr>
+          <a:lstStyle/>
+          <a:p>
+            <a:pPr algn="l"/>
+            <a:r>
+              <a:rPr sz="2000" b="1" i="0">
+                <a:solidFill>
+                  <a:srgbClr val="1F2433"/>
+                </a:solidFill>
+                <a:latin typeface="Cambria"/>
+              </a:rPr>
+              <a:t>Elastic Net</a:t>
+            </a:r>
+          </a:p>
+        </p:txBody>
+      </p:sp>
+      <p:sp>
+        <p:nvSpPr>
+          <p:cNvPr id="29" name="TextBox 28"/>
+          <p:cNvSpPr txBox="1"/>
+          <p:nvPr/>
+        </p:nvSpPr>
+        <p:spPr>
+          <a:xfrm>
+            <a:off x="8220455" y="3200400"/>
+            <a:ext cx="1371600" cy="1280160"/>
+          </a:xfrm>
+          <a:prstGeom prst="rect">
+            <a:avLst/>
+          </a:prstGeom>
+          <a:noFill/>
+        </p:spPr>
+        <p:txBody>
+          <a:bodyPr wrap="square" lIns="0" rIns="0" tIns="0" bIns="0" anchor="t">
+            <a:spAutoFit/>
+          </a:bodyPr>
+          <a:lstStyle/>
+          <a:p>
+            <a:pPr algn="l"/>
+            <a:r>
+              <a:rPr sz="1400" b="0" i="0">
+                <a:solidFill>
+                  <a:srgbClr val="6B7280"/>
+                </a:solidFill>
+                <a:latin typeface="Calibri"/>
+              </a:rPr>
+              <a:t>L1 + L2, α × l1_ratio grid</a:t>
+            </a:r>
+          </a:p>
+        </p:txBody>
+      </p:sp>
+      <p:sp>
+        <p:nvSpPr>
+          <p:cNvPr id="30" name="TextBox 29"/>
+          <p:cNvSpPr txBox="1"/>
+          <p:nvPr/>
+        </p:nvSpPr>
+        <p:spPr>
+          <a:xfrm>
+            <a:off x="8220455" y="4572000"/>
+            <a:ext cx="1371600" cy="1188720"/>
+          </a:xfrm>
+          <a:prstGeom prst="rect">
+            <a:avLst/>
+          </a:prstGeom>
+          <a:noFill/>
+        </p:spPr>
+        <p:txBody>
+          <a:bodyPr wrap="square" lIns="0" rIns="0" tIns="0" bIns="0" anchor="t">
+            <a:spAutoFit/>
+          </a:bodyPr>
+          <a:lstStyle/>
+          <a:p>
+            <a:pPr algn="l"/>
+            <a:r>
+              <a:rPr sz="1400" b="1" i="0">
+                <a:solidFill>
+                  <a:srgbClr val="1F2433"/>
+                </a:solidFill>
+                <a:latin typeface="Calibri"/>
+              </a:rPr>
+              <a:t>Tuned: all-zero in 2 of 5 folds</a:t>
+            </a:r>
+          </a:p>
+        </p:txBody>
+      </p:sp>
+      <p:sp>
+        <p:nvSpPr>
+          <p:cNvPr id="31" name="Model card Logistic"/>
+          <p:cNvSpPr/>
+          <p:nvPr/>
+        </p:nvSpPr>
+        <p:spPr>
+          <a:xfrm>
+            <a:off x="9921240" y="1783080"/>
+            <a:ext cx="1719072" cy="4206240"/>
+          </a:xfrm>
+          <a:prstGeom prst="roundRect">
+            <a:avLst>
+              <a:gd name="adj" fmla="val 8000"/>
+            </a:avLst>
+          </a:prstGeom>
+          <a:solidFill>
+            <a:srgbClr val="141B2D"/>
+          </a:solidFill>
+          <a:ln>
+            <a:noFill/>
+          </a:ln>
+          <a:effectLst/>
+        </p:spPr>
+        <p:style>
+          <a:lnRef idx="1">
+            <a:schemeClr val="accent1"/>
+          </a:lnRef>
+          <a:fillRef idx="3">
+            <a:schemeClr val="accent1"/>
+          </a:fillRef>
+          <a:effectRef idx="2">
+            <a:schemeClr val="accent1"/>
+          </a:effectRef>
+          <a:fontRef idx="minor">
+            <a:schemeClr val="lt1"/>
+          </a:fontRef>
+        </p:style>
+        <p:txBody>
+          <a:bodyPr rtlCol="0" anchor="ctr"/>
+          <a:lstStyle/>
+          <a:p>
+            <a:pPr algn="ctr"/>
+          </a:p>
+        </p:txBody>
+      </p:sp>
+      <p:sp>
+        <p:nvSpPr>
+          <p:cNvPr id="32" name="TextBox 31"/>
+          <p:cNvSpPr txBox="1"/>
+          <p:nvPr/>
+        </p:nvSpPr>
+        <p:spPr>
+          <a:xfrm>
+            <a:off x="10094976" y="2011680"/>
+            <a:ext cx="1371600" cy="274320"/>
+          </a:xfrm>
+          <a:prstGeom prst="rect">
+            <a:avLst/>
+          </a:prstGeom>
+          <a:noFill/>
+        </p:spPr>
+        <p:txBody>
+          <a:bodyPr wrap="square" lIns="0" rIns="0" tIns="0" bIns="0" anchor="t">
+            <a:spAutoFit/>
+          </a:bodyPr>
+          <a:lstStyle/>
+          <a:p>
+            <a:pPr algn="l"/>
+            <a:r>
+              <a:rPr sz="1100" b="1" i="0">
+                <a:solidFill>
+                  <a:srgbClr val="EB6A35"/>
+                </a:solidFill>
+                <a:latin typeface="Calibri"/>
+              </a:rPr>
               <a:t>CLASSIFICATION</a:t>
             </a:r>
           </a:p>
@@ -16910,14 +17386,14 @@
       </p:sp>
       <p:sp>
         <p:nvSpPr>
-          <p:cNvPr id="28" name="TextBox 27"/>
-          <p:cNvSpPr txBox="1"/>
-          <p:nvPr/>
-        </p:nvSpPr>
-        <p:spPr>
-          <a:xfrm>
-            <a:off x="9747504" y="2331720"/>
-            <a:ext cx="1737360" cy="822960"/>
+          <p:cNvPr id="33" name="TextBox 32"/>
+          <p:cNvSpPr txBox="1"/>
+          <p:nvPr/>
+        </p:nvSpPr>
+        <p:spPr>
+          <a:xfrm>
+            <a:off x="10094976" y="2331720"/>
+            <a:ext cx="1371600" cy="822960"/>
           </a:xfrm>
           <a:prstGeom prst="rect">
             <a:avLst/>
@@ -16932,7 +17408,7 @@
           <a:p>
             <a:pPr algn="l"/>
             <a:r>
-              <a:rPr sz="2200" b="1" i="0">
+              <a:rPr sz="2000" b="1" i="0">
                 <a:solidFill>
                   <a:srgbClr val="FFFFFF"/>
                 </a:solidFill>
@@ -16945,14 +17421,14 @@
       </p:sp>
       <p:sp>
         <p:nvSpPr>
-          <p:cNvPr id="29" name="TextBox 28"/>
-          <p:cNvSpPr txBox="1"/>
-          <p:nvPr/>
-        </p:nvSpPr>
-        <p:spPr>
-          <a:xfrm>
-            <a:off x="9747504" y="3200400"/>
-            <a:ext cx="1737360" cy="1280160"/>
+          <p:cNvPr id="34" name="TextBox 33"/>
+          <p:cNvSpPr txBox="1"/>
+          <p:nvPr/>
+        </p:nvSpPr>
+        <p:spPr>
+          <a:xfrm>
+            <a:off x="10094976" y="3200400"/>
+            <a:ext cx="1371600" cy="1280160"/>
           </a:xfrm>
           <a:prstGeom prst="rect">
             <a:avLst/>
@@ -16967,7 +17443,7 @@
           <a:p>
             <a:pPr algn="l"/>
             <a:r>
-              <a:rPr sz="1500" b="0" i="0">
+              <a:rPr sz="1400" b="0" i="0">
                 <a:solidFill>
                   <a:srgbClr val="C9D3E6"/>
                 </a:solidFill>
@@ -16980,14 +17456,14 @@
       </p:sp>
       <p:sp>
         <p:nvSpPr>
-          <p:cNvPr id="30" name="TextBox 29"/>
-          <p:cNvSpPr txBox="1"/>
-          <p:nvPr/>
-        </p:nvSpPr>
-        <p:spPr>
-          <a:xfrm>
-            <a:off x="9747504" y="4572000"/>
-            <a:ext cx="1737360" cy="1188720"/>
+          <p:cNvPr id="35" name="TextBox 34"/>
+          <p:cNvSpPr txBox="1"/>
+          <p:nvPr/>
+        </p:nvSpPr>
+        <p:spPr>
+          <a:xfrm>
+            <a:off x="10094976" y="4572000"/>
+            <a:ext cx="1371600" cy="1188720"/>
           </a:xfrm>
           <a:prstGeom prst="rect">
             <a:avLst/>
@@ -17002,7 +17478,7 @@
           <a:p>
             <a:pPr algn="l"/>
             <a:r>
-              <a:rPr sz="1500" b="1" i="0">
+              <a:rPr sz="1400" b="1" i="0">
                 <a:solidFill>
                   <a:srgbClr val="FFFFFF"/>
                 </a:solidFill>
@@ -17691,7 +18167,7 @@
                 </a:solidFill>
                 <a:latin typeface="Cambria"/>
               </a:rPr>
-              <a:t>2 of 5</a:t>
+              <a:t>1–2 of 5</a:t>
             </a:r>
           </a:p>
         </p:txBody>
@@ -17726,7 +18202,7 @@
                 </a:solidFill>
                 <a:latin typeface="Calibri"/>
               </a:rPr>
-              <a:t>folds where FULL beats CONTROLS (RF and KNN); 3 of 5 for the linear models</a:t>
+              <a:t>folds where FULL beats CONTROLS for the tree models and KNN; 3 of 5 for the linear ones</a:t>
             </a:r>
           </a:p>
         </p:txBody>

</xml_diff>

<commit_message>
Team split for presenting and rechecking; reorder slides to match
report/WORK_SPLIT.md gives each member one continuous block (question and
data, models and results, errors and conclusion) and makes them present,
recheck and answer Q&A on that block in the slides, the report and the code
behind its numbers, with one cross-read each. The 'which mistakes remain'
slide moves after the classification slide so speakers change only twice
(slides 1-6, 7-11, 12-16); speaker notes and hand-over lines follow.
</commit_message>
<xml_diff>
--- a/report/Group7_Presentation_DRAFT.pptx
+++ b/report/Group7_Presentation_DRAFT.pptx
@@ -872,6 +872,210 @@
 <c:chartSpace xmlns:c="http://schemas.openxmlformats.org/drawingml/2006/chart" xmlns:a="http://schemas.openxmlformats.org/drawingml/2006/main" xmlns:r="http://schemas.openxmlformats.org/officeDocument/2006/relationships">
   <c:date1904 val="0"/>
   <c:chart>
+    <c:autoTitleDeleted val="1"/>
+    <c:plotArea>
+      <c:barChart>
+        <c:barDir val="bar"/>
+        <c:grouping val="clustered"/>
+        <c:varyColors val="0"/>
+        <c:ser>
+          <c:idx val="0"/>
+          <c:order val="0"/>
+          <c:tx>
+            <c:strRef>
+              <c:f>Sheet1!$B$1</c:f>
+              <c:strCache>
+                <c:ptCount val="1"/>
+                <c:pt idx="0">
+                  <c:v>RMSE increase</c:v>
+                </c:pt>
+              </c:strCache>
+            </c:strRef>
+          </c:tx>
+          <c:spPr>
+            <a:solidFill>
+              <a:srgbClr val="141B2D"/>
+            </a:solidFill>
+          </c:spPr>
+          <c:dPt>
+            <c:idx val="1"/>
+            <c:spPr>
+              <a:solidFill>
+                <a:srgbClr val="EB6A35"/>
+              </a:solidFill>
+            </c:spPr>
+          </c:dPt>
+          <c:dPt>
+            <c:idx val="2"/>
+            <c:spPr>
+              <a:solidFill>
+                <a:srgbClr val="9AA3B2"/>
+              </a:solidFill>
+            </c:spPr>
+          </c:dPt>
+          <c:cat>
+            <c:strRef>
+              <c:f>Sheet1!$A$2:$A$4</c:f>
+              <c:strCache>
+                <c:ptCount val="3"/>
+                <c:pt idx="0">
+                  <c:v>Controls (9)</c:v>
+                </c:pt>
+                <c:pt idx="1">
+                  <c:v>Emission (13)</c:v>
+                </c:pt>
+                <c:pt idx="2">
+                  <c:v>Static (10)</c:v>
+                </c:pt>
+              </c:strCache>
+            </c:strRef>
+          </c:cat>
+          <c:val>
+            <c:numRef>
+              <c:f>Sheet1!$B$2:$B$4</c:f>
+              <c:numCache>
+                <c:formatCode>General</c:formatCode>
+                <c:ptCount val="3"/>
+                <c:pt idx="0">
+                  <c:v>0.031</c:v>
+                </c:pt>
+                <c:pt idx="1">
+                  <c:v>0.01</c:v>
+                </c:pt>
+                <c:pt idx="2">
+                  <c:v>0.005</c:v>
+                </c:pt>
+              </c:numCache>
+            </c:numRef>
+          </c:val>
+        </c:ser>
+        <c:dLbls>
+          <c:numFmt formatCode="0.000" sourceLinked="0"/>
+          <c:txPr>
+            <a:bodyPr/>
+            <a:lstStyle/>
+            <a:p>
+              <a:pPr>
+                <a:defRPr sz="1200"/>
+              </a:pPr>
+            </a:p>
+          </c:txPr>
+          <c:dLblPos val="outEnd"/>
+          <c:showLegendKey val="0"/>
+          <c:showVal val="1"/>
+          <c:showCatName val="0"/>
+          <c:showSerName val="0"/>
+          <c:showPercent val="0"/>
+          <c:showBubbleSize val="0"/>
+          <c:showLeaderLines val="1"/>
+        </c:dLbls>
+        <c:gapWidth val="55"/>
+        <c:axId val="-2068027336"/>
+        <c:axId val="-2113994440"/>
+      </c:barChart>
+      <c:catAx>
+        <c:axId val="-2068027336"/>
+        <c:scaling>
+          <c:orientation val="maxMin"/>
+        </c:scaling>
+        <c:delete val="0"/>
+        <c:axPos val="l"/>
+        <c:majorTickMark val="out"/>
+        <c:minorTickMark val="none"/>
+        <c:tickLblPos val="nextTo"/>
+        <c:spPr>
+          <a:ln>
+            <a:solidFill>
+              <a:srgbClr val="D9DDE3"/>
+            </a:solidFill>
+          </a:ln>
+        </c:spPr>
+        <c:txPr>
+          <a:bodyPr/>
+          <a:lstStyle/>
+          <a:p>
+            <a:pPr>
+              <a:defRPr sz="1200"/>
+            </a:pPr>
+          </a:p>
+        </c:txPr>
+        <c:crossAx val="-2113994440"/>
+        <c:crosses val="autoZero"/>
+        <c:auto val="1"/>
+        <c:lblAlgn val="ctr"/>
+        <c:lblOffset val="100"/>
+        <c:noMultiLvlLbl val="0"/>
+      </c:catAx>
+      <c:valAx>
+        <c:axId val="-2113994440"/>
+        <c:scaling>
+          <c:max val="0.036"/>
+          <c:min val="0.0"/>
+        </c:scaling>
+        <c:delete val="0"/>
+        <c:axPos val="b"/>
+        <c:majorGridlines>
+          <c:spPr>
+            <a:ln>
+              <a:solidFill>
+                <a:srgbClr val="D9DDE3"/>
+              </a:solidFill>
+            </a:ln>
+          </c:spPr>
+        </c:majorGridlines>
+        <c:numFmt formatCode="0.000" sourceLinked="0"/>
+        <c:majorTickMark val="out"/>
+        <c:minorTickMark val="none"/>
+        <c:tickLblPos val="nextTo"/>
+        <c:spPr>
+          <a:ln>
+            <a:noFill/>
+          </a:ln>
+        </c:spPr>
+        <c:txPr>
+          <a:bodyPr/>
+          <a:lstStyle/>
+          <a:p>
+            <a:pPr>
+              <a:defRPr sz="1100">
+                <a:solidFill>
+                  <a:srgbClr val="6B7280"/>
+                </a:solidFill>
+              </a:defRPr>
+            </a:pPr>
+          </a:p>
+        </c:txPr>
+        <c:crossAx val="-2068027336"/>
+        <c:crosses val="autoZero"/>
+      </c:valAx>
+    </c:plotArea>
+    <c:dispBlanksAs val="gap"/>
+  </c:chart>
+  <c:txPr>
+    <a:bodyPr/>
+    <a:lstStyle/>
+    <a:p>
+      <a:pPr>
+        <a:defRPr sz="1200">
+          <a:solidFill>
+            <a:srgbClr val="1F2433"/>
+          </a:solidFill>
+          <a:latin typeface="Calibri"/>
+        </a:defRPr>
+      </a:pPr>
+      <a:endParaRPr lang="en-US"/>
+    </a:p>
+  </c:txPr>
+  <c:externalData r:id="rId1">
+    <c:autoUpdate val="0"/>
+  </c:externalData>
+</c:chartSpace>
+</file>
+
+<file path=ppt/charts/chart4.xml><?xml version="1.0" encoding="utf-8"?>
+<c:chartSpace xmlns:c="http://schemas.openxmlformats.org/drawingml/2006/chart" xmlns:a="http://schemas.openxmlformats.org/drawingml/2006/main" xmlns:r="http://schemas.openxmlformats.org/officeDocument/2006/relationships">
+  <c:date1904 val="0"/>
+  <c:chart>
     <c:autoTitleDeleted val="0"/>
     <c:plotArea>
       <c:barChart>
@@ -1198,210 +1402,6 @@
 </c:chartSpace>
 </file>
 
-<file path=ppt/charts/chart4.xml><?xml version="1.0" encoding="utf-8"?>
-<c:chartSpace xmlns:c="http://schemas.openxmlformats.org/drawingml/2006/chart" xmlns:a="http://schemas.openxmlformats.org/drawingml/2006/main" xmlns:r="http://schemas.openxmlformats.org/officeDocument/2006/relationships">
-  <c:date1904 val="0"/>
-  <c:chart>
-    <c:autoTitleDeleted val="1"/>
-    <c:plotArea>
-      <c:barChart>
-        <c:barDir val="bar"/>
-        <c:grouping val="clustered"/>
-        <c:varyColors val="0"/>
-        <c:ser>
-          <c:idx val="0"/>
-          <c:order val="0"/>
-          <c:tx>
-            <c:strRef>
-              <c:f>Sheet1!$B$1</c:f>
-              <c:strCache>
-                <c:ptCount val="1"/>
-                <c:pt idx="0">
-                  <c:v>RMSE increase</c:v>
-                </c:pt>
-              </c:strCache>
-            </c:strRef>
-          </c:tx>
-          <c:spPr>
-            <a:solidFill>
-              <a:srgbClr val="141B2D"/>
-            </a:solidFill>
-          </c:spPr>
-          <c:dPt>
-            <c:idx val="1"/>
-            <c:spPr>
-              <a:solidFill>
-                <a:srgbClr val="EB6A35"/>
-              </a:solidFill>
-            </c:spPr>
-          </c:dPt>
-          <c:dPt>
-            <c:idx val="2"/>
-            <c:spPr>
-              <a:solidFill>
-                <a:srgbClr val="9AA3B2"/>
-              </a:solidFill>
-            </c:spPr>
-          </c:dPt>
-          <c:cat>
-            <c:strRef>
-              <c:f>Sheet1!$A$2:$A$4</c:f>
-              <c:strCache>
-                <c:ptCount val="3"/>
-                <c:pt idx="0">
-                  <c:v>Controls (9)</c:v>
-                </c:pt>
-                <c:pt idx="1">
-                  <c:v>Emission (13)</c:v>
-                </c:pt>
-                <c:pt idx="2">
-                  <c:v>Static (10)</c:v>
-                </c:pt>
-              </c:strCache>
-            </c:strRef>
-          </c:cat>
-          <c:val>
-            <c:numRef>
-              <c:f>Sheet1!$B$2:$B$4</c:f>
-              <c:numCache>
-                <c:formatCode>General</c:formatCode>
-                <c:ptCount val="3"/>
-                <c:pt idx="0">
-                  <c:v>0.031</c:v>
-                </c:pt>
-                <c:pt idx="1">
-                  <c:v>0.01</c:v>
-                </c:pt>
-                <c:pt idx="2">
-                  <c:v>0.005</c:v>
-                </c:pt>
-              </c:numCache>
-            </c:numRef>
-          </c:val>
-        </c:ser>
-        <c:dLbls>
-          <c:numFmt formatCode="0.000" sourceLinked="0"/>
-          <c:txPr>
-            <a:bodyPr/>
-            <a:lstStyle/>
-            <a:p>
-              <a:pPr>
-                <a:defRPr sz="1200"/>
-              </a:pPr>
-            </a:p>
-          </c:txPr>
-          <c:dLblPos val="outEnd"/>
-          <c:showLegendKey val="0"/>
-          <c:showVal val="1"/>
-          <c:showCatName val="0"/>
-          <c:showSerName val="0"/>
-          <c:showPercent val="0"/>
-          <c:showBubbleSize val="0"/>
-          <c:showLeaderLines val="1"/>
-        </c:dLbls>
-        <c:gapWidth val="55"/>
-        <c:axId val="-2068027336"/>
-        <c:axId val="-2113994440"/>
-      </c:barChart>
-      <c:catAx>
-        <c:axId val="-2068027336"/>
-        <c:scaling>
-          <c:orientation val="maxMin"/>
-        </c:scaling>
-        <c:delete val="0"/>
-        <c:axPos val="l"/>
-        <c:majorTickMark val="out"/>
-        <c:minorTickMark val="none"/>
-        <c:tickLblPos val="nextTo"/>
-        <c:spPr>
-          <a:ln>
-            <a:solidFill>
-              <a:srgbClr val="D9DDE3"/>
-            </a:solidFill>
-          </a:ln>
-        </c:spPr>
-        <c:txPr>
-          <a:bodyPr/>
-          <a:lstStyle/>
-          <a:p>
-            <a:pPr>
-              <a:defRPr sz="1200"/>
-            </a:pPr>
-          </a:p>
-        </c:txPr>
-        <c:crossAx val="-2113994440"/>
-        <c:crosses val="autoZero"/>
-        <c:auto val="1"/>
-        <c:lblAlgn val="ctr"/>
-        <c:lblOffset val="100"/>
-        <c:noMultiLvlLbl val="0"/>
-      </c:catAx>
-      <c:valAx>
-        <c:axId val="-2113994440"/>
-        <c:scaling>
-          <c:max val="0.036"/>
-          <c:min val="0.0"/>
-        </c:scaling>
-        <c:delete val="0"/>
-        <c:axPos val="b"/>
-        <c:majorGridlines>
-          <c:spPr>
-            <a:ln>
-              <a:solidFill>
-                <a:srgbClr val="D9DDE3"/>
-              </a:solidFill>
-            </a:ln>
-          </c:spPr>
-        </c:majorGridlines>
-        <c:numFmt formatCode="0.000" sourceLinked="0"/>
-        <c:majorTickMark val="out"/>
-        <c:minorTickMark val="none"/>
-        <c:tickLblPos val="nextTo"/>
-        <c:spPr>
-          <a:ln>
-            <a:noFill/>
-          </a:ln>
-        </c:spPr>
-        <c:txPr>
-          <a:bodyPr/>
-          <a:lstStyle/>
-          <a:p>
-            <a:pPr>
-              <a:defRPr sz="1100">
-                <a:solidFill>
-                  <a:srgbClr val="6B7280"/>
-                </a:solidFill>
-              </a:defRPr>
-            </a:pPr>
-          </a:p>
-        </c:txPr>
-        <c:crossAx val="-2068027336"/>
-        <c:crosses val="autoZero"/>
-      </c:valAx>
-    </c:plotArea>
-    <c:dispBlanksAs val="gap"/>
-  </c:chart>
-  <c:txPr>
-    <a:bodyPr/>
-    <a:lstStyle/>
-    <a:p>
-      <a:pPr>
-        <a:defRPr sz="1200">
-          <a:solidFill>
-            <a:srgbClr val="1F2433"/>
-          </a:solidFill>
-          <a:latin typeface="Calibri"/>
-        </a:defRPr>
-      </a:pPr>
-      <a:endParaRPr lang="en-US"/>
-    </a:p>
-  </c:txPr>
-  <c:externalData r:id="rId1">
-    <c:autoUpdate val="0"/>
-  </c:externalData>
-</c:chartSpace>
-</file>
-
 <file path=ppt/notesMasters/notesMaster1.xml><?xml version="1.0" encoding="utf-8"?>
 <p:notesMaster xmlns:a="http://schemas.openxmlformats.org/drawingml/2006/main" xmlns:p="http://schemas.openxmlformats.org/presentationml/2006/main" xmlns:r="http://schemas.openxmlformats.org/officeDocument/2006/relationships">
   <p:cSld>
@@ -1873,13 +1873,13 @@
           <a:lstStyle/>
           <a:p>
             <a:r>
-              <a:t>Speaker: [Member 3]</a:t>
+              <a:t>Speaker: [Member 2]</a:t>
             </a:r>
           </a:p>
           <a:p/>
           <a:p>
             <a:r>
-              <a:t>We pool all test rows and ask where the errors are. If unlock features carried signal, FULL should beat CONTROLS where more than 5% of the float unlocks, or where a cliff is two weeks away. The opposite happens: positive bars mean adding unlock features made the forecast worse. What remains is regression to the mean: too high for tokens that turn calm, too low for tokens that spike. The models' real gain over persistence is fewer large misses.</a:t>
+              <a:t>We explain each model with the tool that suits it. Random Forest permutation importance: shuffling all controls costs three times more test RMSE than shuffling all 13 emission features, and partial dependence on unlock pressure is flat. Coefficients: the largest unlock coefficient is positive, as the narrative says, but five times smaller than trailing volatility, and Elastic Net drops everything in two folds. A shallow tree never splits on an unlock feature. Neighbours: for the most unlock-heavy token-day there is no comparable history, so KNN falls back on trailing volatility.</a:t>
             </a:r>
           </a:p>
         </p:txBody>
@@ -1949,13 +1949,13 @@
           <a:lstStyle/>
           <a:p>
             <a:r>
-              <a:t>Speaker: [Member 3]</a:t>
+              <a:t>Speaker: [Member 2]</a:t>
             </a:r>
           </a:p>
           <a:p/>
           <a:p>
             <a:r>
-              <a:t>We explain each model with the tool that suits it. Random Forest permutation importance: shuffling all controls costs three times more test RMSE than shuffling all 13 emission features, and partial dependence on unlock pressure is flat. Coefficients: the largest unlock coefficient is positive, as the narrative says, but five times smaller than trailing volatility, and Elastic Net drops everything in two folds. A shallow tree never splits on an unlock feature. Neighbours: for the most unlock-heavy token-day there is no comparable history, so KNN falls back on trailing volatility.</a:t>
+              <a:t>Same question as classification. The model on controls does pick out high-volatility tokens better than just ranking by recent volatility, AUC 0.69 against 0.65. Adding unlock features lowers AUC, PR-AUC and the Brier skill score for both events, on both panels. Hand over: on average the answer is no; [Member 3] shows where the remaining errors are and whether any of this matters in practice.</a:t>
             </a:r>
           </a:p>
         </p:txBody>
@@ -2031,7 +2031,7 @@
           <a:p/>
           <a:p>
             <a:r>
-              <a:t>Same question as classification. The model on controls does pick out high-volatility tokens better than just ranking by recent volatility, AUC 0.69 against 0.65. Adding unlock features lowers AUC, PR-AUC and the Brier skill score for both events, on both panels.</a:t>
+              <a:t>We pool all test rows and ask where the errors are. If unlock features carried signal, FULL should beat CONTROLS where more than 5% of the float unlocks, or where a cliff is two weeks away. The opposite happens: positive bars mean adding unlock features made the forecast worse. What remains is regression to the mean: too high for tokens that turn calm, too low for tokens that spike. The models' real gain over persistence is fewer large misses.</a:t>
             </a:r>
           </a:p>
         </p:txBody>
@@ -2779,13 +2779,13 @@
           <a:lstStyle/>
           <a:p>
             <a:r>
-              <a:t>Speaker: [Member 2]</a:t>
+              <a:t>Speaker: [Member 1]</a:t>
             </a:r>
           </a:p>
           <a:p/>
           <a:p>
             <a:r>
-              <a:t>Five folds cut by calendar date, all tokens pooled. Training expands; a 30-day embargo separates train from test because the target looks 14 days ahead. Inside each fold the last 90 days of training are the validation slice used for tuning; the winner is refit on all training data and scored once on the next 90 days. Scalers live inside the sklearn pipeline, so nothing is fit on test data.</a:t>
+              <a:t>Five folds cut by calendar date, all tokens pooled. Training expands; a 30-day embargo separates train from test because the target looks 14 days ahead. Inside each fold the last 90 days of training are the validation slice used for tuning; the winner is refit on all training data and scored once on the next 90 days. Scalers live inside the sklearn pipeline, so nothing is fit on test data. Hand over: with the protocol fixed, [Member 2] shows what six models do under it.</a:t>
             </a:r>
           </a:p>
         </p:txBody>
@@ -6258,7 +6258,7 @@
                 </a:solidFill>
                 <a:latin typeface="Calibri"/>
               </a:rPr>
-              <a:t>WHICH MISTAKES REMAIN?</a:t>
+              <a:t>INTERPRETATION</a:t>
             </a:r>
           </a:p>
         </p:txBody>
@@ -6293,7 +6293,7 @@
                 </a:solidFill>
                 <a:latin typeface="Cambria"/>
               </a:rPr>
-              <a:t>Unlock features do not help even where unlocks are big</a:t>
+              <a:t>Inside the models, unlock features barely register</a:t>
             </a:r>
           </a:p>
         </p:txBody>
@@ -6377,8 +6377,8 @@
           <p:nvPr/>
         </p:nvGraphicFramePr>
         <p:xfrm>
-          <a:off x="548640" y="2011680"/>
-          <a:ext cx="7589520" cy="4160520"/>
+          <a:off x="548640" y="2057400"/>
+          <a:ext cx="5486400" cy="3291840"/>
         </p:xfrm>
         <a:graphic>
           <a:graphicData uri="http://schemas.openxmlformats.org/drawingml/2006/chart">
@@ -6395,7 +6395,7 @@
         <p:spPr>
           <a:xfrm>
             <a:off x="548640" y="1645920"/>
-            <a:ext cx="7589520" cy="365760"/>
+            <a:ext cx="5486400" cy="365760"/>
           </a:xfrm>
           <a:prstGeom prst="rect">
             <a:avLst/>
@@ -6416,7 +6416,7 @@
                 </a:solidFill>
                 <a:latin typeface="Calibri"/>
               </a:rPr>
-              <a:t>Change in test RMSE from adding unlock features (positive = worse), by 30-day unlock share of float</a:t>
+              <a:t>Random Forest: test-RMSE increase when a feature group is shuffled</a:t>
             </a:r>
           </a:p>
         </p:txBody>
@@ -6429,8 +6429,8 @@
         </p:nvSpPr>
         <p:spPr>
           <a:xfrm>
-            <a:off x="8503920" y="1737360"/>
-            <a:ext cx="3200400" cy="640080"/>
+            <a:off x="548640" y="5440680"/>
+            <a:ext cx="5486400" cy="640080"/>
           </a:xfrm>
           <a:prstGeom prst="rect">
             <a:avLst/>
@@ -6445,27 +6445,73 @@
           <a:p>
             <a:pPr algn="l"/>
             <a:r>
-              <a:rPr sz="3200" b="1" i="0">
-                <a:solidFill>
-                  <a:srgbClr val="141B2D"/>
-                </a:solidFill>
-                <a:latin typeface="Cambria"/>
-              </a:rPr>
-              <a:t>18% → 12%</a:t>
-            </a:r>
-          </a:p>
-        </p:txBody>
-      </p:sp>
-      <p:sp>
-        <p:nvSpPr>
-          <p:cNvPr id="9" name="TextBox 8"/>
-          <p:cNvSpPr txBox="1"/>
-          <p:nvPr/>
-        </p:nvSpPr>
-        <p:spPr>
-          <a:xfrm>
-            <a:off x="8503920" y="2423160"/>
-            <a:ext cx="3108960" cy="1097280"/>
+              <a:rPr sz="1300" b="0" i="0">
+                <a:solidFill>
+                  <a:srgbClr val="6B7280"/>
+                </a:solidFill>
+                <a:latin typeface="Calibri"/>
+              </a:rPr>
+              <a:t>Top 5 RF features are all controls; partial dependence on unlock pressure is flat. LightGBM: controls take 92% of split gain, emission 4%.</a:t>
+            </a:r>
+          </a:p>
+        </p:txBody>
+      </p:sp>
+      <p:sp>
+        <p:nvSpPr>
+          <p:cNvPr id="9" name="Interpretation card 0"/>
+          <p:cNvSpPr/>
+          <p:nvPr/>
+        </p:nvSpPr>
+        <p:spPr>
+          <a:xfrm>
+            <a:off x="6492240" y="1691640"/>
+            <a:ext cx="5120640" cy="1298448"/>
+          </a:xfrm>
+          <a:prstGeom prst="roundRect">
+            <a:avLst>
+              <a:gd name="adj" fmla="val 8000"/>
+            </a:avLst>
+          </a:prstGeom>
+          <a:solidFill>
+            <a:srgbClr val="F2F4F7"/>
+          </a:solidFill>
+          <a:ln>
+            <a:noFill/>
+          </a:ln>
+          <a:effectLst/>
+        </p:spPr>
+        <p:style>
+          <a:lnRef idx="1">
+            <a:schemeClr val="accent1"/>
+          </a:lnRef>
+          <a:fillRef idx="3">
+            <a:schemeClr val="accent1"/>
+          </a:fillRef>
+          <a:effectRef idx="2">
+            <a:schemeClr val="accent1"/>
+          </a:effectRef>
+          <a:fontRef idx="minor">
+            <a:schemeClr val="lt1"/>
+          </a:fontRef>
+        </p:style>
+        <p:txBody>
+          <a:bodyPr rtlCol="0" anchor="ctr"/>
+          <a:lstStyle/>
+          <a:p>
+            <a:pPr algn="ctr"/>
+          </a:p>
+        </p:txBody>
+      </p:sp>
+      <p:sp>
+        <p:nvSpPr>
+          <p:cNvPr id="10" name="TextBox 9"/>
+          <p:cNvSpPr txBox="1"/>
+          <p:nvPr/>
+        </p:nvSpPr>
+        <p:spPr>
+          <a:xfrm>
+            <a:off x="6720840" y="1856232"/>
+            <a:ext cx="4663440" cy="274320"/>
           </a:xfrm>
           <a:prstGeom prst="rect">
             <a:avLst/>
@@ -6480,27 +6526,143 @@
           <a:p>
             <a:pPr algn="l"/>
             <a:r>
-              <a:rPr sz="1500" b="0" i="0">
+              <a:rPr sz="1100" b="1" i="0">
+                <a:solidFill>
+                  <a:srgbClr val="EB6A35"/>
+                </a:solidFill>
+                <a:latin typeface="Calibri"/>
+              </a:rPr>
+              <a:t>COEFFICIENTS</a:t>
+            </a:r>
+          </a:p>
+        </p:txBody>
+      </p:sp>
+      <p:sp>
+        <p:nvSpPr>
+          <p:cNvPr id="11" name="TextBox 10"/>
+          <p:cNvSpPr txBox="1"/>
+          <p:nvPr/>
+        </p:nvSpPr>
+        <p:spPr>
+          <a:xfrm>
+            <a:off x="6720840" y="2103120"/>
+            <a:ext cx="4663440" cy="365760"/>
+          </a:xfrm>
+          <a:prstGeom prst="rect">
+            <a:avLst/>
+          </a:prstGeom>
+          <a:noFill/>
+        </p:spPr>
+        <p:txBody>
+          <a:bodyPr wrap="square" lIns="0" rIns="0" tIns="0" bIns="0" anchor="t">
+            <a:spAutoFit/>
+          </a:bodyPr>
+          <a:lstStyle/>
+          <a:p>
+            <a:pPr algn="l"/>
+            <a:r>
+              <a:rPr sz="1500" b="1" i="0">
+                <a:solidFill>
+                  <a:srgbClr val="1F2433"/>
+                </a:solidFill>
+                <a:latin typeface="Calibri"/>
+              </a:rPr>
+              <a:t>Ridge / Elastic Net</a:t>
+            </a:r>
+          </a:p>
+        </p:txBody>
+      </p:sp>
+      <p:sp>
+        <p:nvSpPr>
+          <p:cNvPr id="12" name="TextBox 11"/>
+          <p:cNvSpPr txBox="1"/>
+          <p:nvPr/>
+        </p:nvSpPr>
+        <p:spPr>
+          <a:xfrm>
+            <a:off x="6720840" y="2441448"/>
+            <a:ext cx="4663440" cy="548640"/>
+          </a:xfrm>
+          <a:prstGeom prst="rect">
+            <a:avLst/>
+          </a:prstGeom>
+          <a:noFill/>
+        </p:spPr>
+        <p:txBody>
+          <a:bodyPr wrap="square" lIns="0" rIns="0" tIns="0" bIns="0" anchor="t">
+            <a:spAutoFit/>
+          </a:bodyPr>
+          <a:lstStyle/>
+          <a:p>
+            <a:pPr algn="l"/>
+            <a:r>
+              <a:rPr sz="1300" b="0" i="0">
                 <a:solidFill>
                   <a:srgbClr val="6B7280"/>
                 </a:solidFill>
                 <a:latin typeface="Calibri"/>
               </a:rPr>
-              <a:t>forecasts off by more than 2×: persistence vs Ridge. The real gain is fewer large misses</a:t>
-            </a:r>
-          </a:p>
-        </p:txBody>
-      </p:sp>
-      <p:sp>
-        <p:nvSpPr>
-          <p:cNvPr id="10" name="TextBox 9"/>
-          <p:cNvSpPr txBox="1"/>
-          <p:nvPr/>
-        </p:nvSpPr>
-        <p:spPr>
-          <a:xfrm>
-            <a:off x="8503920" y="3886200"/>
-            <a:ext cx="3200400" cy="640080"/>
+              <a:t>Largest unlock coefficient +0.008 vs +0.040 for trailing 30d vol; EN drops every feature in 2 of 5 folds</a:t>
+            </a:r>
+          </a:p>
+        </p:txBody>
+      </p:sp>
+      <p:sp>
+        <p:nvSpPr>
+          <p:cNvPr id="13" name="Interpretation card 1"/>
+          <p:cNvSpPr/>
+          <p:nvPr/>
+        </p:nvSpPr>
+        <p:spPr>
+          <a:xfrm>
+            <a:off x="6492240" y="3172968"/>
+            <a:ext cx="5120640" cy="1298448"/>
+          </a:xfrm>
+          <a:prstGeom prst="roundRect">
+            <a:avLst>
+              <a:gd name="adj" fmla="val 8000"/>
+            </a:avLst>
+          </a:prstGeom>
+          <a:solidFill>
+            <a:srgbClr val="F2F4F7"/>
+          </a:solidFill>
+          <a:ln>
+            <a:noFill/>
+          </a:ln>
+          <a:effectLst/>
+        </p:spPr>
+        <p:style>
+          <a:lnRef idx="1">
+            <a:schemeClr val="accent1"/>
+          </a:lnRef>
+          <a:fillRef idx="3">
+            <a:schemeClr val="accent1"/>
+          </a:fillRef>
+          <a:effectRef idx="2">
+            <a:schemeClr val="accent1"/>
+          </a:effectRef>
+          <a:fontRef idx="minor">
+            <a:schemeClr val="lt1"/>
+          </a:fontRef>
+        </p:style>
+        <p:txBody>
+          <a:bodyPr rtlCol="0" anchor="ctr"/>
+          <a:lstStyle/>
+          <a:p>
+            <a:pPr algn="ctr"/>
+          </a:p>
+        </p:txBody>
+      </p:sp>
+      <p:sp>
+        <p:nvSpPr>
+          <p:cNvPr id="14" name="TextBox 13"/>
+          <p:cNvSpPr txBox="1"/>
+          <p:nvPr/>
+        </p:nvSpPr>
+        <p:spPr>
+          <a:xfrm>
+            <a:off x="6720840" y="3337560"/>
+            <a:ext cx="4663440" cy="274320"/>
           </a:xfrm>
           <a:prstGeom prst="rect">
             <a:avLst/>
@@ -6515,27 +6677,27 @@
           <a:p>
             <a:pPr algn="l"/>
             <a:r>
-              <a:rPr sz="3200" b="1" i="0">
+              <a:rPr sz="1100" b="1" i="0">
                 <a:solidFill>
                   <a:srgbClr val="EB6A35"/>
                 </a:solidFill>
-                <a:latin typeface="Cambria"/>
-              </a:rPr>
-              <a:t>62%</a:t>
-            </a:r>
-          </a:p>
-        </p:txBody>
-      </p:sp>
-      <p:sp>
-        <p:nvSpPr>
-          <p:cNvPr id="11" name="TextBox 10"/>
-          <p:cNvSpPr txBox="1"/>
-          <p:nvPr/>
-        </p:nvSpPr>
-        <p:spPr>
-          <a:xfrm>
-            <a:off x="8503920" y="4572000"/>
-            <a:ext cx="3108960" cy="1097280"/>
+                <a:latin typeface="Calibri"/>
+              </a:rPr>
+              <a:t>A TREE</a:t>
+            </a:r>
+          </a:p>
+        </p:txBody>
+      </p:sp>
+      <p:sp>
+        <p:nvSpPr>
+          <p:cNvPr id="15" name="TextBox 14"/>
+          <p:cNvSpPr txBox="1"/>
+          <p:nvPr/>
+        </p:nvSpPr>
+        <p:spPr>
+          <a:xfrm>
+            <a:off x="6720840" y="3584448"/>
+            <a:ext cx="4663440" cy="365760"/>
           </a:xfrm>
           <a:prstGeom prst="rect">
             <a:avLst/>
@@ -6550,13 +6712,199 @@
           <a:p>
             <a:pPr algn="l"/>
             <a:r>
-              <a:rPr sz="1500" b="0" i="0">
+              <a:rPr sz="1500" b="1" i="0">
+                <a:solidFill>
+                  <a:srgbClr val="1F2433"/>
+                </a:solidFill>
+                <a:latin typeface="Calibri"/>
+              </a:rPr>
+              <a:t>Depth-3 tree, all 32 features</a:t>
+            </a:r>
+          </a:p>
+        </p:txBody>
+      </p:sp>
+      <p:sp>
+        <p:nvSpPr>
+          <p:cNvPr id="16" name="TextBox 15"/>
+          <p:cNvSpPr txBox="1"/>
+          <p:nvPr/>
+        </p:nvSpPr>
+        <p:spPr>
+          <a:xfrm>
+            <a:off x="6720840" y="3922776"/>
+            <a:ext cx="4663440" cy="548640"/>
+          </a:xfrm>
+          <a:prstGeom prst="rect">
+            <a:avLst/>
+          </a:prstGeom>
+          <a:noFill/>
+        </p:spPr>
+        <p:txBody>
+          <a:bodyPr wrap="square" lIns="0" rIns="0" tIns="0" bIns="0" anchor="t">
+            <a:spAutoFit/>
+          </a:bodyPr>
+          <a:lstStyle/>
+          <a:p>
+            <a:pPr algn="l"/>
+            <a:r>
+              <a:rPr sz="1300" b="0" i="0">
                 <a:solidFill>
                   <a:srgbClr val="6B7280"/>
                 </a:solidFill>
                 <a:latin typeface="Calibri"/>
               </a:rPr>
-              <a:t>of remaining 2× misses are over-forecasts: volatility collapsed. The rest are spikes no feature sees</a:t>
+              <a:t>Splits only on trailing vol, BTC/ETH vol, token age and 30d return</a:t>
+            </a:r>
+          </a:p>
+        </p:txBody>
+      </p:sp>
+      <p:sp>
+        <p:nvSpPr>
+          <p:cNvPr id="17" name="Interpretation card 2"/>
+          <p:cNvSpPr/>
+          <p:nvPr/>
+        </p:nvSpPr>
+        <p:spPr>
+          <a:xfrm>
+            <a:off x="6492240" y="4654296"/>
+            <a:ext cx="5120640" cy="1298448"/>
+          </a:xfrm>
+          <a:prstGeom prst="roundRect">
+            <a:avLst>
+              <a:gd name="adj" fmla="val 8000"/>
+            </a:avLst>
+          </a:prstGeom>
+          <a:solidFill>
+            <a:srgbClr val="F2F4F7"/>
+          </a:solidFill>
+          <a:ln>
+            <a:noFill/>
+          </a:ln>
+          <a:effectLst/>
+        </p:spPr>
+        <p:style>
+          <a:lnRef idx="1">
+            <a:schemeClr val="accent1"/>
+          </a:lnRef>
+          <a:fillRef idx="3">
+            <a:schemeClr val="accent1"/>
+          </a:fillRef>
+          <a:effectRef idx="2">
+            <a:schemeClr val="accent1"/>
+          </a:effectRef>
+          <a:fontRef idx="minor">
+            <a:schemeClr val="lt1"/>
+          </a:fontRef>
+        </p:style>
+        <p:txBody>
+          <a:bodyPr rtlCol="0" anchor="ctr"/>
+          <a:lstStyle/>
+          <a:p>
+            <a:pPr algn="ctr"/>
+          </a:p>
+        </p:txBody>
+      </p:sp>
+      <p:sp>
+        <p:nvSpPr>
+          <p:cNvPr id="18" name="TextBox 17"/>
+          <p:cNvSpPr txBox="1"/>
+          <p:nvPr/>
+        </p:nvSpPr>
+        <p:spPr>
+          <a:xfrm>
+            <a:off x="6720840" y="4818888"/>
+            <a:ext cx="4663440" cy="274320"/>
+          </a:xfrm>
+          <a:prstGeom prst="rect">
+            <a:avLst/>
+          </a:prstGeom>
+          <a:noFill/>
+        </p:spPr>
+        <p:txBody>
+          <a:bodyPr wrap="square" lIns="0" rIns="0" tIns="0" bIns="0" anchor="t">
+            <a:spAutoFit/>
+          </a:bodyPr>
+          <a:lstStyle/>
+          <a:p>
+            <a:pPr algn="l"/>
+            <a:r>
+              <a:rPr sz="1100" b="1" i="0">
+                <a:solidFill>
+                  <a:srgbClr val="EB6A35"/>
+                </a:solidFill>
+                <a:latin typeface="Calibri"/>
+              </a:rPr>
+              <a:t>NEIGHBOURS</a:t>
+            </a:r>
+          </a:p>
+        </p:txBody>
+      </p:sp>
+      <p:sp>
+        <p:nvSpPr>
+          <p:cNvPr id="19" name="TextBox 18"/>
+          <p:cNvSpPr txBox="1"/>
+          <p:nvPr/>
+        </p:nvSpPr>
+        <p:spPr>
+          <a:xfrm>
+            <a:off x="6720840" y="5065776"/>
+            <a:ext cx="4663440" cy="365760"/>
+          </a:xfrm>
+          <a:prstGeom prst="rect">
+            <a:avLst/>
+          </a:prstGeom>
+          <a:noFill/>
+        </p:spPr>
+        <p:txBody>
+          <a:bodyPr wrap="square" lIns="0" rIns="0" tIns="0" bIns="0" anchor="t">
+            <a:spAutoFit/>
+          </a:bodyPr>
+          <a:lstStyle/>
+          <a:p>
+            <a:pPr algn="l"/>
+            <a:r>
+              <a:rPr sz="1500" b="1" i="0">
+                <a:solidFill>
+                  <a:srgbClr val="1F2433"/>
+                </a:solidFill>
+                <a:latin typeface="Calibri"/>
+              </a:rPr>
+              <a:t>KNN, most unlock-heavy row</a:t>
+            </a:r>
+          </a:p>
+        </p:txBody>
+      </p:sp>
+      <p:sp>
+        <p:nvSpPr>
+          <p:cNvPr id="20" name="TextBox 19"/>
+          <p:cNvSpPr txBox="1"/>
+          <p:nvPr/>
+        </p:nvSpPr>
+        <p:spPr>
+          <a:xfrm>
+            <a:off x="6720840" y="5404104"/>
+            <a:ext cx="4663440" cy="548640"/>
+          </a:xfrm>
+          <a:prstGeom prst="rect">
+            <a:avLst/>
+          </a:prstGeom>
+          <a:noFill/>
+        </p:spPr>
+        <p:txBody>
+          <a:bodyPr wrap="square" lIns="0" rIns="0" tIns="0" bIns="0" anchor="t">
+            <a:spAutoFit/>
+          </a:bodyPr>
+          <a:lstStyle/>
+          <a:p>
+            <a:pPr algn="l"/>
+            <a:r>
+              <a:rPr sz="1300" b="0" i="0">
+                <a:solidFill>
+                  <a:srgbClr val="6B7280"/>
+                </a:solidFill>
+                <a:latin typeface="Calibri"/>
+              </a:rPr>
+              <a:t>104% of float unlocking; neighbours' median 12.5%. Forecast 0.78, realized 0.55</a:t>
             </a:r>
           </a:p>
         </p:txBody>
@@ -6617,7 +6965,7 @@
                 </a:solidFill>
                 <a:latin typeface="Calibri"/>
               </a:rPr>
-              <a:t>INTERPRETATION</a:t>
+              <a:t>RESULT 3</a:t>
             </a:r>
           </a:p>
         </p:txBody>
@@ -6652,7 +7000,7 @@
                 </a:solidFill>
                 <a:latin typeface="Cambria"/>
               </a:rPr>
-              <a:t>Inside the models, unlock features barely register</a:t>
+              <a:t>Classification view: unlock features slightly hurt</a:t>
             </a:r>
           </a:p>
         </p:txBody>
@@ -6723,713 +7071,6 @@
                 <a:latin typeface="Calibri"/>
               </a:rPr>
               <a:t>11</a:t>
-            </a:r>
-          </a:p>
-        </p:txBody>
-      </p:sp>
-      <p:graphicFrame>
-        <p:nvGraphicFramePr>
-          <p:cNvPr id="6" name="Chart 5"/>
-          <p:cNvGraphicFramePr>
-            <a:graphicFrameLocks noGrp="1"/>
-          </p:cNvGraphicFramePr>
-          <p:nvPr/>
-        </p:nvGraphicFramePr>
-        <p:xfrm>
-          <a:off x="548640" y="2057400"/>
-          <a:ext cx="5486400" cy="3291840"/>
-        </p:xfrm>
-        <a:graphic>
-          <a:graphicData uri="http://schemas.openxmlformats.org/drawingml/2006/chart">
-            <c:chart xmlns:c="http://schemas.openxmlformats.org/drawingml/2006/chart" r:id="rId3"/>
-          </a:graphicData>
-        </a:graphic>
-      </p:graphicFrame>
-      <p:sp>
-        <p:nvSpPr>
-          <p:cNvPr id="7" name="TextBox 6"/>
-          <p:cNvSpPr txBox="1"/>
-          <p:nvPr/>
-        </p:nvSpPr>
-        <p:spPr>
-          <a:xfrm>
-            <a:off x="548640" y="1645920"/>
-            <a:ext cx="5486400" cy="365760"/>
-          </a:xfrm>
-          <a:prstGeom prst="rect">
-            <a:avLst/>
-          </a:prstGeom>
-          <a:noFill/>
-        </p:spPr>
-        <p:txBody>
-          <a:bodyPr wrap="square" lIns="0" rIns="0" tIns="0" bIns="0" anchor="t">
-            <a:spAutoFit/>
-          </a:bodyPr>
-          <a:lstStyle/>
-          <a:p>
-            <a:pPr algn="l"/>
-            <a:r>
-              <a:rPr sz="1400" b="1" i="0">
-                <a:solidFill>
-                  <a:srgbClr val="1F2433"/>
-                </a:solidFill>
-                <a:latin typeface="Calibri"/>
-              </a:rPr>
-              <a:t>Random Forest: test-RMSE increase when a feature group is shuffled</a:t>
-            </a:r>
-          </a:p>
-        </p:txBody>
-      </p:sp>
-      <p:sp>
-        <p:nvSpPr>
-          <p:cNvPr id="8" name="TextBox 7"/>
-          <p:cNvSpPr txBox="1"/>
-          <p:nvPr/>
-        </p:nvSpPr>
-        <p:spPr>
-          <a:xfrm>
-            <a:off x="548640" y="5440680"/>
-            <a:ext cx="5486400" cy="640080"/>
-          </a:xfrm>
-          <a:prstGeom prst="rect">
-            <a:avLst/>
-          </a:prstGeom>
-          <a:noFill/>
-        </p:spPr>
-        <p:txBody>
-          <a:bodyPr wrap="square" lIns="0" rIns="0" tIns="0" bIns="0" anchor="t">
-            <a:spAutoFit/>
-          </a:bodyPr>
-          <a:lstStyle/>
-          <a:p>
-            <a:pPr algn="l"/>
-            <a:r>
-              <a:rPr sz="1300" b="0" i="0">
-                <a:solidFill>
-                  <a:srgbClr val="6B7280"/>
-                </a:solidFill>
-                <a:latin typeface="Calibri"/>
-              </a:rPr>
-              <a:t>Top 5 RF features are all controls; partial dependence on unlock pressure is flat. LightGBM: controls take 92% of split gain, emission 4%.</a:t>
-            </a:r>
-          </a:p>
-        </p:txBody>
-      </p:sp>
-      <p:sp>
-        <p:nvSpPr>
-          <p:cNvPr id="9" name="Interpretation card 0"/>
-          <p:cNvSpPr/>
-          <p:nvPr/>
-        </p:nvSpPr>
-        <p:spPr>
-          <a:xfrm>
-            <a:off x="6492240" y="1691640"/>
-            <a:ext cx="5120640" cy="1298448"/>
-          </a:xfrm>
-          <a:prstGeom prst="roundRect">
-            <a:avLst>
-              <a:gd name="adj" fmla="val 8000"/>
-            </a:avLst>
-          </a:prstGeom>
-          <a:solidFill>
-            <a:srgbClr val="F2F4F7"/>
-          </a:solidFill>
-          <a:ln>
-            <a:noFill/>
-          </a:ln>
-          <a:effectLst/>
-        </p:spPr>
-        <p:style>
-          <a:lnRef idx="1">
-            <a:schemeClr val="accent1"/>
-          </a:lnRef>
-          <a:fillRef idx="3">
-            <a:schemeClr val="accent1"/>
-          </a:fillRef>
-          <a:effectRef idx="2">
-            <a:schemeClr val="accent1"/>
-          </a:effectRef>
-          <a:fontRef idx="minor">
-            <a:schemeClr val="lt1"/>
-          </a:fontRef>
-        </p:style>
-        <p:txBody>
-          <a:bodyPr rtlCol="0" anchor="ctr"/>
-          <a:lstStyle/>
-          <a:p>
-            <a:pPr algn="ctr"/>
-          </a:p>
-        </p:txBody>
-      </p:sp>
-      <p:sp>
-        <p:nvSpPr>
-          <p:cNvPr id="10" name="TextBox 9"/>
-          <p:cNvSpPr txBox="1"/>
-          <p:nvPr/>
-        </p:nvSpPr>
-        <p:spPr>
-          <a:xfrm>
-            <a:off x="6720840" y="1856232"/>
-            <a:ext cx="4663440" cy="274320"/>
-          </a:xfrm>
-          <a:prstGeom prst="rect">
-            <a:avLst/>
-          </a:prstGeom>
-          <a:noFill/>
-        </p:spPr>
-        <p:txBody>
-          <a:bodyPr wrap="square" lIns="0" rIns="0" tIns="0" bIns="0" anchor="t">
-            <a:spAutoFit/>
-          </a:bodyPr>
-          <a:lstStyle/>
-          <a:p>
-            <a:pPr algn="l"/>
-            <a:r>
-              <a:rPr sz="1100" b="1" i="0">
-                <a:solidFill>
-                  <a:srgbClr val="EB6A35"/>
-                </a:solidFill>
-                <a:latin typeface="Calibri"/>
-              </a:rPr>
-              <a:t>COEFFICIENTS</a:t>
-            </a:r>
-          </a:p>
-        </p:txBody>
-      </p:sp>
-      <p:sp>
-        <p:nvSpPr>
-          <p:cNvPr id="11" name="TextBox 10"/>
-          <p:cNvSpPr txBox="1"/>
-          <p:nvPr/>
-        </p:nvSpPr>
-        <p:spPr>
-          <a:xfrm>
-            <a:off x="6720840" y="2103120"/>
-            <a:ext cx="4663440" cy="365760"/>
-          </a:xfrm>
-          <a:prstGeom prst="rect">
-            <a:avLst/>
-          </a:prstGeom>
-          <a:noFill/>
-        </p:spPr>
-        <p:txBody>
-          <a:bodyPr wrap="square" lIns="0" rIns="0" tIns="0" bIns="0" anchor="t">
-            <a:spAutoFit/>
-          </a:bodyPr>
-          <a:lstStyle/>
-          <a:p>
-            <a:pPr algn="l"/>
-            <a:r>
-              <a:rPr sz="1500" b="1" i="0">
-                <a:solidFill>
-                  <a:srgbClr val="1F2433"/>
-                </a:solidFill>
-                <a:latin typeface="Calibri"/>
-              </a:rPr>
-              <a:t>Ridge / Elastic Net</a:t>
-            </a:r>
-          </a:p>
-        </p:txBody>
-      </p:sp>
-      <p:sp>
-        <p:nvSpPr>
-          <p:cNvPr id="12" name="TextBox 11"/>
-          <p:cNvSpPr txBox="1"/>
-          <p:nvPr/>
-        </p:nvSpPr>
-        <p:spPr>
-          <a:xfrm>
-            <a:off x="6720840" y="2441448"/>
-            <a:ext cx="4663440" cy="548640"/>
-          </a:xfrm>
-          <a:prstGeom prst="rect">
-            <a:avLst/>
-          </a:prstGeom>
-          <a:noFill/>
-        </p:spPr>
-        <p:txBody>
-          <a:bodyPr wrap="square" lIns="0" rIns="0" tIns="0" bIns="0" anchor="t">
-            <a:spAutoFit/>
-          </a:bodyPr>
-          <a:lstStyle/>
-          <a:p>
-            <a:pPr algn="l"/>
-            <a:r>
-              <a:rPr sz="1300" b="0" i="0">
-                <a:solidFill>
-                  <a:srgbClr val="6B7280"/>
-                </a:solidFill>
-                <a:latin typeface="Calibri"/>
-              </a:rPr>
-              <a:t>Largest unlock coefficient +0.008 vs +0.040 for trailing 30d vol; EN drops every feature in 2 of 5 folds</a:t>
-            </a:r>
-          </a:p>
-        </p:txBody>
-      </p:sp>
-      <p:sp>
-        <p:nvSpPr>
-          <p:cNvPr id="13" name="Interpretation card 1"/>
-          <p:cNvSpPr/>
-          <p:nvPr/>
-        </p:nvSpPr>
-        <p:spPr>
-          <a:xfrm>
-            <a:off x="6492240" y="3172968"/>
-            <a:ext cx="5120640" cy="1298448"/>
-          </a:xfrm>
-          <a:prstGeom prst="roundRect">
-            <a:avLst>
-              <a:gd name="adj" fmla="val 8000"/>
-            </a:avLst>
-          </a:prstGeom>
-          <a:solidFill>
-            <a:srgbClr val="F2F4F7"/>
-          </a:solidFill>
-          <a:ln>
-            <a:noFill/>
-          </a:ln>
-          <a:effectLst/>
-        </p:spPr>
-        <p:style>
-          <a:lnRef idx="1">
-            <a:schemeClr val="accent1"/>
-          </a:lnRef>
-          <a:fillRef idx="3">
-            <a:schemeClr val="accent1"/>
-          </a:fillRef>
-          <a:effectRef idx="2">
-            <a:schemeClr val="accent1"/>
-          </a:effectRef>
-          <a:fontRef idx="minor">
-            <a:schemeClr val="lt1"/>
-          </a:fontRef>
-        </p:style>
-        <p:txBody>
-          <a:bodyPr rtlCol="0" anchor="ctr"/>
-          <a:lstStyle/>
-          <a:p>
-            <a:pPr algn="ctr"/>
-          </a:p>
-        </p:txBody>
-      </p:sp>
-      <p:sp>
-        <p:nvSpPr>
-          <p:cNvPr id="14" name="TextBox 13"/>
-          <p:cNvSpPr txBox="1"/>
-          <p:nvPr/>
-        </p:nvSpPr>
-        <p:spPr>
-          <a:xfrm>
-            <a:off x="6720840" y="3337560"/>
-            <a:ext cx="4663440" cy="274320"/>
-          </a:xfrm>
-          <a:prstGeom prst="rect">
-            <a:avLst/>
-          </a:prstGeom>
-          <a:noFill/>
-        </p:spPr>
-        <p:txBody>
-          <a:bodyPr wrap="square" lIns="0" rIns="0" tIns="0" bIns="0" anchor="t">
-            <a:spAutoFit/>
-          </a:bodyPr>
-          <a:lstStyle/>
-          <a:p>
-            <a:pPr algn="l"/>
-            <a:r>
-              <a:rPr sz="1100" b="1" i="0">
-                <a:solidFill>
-                  <a:srgbClr val="EB6A35"/>
-                </a:solidFill>
-                <a:latin typeface="Calibri"/>
-              </a:rPr>
-              <a:t>A TREE</a:t>
-            </a:r>
-          </a:p>
-        </p:txBody>
-      </p:sp>
-      <p:sp>
-        <p:nvSpPr>
-          <p:cNvPr id="15" name="TextBox 14"/>
-          <p:cNvSpPr txBox="1"/>
-          <p:nvPr/>
-        </p:nvSpPr>
-        <p:spPr>
-          <a:xfrm>
-            <a:off x="6720840" y="3584448"/>
-            <a:ext cx="4663440" cy="365760"/>
-          </a:xfrm>
-          <a:prstGeom prst="rect">
-            <a:avLst/>
-          </a:prstGeom>
-          <a:noFill/>
-        </p:spPr>
-        <p:txBody>
-          <a:bodyPr wrap="square" lIns="0" rIns="0" tIns="0" bIns="0" anchor="t">
-            <a:spAutoFit/>
-          </a:bodyPr>
-          <a:lstStyle/>
-          <a:p>
-            <a:pPr algn="l"/>
-            <a:r>
-              <a:rPr sz="1500" b="1" i="0">
-                <a:solidFill>
-                  <a:srgbClr val="1F2433"/>
-                </a:solidFill>
-                <a:latin typeface="Calibri"/>
-              </a:rPr>
-              <a:t>Depth-3 tree, all 32 features</a:t>
-            </a:r>
-          </a:p>
-        </p:txBody>
-      </p:sp>
-      <p:sp>
-        <p:nvSpPr>
-          <p:cNvPr id="16" name="TextBox 15"/>
-          <p:cNvSpPr txBox="1"/>
-          <p:nvPr/>
-        </p:nvSpPr>
-        <p:spPr>
-          <a:xfrm>
-            <a:off x="6720840" y="3922776"/>
-            <a:ext cx="4663440" cy="548640"/>
-          </a:xfrm>
-          <a:prstGeom prst="rect">
-            <a:avLst/>
-          </a:prstGeom>
-          <a:noFill/>
-        </p:spPr>
-        <p:txBody>
-          <a:bodyPr wrap="square" lIns="0" rIns="0" tIns="0" bIns="0" anchor="t">
-            <a:spAutoFit/>
-          </a:bodyPr>
-          <a:lstStyle/>
-          <a:p>
-            <a:pPr algn="l"/>
-            <a:r>
-              <a:rPr sz="1300" b="0" i="0">
-                <a:solidFill>
-                  <a:srgbClr val="6B7280"/>
-                </a:solidFill>
-                <a:latin typeface="Calibri"/>
-              </a:rPr>
-              <a:t>Splits only on trailing vol, BTC/ETH vol, token age and 30d return</a:t>
-            </a:r>
-          </a:p>
-        </p:txBody>
-      </p:sp>
-      <p:sp>
-        <p:nvSpPr>
-          <p:cNvPr id="17" name="Interpretation card 2"/>
-          <p:cNvSpPr/>
-          <p:nvPr/>
-        </p:nvSpPr>
-        <p:spPr>
-          <a:xfrm>
-            <a:off x="6492240" y="4654296"/>
-            <a:ext cx="5120640" cy="1298448"/>
-          </a:xfrm>
-          <a:prstGeom prst="roundRect">
-            <a:avLst>
-              <a:gd name="adj" fmla="val 8000"/>
-            </a:avLst>
-          </a:prstGeom>
-          <a:solidFill>
-            <a:srgbClr val="F2F4F7"/>
-          </a:solidFill>
-          <a:ln>
-            <a:noFill/>
-          </a:ln>
-          <a:effectLst/>
-        </p:spPr>
-        <p:style>
-          <a:lnRef idx="1">
-            <a:schemeClr val="accent1"/>
-          </a:lnRef>
-          <a:fillRef idx="3">
-            <a:schemeClr val="accent1"/>
-          </a:fillRef>
-          <a:effectRef idx="2">
-            <a:schemeClr val="accent1"/>
-          </a:effectRef>
-          <a:fontRef idx="minor">
-            <a:schemeClr val="lt1"/>
-          </a:fontRef>
-        </p:style>
-        <p:txBody>
-          <a:bodyPr rtlCol="0" anchor="ctr"/>
-          <a:lstStyle/>
-          <a:p>
-            <a:pPr algn="ctr"/>
-          </a:p>
-        </p:txBody>
-      </p:sp>
-      <p:sp>
-        <p:nvSpPr>
-          <p:cNvPr id="18" name="TextBox 17"/>
-          <p:cNvSpPr txBox="1"/>
-          <p:nvPr/>
-        </p:nvSpPr>
-        <p:spPr>
-          <a:xfrm>
-            <a:off x="6720840" y="4818888"/>
-            <a:ext cx="4663440" cy="274320"/>
-          </a:xfrm>
-          <a:prstGeom prst="rect">
-            <a:avLst/>
-          </a:prstGeom>
-          <a:noFill/>
-        </p:spPr>
-        <p:txBody>
-          <a:bodyPr wrap="square" lIns="0" rIns="0" tIns="0" bIns="0" anchor="t">
-            <a:spAutoFit/>
-          </a:bodyPr>
-          <a:lstStyle/>
-          <a:p>
-            <a:pPr algn="l"/>
-            <a:r>
-              <a:rPr sz="1100" b="1" i="0">
-                <a:solidFill>
-                  <a:srgbClr val="EB6A35"/>
-                </a:solidFill>
-                <a:latin typeface="Calibri"/>
-              </a:rPr>
-              <a:t>NEIGHBOURS</a:t>
-            </a:r>
-          </a:p>
-        </p:txBody>
-      </p:sp>
-      <p:sp>
-        <p:nvSpPr>
-          <p:cNvPr id="19" name="TextBox 18"/>
-          <p:cNvSpPr txBox="1"/>
-          <p:nvPr/>
-        </p:nvSpPr>
-        <p:spPr>
-          <a:xfrm>
-            <a:off x="6720840" y="5065776"/>
-            <a:ext cx="4663440" cy="365760"/>
-          </a:xfrm>
-          <a:prstGeom prst="rect">
-            <a:avLst/>
-          </a:prstGeom>
-          <a:noFill/>
-        </p:spPr>
-        <p:txBody>
-          <a:bodyPr wrap="square" lIns="0" rIns="0" tIns="0" bIns="0" anchor="t">
-            <a:spAutoFit/>
-          </a:bodyPr>
-          <a:lstStyle/>
-          <a:p>
-            <a:pPr algn="l"/>
-            <a:r>
-              <a:rPr sz="1500" b="1" i="0">
-                <a:solidFill>
-                  <a:srgbClr val="1F2433"/>
-                </a:solidFill>
-                <a:latin typeface="Calibri"/>
-              </a:rPr>
-              <a:t>KNN, most unlock-heavy row</a:t>
-            </a:r>
-          </a:p>
-        </p:txBody>
-      </p:sp>
-      <p:sp>
-        <p:nvSpPr>
-          <p:cNvPr id="20" name="TextBox 19"/>
-          <p:cNvSpPr txBox="1"/>
-          <p:nvPr/>
-        </p:nvSpPr>
-        <p:spPr>
-          <a:xfrm>
-            <a:off x="6720840" y="5404104"/>
-            <a:ext cx="4663440" cy="548640"/>
-          </a:xfrm>
-          <a:prstGeom prst="rect">
-            <a:avLst/>
-          </a:prstGeom>
-          <a:noFill/>
-        </p:spPr>
-        <p:txBody>
-          <a:bodyPr wrap="square" lIns="0" rIns="0" tIns="0" bIns="0" anchor="t">
-            <a:spAutoFit/>
-          </a:bodyPr>
-          <a:lstStyle/>
-          <a:p>
-            <a:pPr algn="l"/>
-            <a:r>
-              <a:rPr sz="1300" b="0" i="0">
-                <a:solidFill>
-                  <a:srgbClr val="6B7280"/>
-                </a:solidFill>
-                <a:latin typeface="Calibri"/>
-              </a:rPr>
-              <a:t>104% of float unlocking; neighbours' median 12.5%. Forecast 0.78, realized 0.55</a:t>
-            </a:r>
-          </a:p>
-        </p:txBody>
-      </p:sp>
-    </p:spTree>
-  </p:cSld>
-  <p:clrMapOvr>
-    <a:masterClrMapping/>
-  </p:clrMapOvr>
-</p:sld>
-</file>
-
-<file path=ppt/slides/slide12.xml><?xml version="1.0" encoding="utf-8"?>
-<p:sld xmlns:a="http://schemas.openxmlformats.org/drawingml/2006/main" xmlns:p="http://schemas.openxmlformats.org/presentationml/2006/main" xmlns:r="http://schemas.openxmlformats.org/officeDocument/2006/relationships">
-  <p:cSld>
-    <p:bg>
-      <p:bgPr>
-        <a:solidFill>
-          <a:srgbClr val="FFFFFF"/>
-        </a:solidFill>
-        <a:effectLst/>
-      </p:bgPr>
-    </p:bg>
-    <p:spTree>
-      <p:nvGrpSpPr>
-        <p:cNvPr id="1" name=""/>
-        <p:cNvGrpSpPr/>
-        <p:nvPr/>
-      </p:nvGrpSpPr>
-      <p:grpSpPr/>
-      <p:sp>
-        <p:nvSpPr>
-          <p:cNvPr id="2" name="Kicker"/>
-          <p:cNvSpPr txBox="1"/>
-          <p:nvPr/>
-        </p:nvSpPr>
-        <p:spPr>
-          <a:xfrm>
-            <a:off x="548640" y="320040"/>
-            <a:ext cx="11064240" cy="274320"/>
-          </a:xfrm>
-          <a:prstGeom prst="rect">
-            <a:avLst/>
-          </a:prstGeom>
-          <a:noFill/>
-        </p:spPr>
-        <p:txBody>
-          <a:bodyPr wrap="square" lIns="0" rIns="0" tIns="0" bIns="0" anchor="t">
-            <a:spAutoFit/>
-          </a:bodyPr>
-          <a:lstStyle/>
-          <a:p>
-            <a:pPr algn="l"/>
-            <a:r>
-              <a:rPr sz="1200" b="1" i="0">
-                <a:solidFill>
-                  <a:srgbClr val="EB6A35"/>
-                </a:solidFill>
-                <a:latin typeface="Calibri"/>
-              </a:rPr>
-              <a:t>RESULT 3</a:t>
-            </a:r>
-          </a:p>
-        </p:txBody>
-      </p:sp>
-      <p:sp>
-        <p:nvSpPr>
-          <p:cNvPr id="3" name="Title"/>
-          <p:cNvSpPr txBox="1"/>
-          <p:nvPr/>
-        </p:nvSpPr>
-        <p:spPr>
-          <a:xfrm>
-            <a:off x="548640" y="594360"/>
-            <a:ext cx="11064240" cy="822960"/>
-          </a:xfrm>
-          <a:prstGeom prst="rect">
-            <a:avLst/>
-          </a:prstGeom>
-          <a:noFill/>
-        </p:spPr>
-        <p:txBody>
-          <a:bodyPr wrap="square" lIns="0" rIns="0" tIns="0" bIns="0" anchor="t">
-            <a:spAutoFit/>
-          </a:bodyPr>
-          <a:lstStyle/>
-          <a:p>
-            <a:pPr algn="l"/>
-            <a:r>
-              <a:rPr sz="3200" b="1" i="0">
-                <a:solidFill>
-                  <a:srgbClr val="1F2433"/>
-                </a:solidFill>
-                <a:latin typeface="Cambria"/>
-              </a:rPr>
-              <a:t>Classification view: unlock features slightly hurt</a:t>
-            </a:r>
-          </a:p>
-        </p:txBody>
-      </p:sp>
-      <p:sp>
-        <p:nvSpPr>
-          <p:cNvPr id="4" name="Footer"/>
-          <p:cNvSpPr txBox="1"/>
-          <p:nvPr/>
-        </p:nvSpPr>
-        <p:spPr>
-          <a:xfrm>
-            <a:off x="548640" y="6400800"/>
-            <a:ext cx="7315200" cy="274320"/>
-          </a:xfrm>
-          <a:prstGeom prst="rect">
-            <a:avLst/>
-          </a:prstGeom>
-          <a:noFill/>
-        </p:spPr>
-        <p:txBody>
-          <a:bodyPr wrap="square" lIns="0" rIns="0" tIns="0" bIns="0" anchor="t">
-            <a:spAutoFit/>
-          </a:bodyPr>
-          <a:lstStyle/>
-          <a:p>
-            <a:pPr algn="l"/>
-            <a:r>
-              <a:rPr sz="1000" b="0" i="0">
-                <a:solidFill>
-                  <a:srgbClr val="6B7280"/>
-                </a:solidFill>
-                <a:latin typeface="Calibri"/>
-              </a:rPr>
-              <a:t>MH6805 Group 7  |  Token unlocks and forward volatility</a:t>
-            </a:r>
-          </a:p>
-        </p:txBody>
-      </p:sp>
-      <p:sp>
-        <p:nvSpPr>
-          <p:cNvPr id="5" name="Slide number"/>
-          <p:cNvSpPr txBox="1"/>
-          <p:nvPr/>
-        </p:nvSpPr>
-        <p:spPr>
-          <a:xfrm>
-            <a:off x="10241280" y="6400800"/>
-            <a:ext cx="1399032" cy="274320"/>
-          </a:xfrm>
-          <a:prstGeom prst="rect">
-            <a:avLst/>
-          </a:prstGeom>
-          <a:noFill/>
-        </p:spPr>
-        <p:txBody>
-          <a:bodyPr wrap="square" lIns="0" rIns="0" tIns="0" bIns="0" anchor="t">
-            <a:spAutoFit/>
-          </a:bodyPr>
-          <a:lstStyle/>
-          <a:p>
-            <a:pPr algn="r"/>
-            <a:r>
-              <a:rPr sz="1000" b="0" i="0">
-                <a:solidFill>
-                  <a:srgbClr val="6B7280"/>
-                </a:solidFill>
-                <a:latin typeface="Calibri"/>
-              </a:rPr>
-              <a:t>12</a:t>
             </a:r>
           </a:p>
         </p:txBody>
@@ -7994,6 +7635,365 @@
                 <a:latin typeface="Calibri"/>
               </a:rPr>
               <a:t>PR-AUC and Brier skill fall too, on both panels. Unlock schedules do not help pick the most volatile tokens, nor anticipate a token's own volatility jump.</a:t>
+            </a:r>
+          </a:p>
+        </p:txBody>
+      </p:sp>
+    </p:spTree>
+  </p:cSld>
+  <p:clrMapOvr>
+    <a:masterClrMapping/>
+  </p:clrMapOvr>
+</p:sld>
+</file>
+
+<file path=ppt/slides/slide12.xml><?xml version="1.0" encoding="utf-8"?>
+<p:sld xmlns:a="http://schemas.openxmlformats.org/drawingml/2006/main" xmlns:p="http://schemas.openxmlformats.org/presentationml/2006/main" xmlns:r="http://schemas.openxmlformats.org/officeDocument/2006/relationships">
+  <p:cSld>
+    <p:bg>
+      <p:bgPr>
+        <a:solidFill>
+          <a:srgbClr val="FFFFFF"/>
+        </a:solidFill>
+        <a:effectLst/>
+      </p:bgPr>
+    </p:bg>
+    <p:spTree>
+      <p:nvGrpSpPr>
+        <p:cNvPr id="1" name=""/>
+        <p:cNvGrpSpPr/>
+        <p:nvPr/>
+      </p:nvGrpSpPr>
+      <p:grpSpPr/>
+      <p:sp>
+        <p:nvSpPr>
+          <p:cNvPr id="2" name="Kicker"/>
+          <p:cNvSpPr txBox="1"/>
+          <p:nvPr/>
+        </p:nvSpPr>
+        <p:spPr>
+          <a:xfrm>
+            <a:off x="548640" y="320040"/>
+            <a:ext cx="11064240" cy="274320"/>
+          </a:xfrm>
+          <a:prstGeom prst="rect">
+            <a:avLst/>
+          </a:prstGeom>
+          <a:noFill/>
+        </p:spPr>
+        <p:txBody>
+          <a:bodyPr wrap="square" lIns="0" rIns="0" tIns="0" bIns="0" anchor="t">
+            <a:spAutoFit/>
+          </a:bodyPr>
+          <a:lstStyle/>
+          <a:p>
+            <a:pPr algn="l"/>
+            <a:r>
+              <a:rPr sz="1200" b="1" i="0">
+                <a:solidFill>
+                  <a:srgbClr val="EB6A35"/>
+                </a:solidFill>
+                <a:latin typeface="Calibri"/>
+              </a:rPr>
+              <a:t>WHICH MISTAKES REMAIN?</a:t>
+            </a:r>
+          </a:p>
+        </p:txBody>
+      </p:sp>
+      <p:sp>
+        <p:nvSpPr>
+          <p:cNvPr id="3" name="Title"/>
+          <p:cNvSpPr txBox="1"/>
+          <p:nvPr/>
+        </p:nvSpPr>
+        <p:spPr>
+          <a:xfrm>
+            <a:off x="548640" y="594360"/>
+            <a:ext cx="11064240" cy="822960"/>
+          </a:xfrm>
+          <a:prstGeom prst="rect">
+            <a:avLst/>
+          </a:prstGeom>
+          <a:noFill/>
+        </p:spPr>
+        <p:txBody>
+          <a:bodyPr wrap="square" lIns="0" rIns="0" tIns="0" bIns="0" anchor="t">
+            <a:spAutoFit/>
+          </a:bodyPr>
+          <a:lstStyle/>
+          <a:p>
+            <a:pPr algn="l"/>
+            <a:r>
+              <a:rPr sz="3200" b="1" i="0">
+                <a:solidFill>
+                  <a:srgbClr val="1F2433"/>
+                </a:solidFill>
+                <a:latin typeface="Cambria"/>
+              </a:rPr>
+              <a:t>Unlock features do not help even where unlocks are big</a:t>
+            </a:r>
+          </a:p>
+        </p:txBody>
+      </p:sp>
+      <p:sp>
+        <p:nvSpPr>
+          <p:cNvPr id="4" name="Footer"/>
+          <p:cNvSpPr txBox="1"/>
+          <p:nvPr/>
+        </p:nvSpPr>
+        <p:spPr>
+          <a:xfrm>
+            <a:off x="548640" y="6400800"/>
+            <a:ext cx="7315200" cy="274320"/>
+          </a:xfrm>
+          <a:prstGeom prst="rect">
+            <a:avLst/>
+          </a:prstGeom>
+          <a:noFill/>
+        </p:spPr>
+        <p:txBody>
+          <a:bodyPr wrap="square" lIns="0" rIns="0" tIns="0" bIns="0" anchor="t">
+            <a:spAutoFit/>
+          </a:bodyPr>
+          <a:lstStyle/>
+          <a:p>
+            <a:pPr algn="l"/>
+            <a:r>
+              <a:rPr sz="1000" b="0" i="0">
+                <a:solidFill>
+                  <a:srgbClr val="6B7280"/>
+                </a:solidFill>
+                <a:latin typeface="Calibri"/>
+              </a:rPr>
+              <a:t>MH6805 Group 7  |  Token unlocks and forward volatility</a:t>
+            </a:r>
+          </a:p>
+        </p:txBody>
+      </p:sp>
+      <p:sp>
+        <p:nvSpPr>
+          <p:cNvPr id="5" name="Slide number"/>
+          <p:cNvSpPr txBox="1"/>
+          <p:nvPr/>
+        </p:nvSpPr>
+        <p:spPr>
+          <a:xfrm>
+            <a:off x="10241280" y="6400800"/>
+            <a:ext cx="1399032" cy="274320"/>
+          </a:xfrm>
+          <a:prstGeom prst="rect">
+            <a:avLst/>
+          </a:prstGeom>
+          <a:noFill/>
+        </p:spPr>
+        <p:txBody>
+          <a:bodyPr wrap="square" lIns="0" rIns="0" tIns="0" bIns="0" anchor="t">
+            <a:spAutoFit/>
+          </a:bodyPr>
+          <a:lstStyle/>
+          <a:p>
+            <a:pPr algn="r"/>
+            <a:r>
+              <a:rPr sz="1000" b="0" i="0">
+                <a:solidFill>
+                  <a:srgbClr val="6B7280"/>
+                </a:solidFill>
+                <a:latin typeface="Calibri"/>
+              </a:rPr>
+              <a:t>12</a:t>
+            </a:r>
+          </a:p>
+        </p:txBody>
+      </p:sp>
+      <p:graphicFrame>
+        <p:nvGraphicFramePr>
+          <p:cNvPr id="6" name="Chart 5"/>
+          <p:cNvGraphicFramePr>
+            <a:graphicFrameLocks noGrp="1"/>
+          </p:cNvGraphicFramePr>
+          <p:nvPr/>
+        </p:nvGraphicFramePr>
+        <p:xfrm>
+          <a:off x="548640" y="2011680"/>
+          <a:ext cx="7589520" cy="4160520"/>
+        </p:xfrm>
+        <a:graphic>
+          <a:graphicData uri="http://schemas.openxmlformats.org/drawingml/2006/chart">
+            <c:chart xmlns:c="http://schemas.openxmlformats.org/drawingml/2006/chart" r:id="rId3"/>
+          </a:graphicData>
+        </a:graphic>
+      </p:graphicFrame>
+      <p:sp>
+        <p:nvSpPr>
+          <p:cNvPr id="7" name="TextBox 6"/>
+          <p:cNvSpPr txBox="1"/>
+          <p:nvPr/>
+        </p:nvSpPr>
+        <p:spPr>
+          <a:xfrm>
+            <a:off x="548640" y="1645920"/>
+            <a:ext cx="7589520" cy="365760"/>
+          </a:xfrm>
+          <a:prstGeom prst="rect">
+            <a:avLst/>
+          </a:prstGeom>
+          <a:noFill/>
+        </p:spPr>
+        <p:txBody>
+          <a:bodyPr wrap="square" lIns="0" rIns="0" tIns="0" bIns="0" anchor="t">
+            <a:spAutoFit/>
+          </a:bodyPr>
+          <a:lstStyle/>
+          <a:p>
+            <a:pPr algn="l"/>
+            <a:r>
+              <a:rPr sz="1400" b="1" i="0">
+                <a:solidFill>
+                  <a:srgbClr val="1F2433"/>
+                </a:solidFill>
+                <a:latin typeface="Calibri"/>
+              </a:rPr>
+              <a:t>Change in test RMSE from adding unlock features (positive = worse), by 30-day unlock share of float</a:t>
+            </a:r>
+          </a:p>
+        </p:txBody>
+      </p:sp>
+      <p:sp>
+        <p:nvSpPr>
+          <p:cNvPr id="8" name="TextBox 7"/>
+          <p:cNvSpPr txBox="1"/>
+          <p:nvPr/>
+        </p:nvSpPr>
+        <p:spPr>
+          <a:xfrm>
+            <a:off x="8503920" y="1737360"/>
+            <a:ext cx="3200400" cy="640080"/>
+          </a:xfrm>
+          <a:prstGeom prst="rect">
+            <a:avLst/>
+          </a:prstGeom>
+          <a:noFill/>
+        </p:spPr>
+        <p:txBody>
+          <a:bodyPr wrap="square" lIns="0" rIns="0" tIns="0" bIns="0" anchor="t">
+            <a:spAutoFit/>
+          </a:bodyPr>
+          <a:lstStyle/>
+          <a:p>
+            <a:pPr algn="l"/>
+            <a:r>
+              <a:rPr sz="3200" b="1" i="0">
+                <a:solidFill>
+                  <a:srgbClr val="141B2D"/>
+                </a:solidFill>
+                <a:latin typeface="Cambria"/>
+              </a:rPr>
+              <a:t>18% → 12%</a:t>
+            </a:r>
+          </a:p>
+        </p:txBody>
+      </p:sp>
+      <p:sp>
+        <p:nvSpPr>
+          <p:cNvPr id="9" name="TextBox 8"/>
+          <p:cNvSpPr txBox="1"/>
+          <p:nvPr/>
+        </p:nvSpPr>
+        <p:spPr>
+          <a:xfrm>
+            <a:off x="8503920" y="2423160"/>
+            <a:ext cx="3108960" cy="1097280"/>
+          </a:xfrm>
+          <a:prstGeom prst="rect">
+            <a:avLst/>
+          </a:prstGeom>
+          <a:noFill/>
+        </p:spPr>
+        <p:txBody>
+          <a:bodyPr wrap="square" lIns="0" rIns="0" tIns="0" bIns="0" anchor="t">
+            <a:spAutoFit/>
+          </a:bodyPr>
+          <a:lstStyle/>
+          <a:p>
+            <a:pPr algn="l"/>
+            <a:r>
+              <a:rPr sz="1500" b="0" i="0">
+                <a:solidFill>
+                  <a:srgbClr val="6B7280"/>
+                </a:solidFill>
+                <a:latin typeface="Calibri"/>
+              </a:rPr>
+              <a:t>forecasts off by more than 2×: persistence vs Ridge. The real gain is fewer large misses</a:t>
+            </a:r>
+          </a:p>
+        </p:txBody>
+      </p:sp>
+      <p:sp>
+        <p:nvSpPr>
+          <p:cNvPr id="10" name="TextBox 9"/>
+          <p:cNvSpPr txBox="1"/>
+          <p:nvPr/>
+        </p:nvSpPr>
+        <p:spPr>
+          <a:xfrm>
+            <a:off x="8503920" y="3886200"/>
+            <a:ext cx="3200400" cy="640080"/>
+          </a:xfrm>
+          <a:prstGeom prst="rect">
+            <a:avLst/>
+          </a:prstGeom>
+          <a:noFill/>
+        </p:spPr>
+        <p:txBody>
+          <a:bodyPr wrap="square" lIns="0" rIns="0" tIns="0" bIns="0" anchor="t">
+            <a:spAutoFit/>
+          </a:bodyPr>
+          <a:lstStyle/>
+          <a:p>
+            <a:pPr algn="l"/>
+            <a:r>
+              <a:rPr sz="3200" b="1" i="0">
+                <a:solidFill>
+                  <a:srgbClr val="EB6A35"/>
+                </a:solidFill>
+                <a:latin typeface="Cambria"/>
+              </a:rPr>
+              <a:t>62%</a:t>
+            </a:r>
+          </a:p>
+        </p:txBody>
+      </p:sp>
+      <p:sp>
+        <p:nvSpPr>
+          <p:cNvPr id="11" name="TextBox 10"/>
+          <p:cNvSpPr txBox="1"/>
+          <p:nvPr/>
+        </p:nvSpPr>
+        <p:spPr>
+          <a:xfrm>
+            <a:off x="8503920" y="4572000"/>
+            <a:ext cx="3108960" cy="1097280"/>
+          </a:xfrm>
+          <a:prstGeom prst="rect">
+            <a:avLst/>
+          </a:prstGeom>
+          <a:noFill/>
+        </p:spPr>
+        <p:txBody>
+          <a:bodyPr wrap="square" lIns="0" rIns="0" tIns="0" bIns="0" anchor="t">
+            <a:spAutoFit/>
+          </a:bodyPr>
+          <a:lstStyle/>
+          <a:p>
+            <a:pPr algn="l"/>
+            <a:r>
+              <a:rPr sz="1500" b="0" i="0">
+                <a:solidFill>
+                  <a:srgbClr val="6B7280"/>
+                </a:solidFill>
+                <a:latin typeface="Calibri"/>
+              </a:rPr>
+              <a:t>of remaining 2× misses are over-forecasts: volatility collapsed. The rest are spikes no feature sees</a:t>
             </a:r>
           </a:p>
         </p:txBody>

</xml_diff>

<commit_message>
Cut the deck to 12 slides for the 8-minute slot
Motivation folds into the question-and-design slide, the dataset into the
first-look slide, the classification result into the robustness slide, and
limitations plus questions into the conclusion. Each member now presents four
slides (1-4, 5-8, 9-12); renumbered slides and hand-over notes follow.
FULL_DECK=1 still builds all 17 slides as a Q&A backup. WORK_SPLIT.md
updated: the logistic section moves to Member 3 with its slide, and the
references and final formatting pass move to Member 1 to keep the review
load even.
</commit_message>
<xml_diff>
--- a/report/Group7_Presentation_DRAFT.pptx
+++ b/report/Group7_Presentation_DRAFT.pptx
@@ -6,22 +6,17 @@
   </p:sldMasterIdLst>
   <p:sldIdLst>
     <p:sldId id="256" r:id="rId7"/>
-    <p:sldId id="257" r:id="rId9"/>
     <p:sldId id="258" r:id="rId10"/>
-    <p:sldId id="259" r:id="rId11"/>
     <p:sldId id="260" r:id="rId12"/>
     <p:sldId id="261" r:id="rId13"/>
     <p:sldId id="262" r:id="rId14"/>
     <p:sldId id="263" r:id="rId15"/>
     <p:sldId id="264" r:id="rId16"/>
     <p:sldId id="265" r:id="rId17"/>
-    <p:sldId id="266" r:id="rId18"/>
     <p:sldId id="267" r:id="rId19"/>
     <p:sldId id="268" r:id="rId20"/>
     <p:sldId id="269" r:id="rId21"/>
     <p:sldId id="270" r:id="rId22"/>
-    <p:sldId id="271" r:id="rId23"/>
-    <p:sldId id="272" r:id="rId24"/>
   </p:sldIdLst>
   <p:sldSz cx="12191695" cy="6858000" type="screen4x3"/>
   <p:notesSz cx="6858000" cy="9144000"/>
@@ -1879,83 +1874,7 @@
           <a:p/>
           <a:p>
             <a:r>
-              <a:t>We explain each model with the tool that suits it. Random Forest permutation importance: shuffling all controls costs three times more test RMSE than shuffling all 13 emission features, and partial dependence on unlock pressure is flat. Coefficients: the largest unlock coefficient is positive, as the narrative says, but five times smaller than trailing volatility, and Elastic Net drops everything in two folds. A shallow tree never splits on an unlock feature. Neighbours: for the most unlock-heavy token-day there is no comparable history, so KNN falls back on trailing volatility.</a:t>
-            </a:r>
-          </a:p>
-        </p:txBody>
-      </p:sp>
-      <p:sp>
-        <p:nvSpPr>
-          <p:cNvPr id="4" name="Slide Number Placeholder 3"/>
-          <p:cNvSpPr>
-            <a:spLocks noGrp="1"/>
-          </p:cNvSpPr>
-          <p:nvPr>
-            <p:ph type="sldNum" idx="5" sz="quarter"/>
-          </p:nvPr>
-        </p:nvSpPr>
-        <p:spPr/>
-      </p:sp>
-    </p:spTree>
-  </p:cSld>
-  <p:clrMapOvr>
-    <a:masterClrMapping/>
-  </p:clrMapOvr>
-</p:notes>
-</file>
-
-<file path=ppt/notesSlides/notesSlide11.xml><?xml version="1.0" encoding="utf-8"?>
-<p:notes xmlns:a="http://schemas.openxmlformats.org/drawingml/2006/main" xmlns:p="http://schemas.openxmlformats.org/presentationml/2006/main" xmlns:r="http://schemas.openxmlformats.org/officeDocument/2006/relationships">
-  <p:cSld>
-    <p:spTree>
-      <p:nvGrpSpPr>
-        <p:cNvPr id="1" name=""/>
-        <p:cNvGrpSpPr/>
-        <p:nvPr/>
-      </p:nvGrpSpPr>
-      <p:grpSpPr>
-        <a:xfrm>
-          <a:off x="0" y="0"/>
-          <a:ext cx="0" cy="0"/>
-          <a:chOff x="0" y="0"/>
-          <a:chExt cx="0" cy="0"/>
-        </a:xfrm>
-      </p:grpSpPr>
-      <p:sp>
-        <p:nvSpPr>
-          <p:cNvPr id="2" name="Slide Image Placeholder 1"/>
-          <p:cNvSpPr>
-            <a:spLocks noGrp="1"/>
-          </p:cNvSpPr>
-          <p:nvPr>
-            <p:ph type="sldImg" idx="2"/>
-          </p:nvPr>
-        </p:nvSpPr>
-        <p:spPr/>
-      </p:sp>
-      <p:sp>
-        <p:nvSpPr>
-          <p:cNvPr id="3" name="Notes Placeholder 2"/>
-          <p:cNvSpPr>
-            <a:spLocks noGrp="1"/>
-          </p:cNvSpPr>
-          <p:nvPr>
-            <p:ph type="body" idx="3" sz="quarter"/>
-          </p:nvPr>
-        </p:nvSpPr>
-        <p:spPr/>
-        <p:txBody>
-          <a:bodyPr/>
-          <a:lstStyle/>
-          <a:p>
-            <a:r>
-              <a:t>Speaker: [Member 2]</a:t>
-            </a:r>
-          </a:p>
-          <a:p/>
-          <a:p>
-            <a:r>
-              <a:t>Same question as classification. The model on controls does pick out high-volatility tokens better than just ranking by recent volatility, AUC 0.69 against 0.65. Adding unlock features lowers AUC, PR-AUC and the Brier skill score for both events, on both panels. Hand over: on average the answer is no; [Member 3] shows where the remaining errors are and whether any of this matters in practice.</a:t>
+              <a:t>We explain each model with the tool that suits it. Random Forest permutation importance: shuffling all controls costs three times more test RMSE than shuffling all 13 emission features, and partial dependence on unlock pressure is flat. Coefficients: the largest unlock coefficient is positive, as the narrative says, but five times smaller than trailing volatility, and Elastic Net drops everything in two folds. A shallow tree never splits on an unlock feature. Neighbours: for the most unlock-heavy token-day there is no comparable history, so KNN falls back on trailing volatility. Hand over: on average the answer is no; [Member 3] shows where the remaining errors are and whether any of this matters in practice.</a:t>
             </a:r>
           </a:p>
         </p:txBody>
@@ -2107,7 +2026,7 @@
           <a:p/>
           <a:p>
             <a:r>
-              <a:t>We re-ran the comparison on the weekly panel, on three alternative volatility targets and on the tokens Tokenomist curates by hand, where schedules should be most accurate. The largest gain anywhere is +0.017, for the Random Forest on the curated subsample, still about a tenth of the fold-to-fold spread. Ridge on the Parkinson target is the only case that wins all five folds, by 0.011. LightGBM shows the same picture, and on the small weekly panel it falls just below the training mean.</a:t>
+              <a:t>We re-ran the comparison on the weekly panel, on three alternative volatility targets and on the tokens Tokenomist curates by hand, where schedules should be most accurate. The largest gain anywhere is +0.017, for the Random Forest on the curated subsample, still about a tenth of the fold-to-fold spread. Ridge on the Parkinson target is the only case that wins all five folds, by 0.011. LightGBM shows the same picture, and on the small weekly panel it falls just below the training mean. Classification tells the same story: logistic regression on controls beats ranking by recent volatility (AUC 0.69 vs 0.65), and adding unlock features lowers AUC for both high-volatility events.</a:t>
             </a:r>
           </a:p>
         </p:txBody>
@@ -2259,229 +2178,7 @@
           <a:p/>
           <a:p>
             <a:r>
-              <a:t>State the answer plainly: once you know a token's recent volatility and the market regime, its unlock calendar does not help forecast the next two weeks. Give the interpretation: the unconditional correlation comes from young, volatile tokens having big unlocks. Practical takeaway: do not bump a volatility forecast just because an unlock is coming.</a:t>
-            </a:r>
-          </a:p>
-        </p:txBody>
-      </p:sp>
-      <p:sp>
-        <p:nvSpPr>
-          <p:cNvPr id="4" name="Slide Number Placeholder 3"/>
-          <p:cNvSpPr>
-            <a:spLocks noGrp="1"/>
-          </p:cNvSpPr>
-          <p:nvPr>
-            <p:ph type="sldNum" idx="5" sz="quarter"/>
-          </p:nvPr>
-        </p:nvSpPr>
-        <p:spPr/>
-      </p:sp>
-    </p:spTree>
-  </p:cSld>
-  <p:clrMapOvr>
-    <a:masterClrMapping/>
-  </p:clrMapOvr>
-</p:notes>
-</file>
-
-<file path=ppt/notesSlides/notesSlide16.xml><?xml version="1.0" encoding="utf-8"?>
-<p:notes xmlns:a="http://schemas.openxmlformats.org/drawingml/2006/main" xmlns:p="http://schemas.openxmlformats.org/presentationml/2006/main" xmlns:r="http://schemas.openxmlformats.org/officeDocument/2006/relationships">
-  <p:cSld>
-    <p:spTree>
-      <p:nvGrpSpPr>
-        <p:cNvPr id="1" name=""/>
-        <p:cNvGrpSpPr/>
-        <p:nvPr/>
-      </p:nvGrpSpPr>
-      <p:grpSpPr>
-        <a:xfrm>
-          <a:off x="0" y="0"/>
-          <a:ext cx="0" cy="0"/>
-          <a:chOff x="0" y="0"/>
-          <a:chExt cx="0" cy="0"/>
-        </a:xfrm>
-      </p:grpSpPr>
-      <p:sp>
-        <p:nvSpPr>
-          <p:cNvPr id="2" name="Slide Image Placeholder 1"/>
-          <p:cNvSpPr>
-            <a:spLocks noGrp="1"/>
-          </p:cNvSpPr>
-          <p:nvPr>
-            <p:ph type="sldImg" idx="2"/>
-          </p:nvPr>
-        </p:nvSpPr>
-        <p:spPr/>
-      </p:sp>
-      <p:sp>
-        <p:nvSpPr>
-          <p:cNvPr id="3" name="Notes Placeholder 2"/>
-          <p:cNvSpPr>
-            <a:spLocks noGrp="1"/>
-          </p:cNvSpPr>
-          <p:nvPr>
-            <p:ph type="body" idx="3" sz="quarter"/>
-          </p:nvPr>
-        </p:nvSpPr>
-        <p:spPr/>
-        <p:txBody>
-          <a:bodyPr/>
-          <a:lstStyle/>
-          <a:p>
-            <a:r>
-              <a:t>Speaker: [Member 3]</a:t>
-            </a:r>
-          </a:p>
-          <a:p/>
-          <a:p>
-            <a:r>
-              <a:t>Be upfront: one regime, and schedule revisions are back-filled, which if anything flatters the unlock features and so makes our null stronger. The natural next study is an event study around the largest cliff unlocks with intraday data, where an effect, if any, would be concentrated.</a:t>
-            </a:r>
-          </a:p>
-        </p:txBody>
-      </p:sp>
-      <p:sp>
-        <p:nvSpPr>
-          <p:cNvPr id="4" name="Slide Number Placeholder 3"/>
-          <p:cNvSpPr>
-            <a:spLocks noGrp="1"/>
-          </p:cNvSpPr>
-          <p:nvPr>
-            <p:ph type="sldNum" idx="5" sz="quarter"/>
-          </p:nvPr>
-        </p:nvSpPr>
-        <p:spPr/>
-      </p:sp>
-    </p:spTree>
-  </p:cSld>
-  <p:clrMapOvr>
-    <a:masterClrMapping/>
-  </p:clrMapOvr>
-</p:notes>
-</file>
-
-<file path=ppt/notesSlides/notesSlide17.xml><?xml version="1.0" encoding="utf-8"?>
-<p:notes xmlns:a="http://schemas.openxmlformats.org/drawingml/2006/main" xmlns:p="http://schemas.openxmlformats.org/presentationml/2006/main" xmlns:r="http://schemas.openxmlformats.org/officeDocument/2006/relationships">
-  <p:cSld>
-    <p:spTree>
-      <p:nvGrpSpPr>
-        <p:cNvPr id="1" name=""/>
-        <p:cNvGrpSpPr/>
-        <p:nvPr/>
-      </p:nvGrpSpPr>
-      <p:grpSpPr>
-        <a:xfrm>
-          <a:off x="0" y="0"/>
-          <a:ext cx="0" cy="0"/>
-          <a:chOff x="0" y="0"/>
-          <a:chExt cx="0" cy="0"/>
-        </a:xfrm>
-      </p:grpSpPr>
-      <p:sp>
-        <p:nvSpPr>
-          <p:cNvPr id="2" name="Slide Image Placeholder 1"/>
-          <p:cNvSpPr>
-            <a:spLocks noGrp="1"/>
-          </p:cNvSpPr>
-          <p:nvPr>
-            <p:ph type="sldImg" idx="2"/>
-          </p:nvPr>
-        </p:nvSpPr>
-        <p:spPr/>
-      </p:sp>
-      <p:sp>
-        <p:nvSpPr>
-          <p:cNvPr id="3" name="Notes Placeholder 2"/>
-          <p:cNvSpPr>
-            <a:spLocks noGrp="1"/>
-          </p:cNvSpPr>
-          <p:nvPr>
-            <p:ph type="body" idx="3" sz="quarter"/>
-          </p:nvPr>
-        </p:nvSpPr>
-        <p:spPr/>
-        <p:txBody>
-          <a:bodyPr/>
-          <a:lstStyle/>
-          <a:p>
-            <a:r>
-              <a:t>All members: take questions. Each member should be ready to answer on the model they built.</a:t>
-            </a:r>
-          </a:p>
-        </p:txBody>
-      </p:sp>
-      <p:sp>
-        <p:nvSpPr>
-          <p:cNvPr id="4" name="Slide Number Placeholder 3"/>
-          <p:cNvSpPr>
-            <a:spLocks noGrp="1"/>
-          </p:cNvSpPr>
-          <p:nvPr>
-            <p:ph type="sldNum" idx="5" sz="quarter"/>
-          </p:nvPr>
-        </p:nvSpPr>
-        <p:spPr/>
-      </p:sp>
-    </p:spTree>
-  </p:cSld>
-  <p:clrMapOvr>
-    <a:masterClrMapping/>
-  </p:clrMapOvr>
-</p:notes>
-</file>
-
-<file path=ppt/notesSlides/notesSlide2.xml><?xml version="1.0" encoding="utf-8"?>
-<p:notes xmlns:a="http://schemas.openxmlformats.org/drawingml/2006/main" xmlns:p="http://schemas.openxmlformats.org/presentationml/2006/main" xmlns:r="http://schemas.openxmlformats.org/officeDocument/2006/relationships">
-  <p:cSld>
-    <p:spTree>
-      <p:nvGrpSpPr>
-        <p:cNvPr id="1" name=""/>
-        <p:cNvGrpSpPr/>
-        <p:nvPr/>
-      </p:nvGrpSpPr>
-      <p:grpSpPr>
-        <a:xfrm>
-          <a:off x="0" y="0"/>
-          <a:ext cx="0" cy="0"/>
-          <a:chOff x="0" y="0"/>
-          <a:chExt cx="0" cy="0"/>
-        </a:xfrm>
-      </p:grpSpPr>
-      <p:sp>
-        <p:nvSpPr>
-          <p:cNvPr id="2" name="Slide Image Placeholder 1"/>
-          <p:cNvSpPr>
-            <a:spLocks noGrp="1"/>
-          </p:cNvSpPr>
-          <p:nvPr>
-            <p:ph type="sldImg" idx="2"/>
-          </p:nvPr>
-        </p:nvSpPr>
-        <p:spPr/>
-      </p:sp>
-      <p:sp>
-        <p:nvSpPr>
-          <p:cNvPr id="3" name="Notes Placeholder 2"/>
-          <p:cNvSpPr>
-            <a:spLocks noGrp="1"/>
-          </p:cNvSpPr>
-          <p:nvPr>
-            <p:ph type="body" idx="3" sz="quarter"/>
-          </p:nvPr>
-        </p:nvSpPr>
-        <p:spPr/>
-        <p:txBody>
-          <a:bodyPr/>
-          <a:lstStyle/>
-          <a:p>
-            <a:r>
-              <a:t>Speaker: [Member 1]</a:t>
-            </a:r>
-          </a:p>
-          <a:p/>
-          <a:p>
-            <a:r>
-              <a:t>Explain vesting: most of a token's supply is locked at launch and released on a published schedule. The market narrative is that unlocks bring new sellers and so more volatility. Because the schedule is public in advance it is a legitimate forward-looking input, which is rare in forecasting. But volatility is very persistent, so any new feature has a high bar to clear.</a:t>
+              <a:t>State the answer plainly: once you know a token's recent volatility and the market regime, its unlock calendar does not help forecast the next two weeks. Give the interpretation: the unconditional correlation comes from young, volatile tokens having big unlocks. Practical takeaway: do not bump a volatility forecast just because an unlock is coming. Limitations in one breath: one calm-to-moderate regime, and back-filled schedule revisions, which can only flatter the unlock features. Then invite questions; each member takes questions on their own block.</a:t>
             </a:r>
           </a:p>
         </p:txBody>
@@ -2557,83 +2254,7 @@
           <a:p/>
           <a:p>
             <a:r>
-              <a:t>Every model is trained twice with the same rows, folds and tuning grid: once on the nine controls and once with the 23 unlock and static features added. The difference in out-of-sample R squared is the finding. We decided up front that a null result is a valid result and we did not tune to change it.</a:t>
-            </a:r>
-          </a:p>
-        </p:txBody>
-      </p:sp>
-      <p:sp>
-        <p:nvSpPr>
-          <p:cNvPr id="4" name="Slide Number Placeholder 3"/>
-          <p:cNvSpPr>
-            <a:spLocks noGrp="1"/>
-          </p:cNvSpPr>
-          <p:nvPr>
-            <p:ph type="sldNum" idx="5" sz="quarter"/>
-          </p:nvPr>
-        </p:nvSpPr>
-        <p:spPr/>
-      </p:sp>
-    </p:spTree>
-  </p:cSld>
-  <p:clrMapOvr>
-    <a:masterClrMapping/>
-  </p:clrMapOvr>
-</p:notes>
-</file>
-
-<file path=ppt/notesSlides/notesSlide4.xml><?xml version="1.0" encoding="utf-8"?>
-<p:notes xmlns:a="http://schemas.openxmlformats.org/drawingml/2006/main" xmlns:p="http://schemas.openxmlformats.org/presentationml/2006/main" xmlns:r="http://schemas.openxmlformats.org/officeDocument/2006/relationships">
-  <p:cSld>
-    <p:spTree>
-      <p:nvGrpSpPr>
-        <p:cNvPr id="1" name=""/>
-        <p:cNvGrpSpPr/>
-        <p:nvPr/>
-      </p:nvGrpSpPr>
-      <p:grpSpPr>
-        <a:xfrm>
-          <a:off x="0" y="0"/>
-          <a:ext cx="0" cy="0"/>
-          <a:chOff x="0" y="0"/>
-          <a:chExt cx="0" cy="0"/>
-        </a:xfrm>
-      </p:grpSpPr>
-      <p:sp>
-        <p:nvSpPr>
-          <p:cNvPr id="2" name="Slide Image Placeholder 1"/>
-          <p:cNvSpPr>
-            <a:spLocks noGrp="1"/>
-          </p:cNvSpPr>
-          <p:nvPr>
-            <p:ph type="sldImg" idx="2"/>
-          </p:nvPr>
-        </p:nvSpPr>
-        <p:spPr/>
-      </p:sp>
-      <p:sp>
-        <p:nvSpPr>
-          <p:cNvPr id="3" name="Notes Placeholder 2"/>
-          <p:cNvSpPr>
-            <a:spLocks noGrp="1"/>
-          </p:cNvSpPr>
-          <p:nvPr>
-            <p:ph type="body" idx="3" sz="quarter"/>
-          </p:nvPr>
-        </p:nvSpPr>
-        <p:spPr/>
-        <p:txBody>
-          <a:bodyPr/>
-          <a:lstStyle/>
-          <a:p>
-            <a:r>
-              <a:t>Speaker: [Member 1]</a:t>
-            </a:r>
-          </a:p>
-          <a:p/>
-          <a:p>
-            <a:r>
-              <a:t>Two real sources: Binance daily candles for prices and Tokenomist for unlock schedules and allocations. One row per token per day from September 2024 to August 2026. Every feature is known at the close of the day; the only forward-looking inputs are the published schedule columns. One caveat: schedules are the version curated on our pull date, so later revisions are back-filled.</a:t>
+              <a:t>Motivation: most token supply is locked at launch and released on a published schedule, and traders treat big unlocks as volatility events. The schedule is public in advance, so it is a legitimate forward-looking input, but volatility is very persistent, so the bar is high. Design: every model is trained twice with the same rows, folds and tuning grid: once on the nine controls and once with the 23 unlock and static features added. The difference in out-of-sample R squared is the finding. We decided up front that a null result is a valid result and we did not tune to change it.</a:t>
             </a:r>
           </a:p>
         </p:txBody>
@@ -2709,7 +2330,7 @@
           <a:p/>
           <a:p>
             <a:r>
-              <a:t>This is the hook: unconditionally, there is a relationship. Forward volatility climbs from about 0.97 in the lowest unlock decile to 1.14 in the highest, and the correlation is positive for three quarters of tokens. But heavy-unlock tokens are young, small and already volatile, so the question is whether this survives once trailing volatility is in the model.</a:t>
+              <a:t>Data first: 176 tokens, one row per token per day from September 2024 to August 2026, prices from Binance and unlock schedules from Tokenomist; every feature is known at the close of the day. Then the hook: unconditionally, there is a relationship. Forward volatility climbs from about 0.97 in the lowest unlock decile to 1.14 in the highest, and the correlation is positive for three quarters of tokens. But heavy-unlock tokens are young, small and already volatile, so the question is whether this survives once trailing volatility is in the model.</a:t>
             </a:r>
           </a:p>
         </p:txBody>
@@ -6363,7 +5984,7 @@
                 </a:solidFill>
                 <a:latin typeface="Calibri"/>
               </a:rPr>
-              <a:t>10</a:t>
+              <a:t>8</a:t>
             </a:r>
           </a:p>
         </p:txBody>
@@ -6905,736 +6526,6 @@
                 <a:latin typeface="Calibri"/>
               </a:rPr>
               <a:t>104% of float unlocking; neighbours' median 12.5%. Forecast 0.78, realized 0.55</a:t>
-            </a:r>
-          </a:p>
-        </p:txBody>
-      </p:sp>
-    </p:spTree>
-  </p:cSld>
-  <p:clrMapOvr>
-    <a:masterClrMapping/>
-  </p:clrMapOvr>
-</p:sld>
-</file>
-
-<file path=ppt/slides/slide11.xml><?xml version="1.0" encoding="utf-8"?>
-<p:sld xmlns:a="http://schemas.openxmlformats.org/drawingml/2006/main" xmlns:p="http://schemas.openxmlformats.org/presentationml/2006/main" xmlns:r="http://schemas.openxmlformats.org/officeDocument/2006/relationships">
-  <p:cSld>
-    <p:bg>
-      <p:bgPr>
-        <a:solidFill>
-          <a:srgbClr val="FFFFFF"/>
-        </a:solidFill>
-        <a:effectLst/>
-      </p:bgPr>
-    </p:bg>
-    <p:spTree>
-      <p:nvGrpSpPr>
-        <p:cNvPr id="1" name=""/>
-        <p:cNvGrpSpPr/>
-        <p:nvPr/>
-      </p:nvGrpSpPr>
-      <p:grpSpPr/>
-      <p:sp>
-        <p:nvSpPr>
-          <p:cNvPr id="2" name="Kicker"/>
-          <p:cNvSpPr txBox="1"/>
-          <p:nvPr/>
-        </p:nvSpPr>
-        <p:spPr>
-          <a:xfrm>
-            <a:off x="548640" y="320040"/>
-            <a:ext cx="11064240" cy="274320"/>
-          </a:xfrm>
-          <a:prstGeom prst="rect">
-            <a:avLst/>
-          </a:prstGeom>
-          <a:noFill/>
-        </p:spPr>
-        <p:txBody>
-          <a:bodyPr wrap="square" lIns="0" rIns="0" tIns="0" bIns="0" anchor="t">
-            <a:spAutoFit/>
-          </a:bodyPr>
-          <a:lstStyle/>
-          <a:p>
-            <a:pPr algn="l"/>
-            <a:r>
-              <a:rPr sz="1200" b="1" i="0">
-                <a:solidFill>
-                  <a:srgbClr val="EB6A35"/>
-                </a:solidFill>
-                <a:latin typeface="Calibri"/>
-              </a:rPr>
-              <a:t>RESULT 3</a:t>
-            </a:r>
-          </a:p>
-        </p:txBody>
-      </p:sp>
-      <p:sp>
-        <p:nvSpPr>
-          <p:cNvPr id="3" name="Title"/>
-          <p:cNvSpPr txBox="1"/>
-          <p:nvPr/>
-        </p:nvSpPr>
-        <p:spPr>
-          <a:xfrm>
-            <a:off x="548640" y="594360"/>
-            <a:ext cx="11064240" cy="822960"/>
-          </a:xfrm>
-          <a:prstGeom prst="rect">
-            <a:avLst/>
-          </a:prstGeom>
-          <a:noFill/>
-        </p:spPr>
-        <p:txBody>
-          <a:bodyPr wrap="square" lIns="0" rIns="0" tIns="0" bIns="0" anchor="t">
-            <a:spAutoFit/>
-          </a:bodyPr>
-          <a:lstStyle/>
-          <a:p>
-            <a:pPr algn="l"/>
-            <a:r>
-              <a:rPr sz="3200" b="1" i="0">
-                <a:solidFill>
-                  <a:srgbClr val="1F2433"/>
-                </a:solidFill>
-                <a:latin typeface="Cambria"/>
-              </a:rPr>
-              <a:t>Classification view: unlock features slightly hurt</a:t>
-            </a:r>
-          </a:p>
-        </p:txBody>
-      </p:sp>
-      <p:sp>
-        <p:nvSpPr>
-          <p:cNvPr id="4" name="Footer"/>
-          <p:cNvSpPr txBox="1"/>
-          <p:nvPr/>
-        </p:nvSpPr>
-        <p:spPr>
-          <a:xfrm>
-            <a:off x="548640" y="6400800"/>
-            <a:ext cx="7315200" cy="274320"/>
-          </a:xfrm>
-          <a:prstGeom prst="rect">
-            <a:avLst/>
-          </a:prstGeom>
-          <a:noFill/>
-        </p:spPr>
-        <p:txBody>
-          <a:bodyPr wrap="square" lIns="0" rIns="0" tIns="0" bIns="0" anchor="t">
-            <a:spAutoFit/>
-          </a:bodyPr>
-          <a:lstStyle/>
-          <a:p>
-            <a:pPr algn="l"/>
-            <a:r>
-              <a:rPr sz="1000" b="0" i="0">
-                <a:solidFill>
-                  <a:srgbClr val="6B7280"/>
-                </a:solidFill>
-                <a:latin typeface="Calibri"/>
-              </a:rPr>
-              <a:t>MH6805 Group 7  |  Token unlocks and forward volatility</a:t>
-            </a:r>
-          </a:p>
-        </p:txBody>
-      </p:sp>
-      <p:sp>
-        <p:nvSpPr>
-          <p:cNvPr id="5" name="Slide number"/>
-          <p:cNvSpPr txBox="1"/>
-          <p:nvPr/>
-        </p:nvSpPr>
-        <p:spPr>
-          <a:xfrm>
-            <a:off x="10241280" y="6400800"/>
-            <a:ext cx="1399032" cy="274320"/>
-          </a:xfrm>
-          <a:prstGeom prst="rect">
-            <a:avLst/>
-          </a:prstGeom>
-          <a:noFill/>
-        </p:spPr>
-        <p:txBody>
-          <a:bodyPr wrap="square" lIns="0" rIns="0" tIns="0" bIns="0" anchor="t">
-            <a:spAutoFit/>
-          </a:bodyPr>
-          <a:lstStyle/>
-          <a:p>
-            <a:pPr algn="r"/>
-            <a:r>
-              <a:rPr sz="1000" b="0" i="0">
-                <a:solidFill>
-                  <a:srgbClr val="6B7280"/>
-                </a:solidFill>
-                <a:latin typeface="Calibri"/>
-              </a:rPr>
-              <a:t>11</a:t>
-            </a:r>
-          </a:p>
-        </p:txBody>
-      </p:sp>
-      <p:graphicFrame>
-        <p:nvGraphicFramePr>
-          <p:cNvPr id="6" name="Table 5"/>
-          <p:cNvGraphicFramePr>
-            <a:graphicFrameLocks noGrp="1"/>
-          </p:cNvGraphicFramePr>
-          <p:nvPr/>
-        </p:nvGraphicFramePr>
-        <p:xfrm>
-          <a:off x="548640" y="1828800"/>
-          <a:ext cx="11064240" cy="1920240"/>
-        </p:xfrm>
-        <a:graphic>
-          <a:graphicData uri="http://schemas.openxmlformats.org/drawingml/2006/table">
-            <a:tbl>
-              <a:tblPr firstRow="1" bandRow="1">
-                <a:tableStyleId>{5C22544A-7EE6-4342-B048-85BDC9FD1C3A}</a:tableStyleId>
-              </a:tblPr>
-              <a:tblGrid>
-                <a:gridCol w="4206240"/>
-                <a:gridCol w="1280160"/>
-                <a:gridCol w="1371600"/>
-                <a:gridCol w="1463040"/>
-                <a:gridCol w="1463040"/>
-                <a:gridCol w="1280160"/>
-              </a:tblGrid>
-              <a:tr h="640080">
-                <a:tc>
-                  <a:txBody>
-                    <a:bodyPr/>
-                    <a:lstStyle/>
-                    <a:p>
-                      <a:pPr algn="l"/>
-                      <a:r>
-                        <a:rPr sz="1500" b="1">
-                          <a:solidFill>
-                            <a:srgbClr val="FFFFFF"/>
-                          </a:solidFill>
-                          <a:latin typeface="Calibri"/>
-                        </a:rPr>
-                        <a:t>Event</a:t>
-                      </a:r>
-                    </a:p>
-                  </a:txBody>
-                  <a:tcPr anchor="ctr">
-                    <a:solidFill>
-                      <a:srgbClr val="141B2D"/>
-                    </a:solidFill>
-                  </a:tcPr>
-                </a:tc>
-                <a:tc>
-                  <a:txBody>
-                    <a:bodyPr/>
-                    <a:lstStyle/>
-                    <a:p>
-                      <a:pPr algn="ctr"/>
-                      <a:r>
-                        <a:rPr sz="1500" b="1">
-                          <a:solidFill>
-                            <a:srgbClr val="FFFFFF"/>
-                          </a:solidFill>
-                          <a:latin typeface="Calibri"/>
-                        </a:rPr>
-                        <a:t>Base rate</a:t>
-                      </a:r>
-                    </a:p>
-                  </a:txBody>
-                  <a:tcPr anchor="ctr">
-                    <a:solidFill>
-                      <a:srgbClr val="141B2D"/>
-                    </a:solidFill>
-                  </a:tcPr>
-                </a:tc>
-                <a:tc>
-                  <a:txBody>
-                    <a:bodyPr/>
-                    <a:lstStyle/>
-                    <a:p>
-                      <a:pPr algn="ctr"/>
-                      <a:r>
-                        <a:rPr sz="1500" b="1">
-                          <a:solidFill>
-                            <a:srgbClr val="FFFFFF"/>
-                          </a:solidFill>
-                          <a:latin typeface="Calibri"/>
-                        </a:rPr>
-                        <a:t>Naive AUC</a:t>
-                      </a:r>
-                    </a:p>
-                  </a:txBody>
-                  <a:tcPr anchor="ctr">
-                    <a:solidFill>
-                      <a:srgbClr val="141B2D"/>
-                    </a:solidFill>
-                  </a:tcPr>
-                </a:tc>
-                <a:tc>
-                  <a:txBody>
-                    <a:bodyPr/>
-                    <a:lstStyle/>
-                    <a:p>
-                      <a:pPr algn="ctr"/>
-                      <a:r>
-                        <a:rPr sz="1500" b="1">
-                          <a:solidFill>
-                            <a:srgbClr val="FFFFFF"/>
-                          </a:solidFill>
-                          <a:latin typeface="Calibri"/>
-                        </a:rPr>
-                        <a:t>AUC controls</a:t>
-                      </a:r>
-                    </a:p>
-                  </a:txBody>
-                  <a:tcPr anchor="ctr">
-                    <a:solidFill>
-                      <a:srgbClr val="141B2D"/>
-                    </a:solidFill>
-                  </a:tcPr>
-                </a:tc>
-                <a:tc>
-                  <a:txBody>
-                    <a:bodyPr/>
-                    <a:lstStyle/>
-                    <a:p>
-                      <a:pPr algn="ctr"/>
-                      <a:r>
-                        <a:rPr sz="1500" b="1">
-                          <a:solidFill>
-                            <a:srgbClr val="FFFFFF"/>
-                          </a:solidFill>
-                          <a:latin typeface="Calibri"/>
-                        </a:rPr>
-                        <a:t>AUC + unlocks</a:t>
-                      </a:r>
-                    </a:p>
-                  </a:txBody>
-                  <a:tcPr anchor="ctr">
-                    <a:solidFill>
-                      <a:srgbClr val="141B2D"/>
-                    </a:solidFill>
-                  </a:tcPr>
-                </a:tc>
-                <a:tc>
-                  <a:txBody>
-                    <a:bodyPr/>
-                    <a:lstStyle/>
-                    <a:p>
-                      <a:pPr algn="ctr"/>
-                      <a:r>
-                        <a:rPr sz="1500" b="1">
-                          <a:solidFill>
-                            <a:srgbClr val="FFFFFF"/>
-                          </a:solidFill>
-                          <a:latin typeface="Calibri"/>
-                        </a:rPr>
-                        <a:t>Δ AUC</a:t>
-                      </a:r>
-                    </a:p>
-                  </a:txBody>
-                  <a:tcPr anchor="ctr">
-                    <a:solidFill>
-                      <a:srgbClr val="141B2D"/>
-                    </a:solidFill>
-                  </a:tcPr>
-                </a:tc>
-              </a:tr>
-              <a:tr h="640080">
-                <a:tc>
-                  <a:txBody>
-                    <a:bodyPr/>
-                    <a:lstStyle/>
-                    <a:p>
-                      <a:pPr algn="l"/>
-                      <a:r>
-                        <a:rPr sz="1500" b="0">
-                          <a:solidFill>
-                            <a:srgbClr val="1F2433"/>
-                          </a:solidFill>
-                          <a:latin typeface="Calibri"/>
-                        </a:rPr>
-                        <a:t>Top 20% most volatile tokens on the date</a:t>
-                      </a:r>
-                    </a:p>
-                  </a:txBody>
-                  <a:tcPr anchor="ctr">
-                    <a:solidFill>
-                      <a:srgbClr val="FFFFFF"/>
-                    </a:solidFill>
-                  </a:tcPr>
-                </a:tc>
-                <a:tc>
-                  <a:txBody>
-                    <a:bodyPr/>
-                    <a:lstStyle/>
-                    <a:p>
-                      <a:pPr algn="ctr"/>
-                      <a:r>
-                        <a:rPr sz="1500" b="0">
-                          <a:solidFill>
-                            <a:srgbClr val="1F2433"/>
-                          </a:solidFill>
-                          <a:latin typeface="Calibri"/>
-                        </a:rPr>
-                        <a:t>20%</a:t>
-                      </a:r>
-                    </a:p>
-                  </a:txBody>
-                  <a:tcPr anchor="ctr">
-                    <a:solidFill>
-                      <a:srgbClr val="FFFFFF"/>
-                    </a:solidFill>
-                  </a:tcPr>
-                </a:tc>
-                <a:tc>
-                  <a:txBody>
-                    <a:bodyPr/>
-                    <a:lstStyle/>
-                    <a:p>
-                      <a:pPr algn="ctr"/>
-                      <a:r>
-                        <a:rPr sz="1500" b="0">
-                          <a:solidFill>
-                            <a:srgbClr val="1F2433"/>
-                          </a:solidFill>
-                          <a:latin typeface="Calibri"/>
-                        </a:rPr>
-                        <a:t>0.653</a:t>
-                      </a:r>
-                    </a:p>
-                  </a:txBody>
-                  <a:tcPr anchor="ctr">
-                    <a:solidFill>
-                      <a:srgbClr val="FFFFFF"/>
-                    </a:solidFill>
-                  </a:tcPr>
-                </a:tc>
-                <a:tc>
-                  <a:txBody>
-                    <a:bodyPr/>
-                    <a:lstStyle/>
-                    <a:p>
-                      <a:pPr algn="ctr"/>
-                      <a:r>
-                        <a:rPr sz="1500" b="0">
-                          <a:solidFill>
-                            <a:srgbClr val="1F2433"/>
-                          </a:solidFill>
-                          <a:latin typeface="Calibri"/>
-                        </a:rPr>
-                        <a:t>0.694</a:t>
-                      </a:r>
-                    </a:p>
-                  </a:txBody>
-                  <a:tcPr anchor="ctr">
-                    <a:solidFill>
-                      <a:srgbClr val="FFFFFF"/>
-                    </a:solidFill>
-                  </a:tcPr>
-                </a:tc>
-                <a:tc>
-                  <a:txBody>
-                    <a:bodyPr/>
-                    <a:lstStyle/>
-                    <a:p>
-                      <a:pPr algn="ctr"/>
-                      <a:r>
-                        <a:rPr sz="1500" b="0">
-                          <a:solidFill>
-                            <a:srgbClr val="1F2433"/>
-                          </a:solidFill>
-                          <a:latin typeface="Calibri"/>
-                        </a:rPr>
-                        <a:t>0.693</a:t>
-                      </a:r>
-                    </a:p>
-                  </a:txBody>
-                  <a:tcPr anchor="ctr">
-                    <a:solidFill>
-                      <a:srgbClr val="FFFFFF"/>
-                    </a:solidFill>
-                  </a:tcPr>
-                </a:tc>
-                <a:tc>
-                  <a:txBody>
-                    <a:bodyPr/>
-                    <a:lstStyle/>
-                    <a:p>
-                      <a:pPr algn="ctr"/>
-                      <a:r>
-                        <a:rPr sz="1500" b="1">
-                          <a:solidFill>
-                            <a:srgbClr val="EB6A35"/>
-                          </a:solidFill>
-                          <a:latin typeface="Calibri"/>
-                        </a:rPr>
-                        <a:t>-0.002</a:t>
-                      </a:r>
-                    </a:p>
-                  </a:txBody>
-                  <a:tcPr anchor="ctr">
-                    <a:solidFill>
-                      <a:srgbClr val="FFFFFF"/>
-                    </a:solidFill>
-                  </a:tcPr>
-                </a:tc>
-              </a:tr>
-              <a:tr h="640080">
-                <a:tc>
-                  <a:txBody>
-                    <a:bodyPr/>
-                    <a:lstStyle/>
-                    <a:p>
-                      <a:pPr algn="l"/>
-                      <a:r>
-                        <a:rPr sz="1500" b="0">
-                          <a:solidFill>
-                            <a:srgbClr val="1F2433"/>
-                          </a:solidFill>
-                          <a:latin typeface="Calibri"/>
-                        </a:rPr>
-                        <a:t>Vol jumps above 1.5× own 30d level</a:t>
-                      </a:r>
-                    </a:p>
-                  </a:txBody>
-                  <a:tcPr anchor="ctr">
-                    <a:solidFill>
-                      <a:srgbClr val="F2F4F7"/>
-                    </a:solidFill>
-                  </a:tcPr>
-                </a:tc>
-                <a:tc>
-                  <a:txBody>
-                    <a:bodyPr/>
-                    <a:lstStyle/>
-                    <a:p>
-                      <a:pPr algn="ctr"/>
-                      <a:r>
-                        <a:rPr sz="1500" b="0">
-                          <a:solidFill>
-                            <a:srgbClr val="1F2433"/>
-                          </a:solidFill>
-                          <a:latin typeface="Calibri"/>
-                        </a:rPr>
-                        <a:t>14%</a:t>
-                      </a:r>
-                    </a:p>
-                  </a:txBody>
-                  <a:tcPr anchor="ctr">
-                    <a:solidFill>
-                      <a:srgbClr val="F2F4F7"/>
-                    </a:solidFill>
-                  </a:tcPr>
-                </a:tc>
-                <a:tc>
-                  <a:txBody>
-                    <a:bodyPr/>
-                    <a:lstStyle/>
-                    <a:p>
-                      <a:pPr algn="ctr"/>
-                      <a:r>
-                        <a:rPr sz="1500" b="0">
-                          <a:solidFill>
-                            <a:srgbClr val="1F2433"/>
-                          </a:solidFill>
-                          <a:latin typeface="Calibri"/>
-                        </a:rPr>
-                        <a:t>–</a:t>
-                      </a:r>
-                    </a:p>
-                  </a:txBody>
-                  <a:tcPr anchor="ctr">
-                    <a:solidFill>
-                      <a:srgbClr val="F2F4F7"/>
-                    </a:solidFill>
-                  </a:tcPr>
-                </a:tc>
-                <a:tc>
-                  <a:txBody>
-                    <a:bodyPr/>
-                    <a:lstStyle/>
-                    <a:p>
-                      <a:pPr algn="ctr"/>
-                      <a:r>
-                        <a:rPr sz="1500" b="0">
-                          <a:solidFill>
-                            <a:srgbClr val="1F2433"/>
-                          </a:solidFill>
-                          <a:latin typeface="Calibri"/>
-                        </a:rPr>
-                        <a:t>0.722</a:t>
-                      </a:r>
-                    </a:p>
-                  </a:txBody>
-                  <a:tcPr anchor="ctr">
-                    <a:solidFill>
-                      <a:srgbClr val="F2F4F7"/>
-                    </a:solidFill>
-                  </a:tcPr>
-                </a:tc>
-                <a:tc>
-                  <a:txBody>
-                    <a:bodyPr/>
-                    <a:lstStyle/>
-                    <a:p>
-                      <a:pPr algn="ctr"/>
-                      <a:r>
-                        <a:rPr sz="1500" b="0">
-                          <a:solidFill>
-                            <a:srgbClr val="1F2433"/>
-                          </a:solidFill>
-                          <a:latin typeface="Calibri"/>
-                        </a:rPr>
-                        <a:t>0.718</a:t>
-                      </a:r>
-                    </a:p>
-                  </a:txBody>
-                  <a:tcPr anchor="ctr">
-                    <a:solidFill>
-                      <a:srgbClr val="F2F4F7"/>
-                    </a:solidFill>
-                  </a:tcPr>
-                </a:tc>
-                <a:tc>
-                  <a:txBody>
-                    <a:bodyPr/>
-                    <a:lstStyle/>
-                    <a:p>
-                      <a:pPr algn="ctr"/>
-                      <a:r>
-                        <a:rPr sz="1500" b="1">
-                          <a:solidFill>
-                            <a:srgbClr val="EB6A35"/>
-                          </a:solidFill>
-                          <a:latin typeface="Calibri"/>
-                        </a:rPr>
-                        <a:t>-0.004</a:t>
-                      </a:r>
-                    </a:p>
-                  </a:txBody>
-                  <a:tcPr anchor="ctr">
-                    <a:solidFill>
-                      <a:srgbClr val="F2F4F7"/>
-                    </a:solidFill>
-                  </a:tcPr>
-                </a:tc>
-              </a:tr>
-            </a:tbl>
-          </a:graphicData>
-        </a:graphic>
-      </p:graphicFrame>
-      <p:pic>
-        <p:nvPicPr>
-          <p:cNvPr id="7" name="Picture 6" descr="logistic_auc.png"/>
-          <p:cNvPicPr>
-            <a:picLocks noChangeAspect="1"/>
-          </p:cNvPicPr>
-          <p:nvPr/>
-        </p:nvPicPr>
-        <p:blipFill>
-          <a:blip r:embed="rId3"/>
-          <a:stretch>
-            <a:fillRect/>
-          </a:stretch>
-        </p:blipFill>
-        <p:spPr>
-          <a:xfrm>
-            <a:off x="548640" y="3977639"/>
-            <a:ext cx="4917621" cy="2240280"/>
-          </a:xfrm>
-          <a:prstGeom prst="rect">
-            <a:avLst/>
-          </a:prstGeom>
-        </p:spPr>
-      </p:pic>
-      <p:sp>
-        <p:nvSpPr>
-          <p:cNvPr id="8" name="Logistic takeaway"/>
-          <p:cNvSpPr/>
-          <p:nvPr/>
-        </p:nvSpPr>
-        <p:spPr>
-          <a:xfrm>
-            <a:off x="6675120" y="4069080"/>
-            <a:ext cx="4937760" cy="1600200"/>
-          </a:xfrm>
-          <a:prstGeom prst="roundRect">
-            <a:avLst>
-              <a:gd name="adj" fmla="val 8000"/>
-            </a:avLst>
-          </a:prstGeom>
-          <a:solidFill>
-            <a:srgbClr val="F2F4F7"/>
-          </a:solidFill>
-          <a:ln>
-            <a:noFill/>
-          </a:ln>
-          <a:effectLst/>
-        </p:spPr>
-        <p:style>
-          <a:lnRef idx="1">
-            <a:schemeClr val="accent1"/>
-          </a:lnRef>
-          <a:fillRef idx="3">
-            <a:schemeClr val="accent1"/>
-          </a:fillRef>
-          <a:effectRef idx="2">
-            <a:schemeClr val="accent1"/>
-          </a:effectRef>
-          <a:fontRef idx="minor">
-            <a:schemeClr val="lt1"/>
-          </a:fontRef>
-        </p:style>
-        <p:txBody>
-          <a:bodyPr rtlCol="0" anchor="ctr"/>
-          <a:lstStyle/>
-          <a:p>
-            <a:pPr algn="ctr"/>
-          </a:p>
-        </p:txBody>
-      </p:sp>
-      <p:sp>
-        <p:nvSpPr>
-          <p:cNvPr id="9" name="TextBox 8"/>
-          <p:cNvSpPr txBox="1"/>
-          <p:nvPr/>
-        </p:nvSpPr>
-        <p:spPr>
-          <a:xfrm>
-            <a:off x="6949440" y="4251960"/>
-            <a:ext cx="4480560" cy="1737360"/>
-          </a:xfrm>
-          <a:prstGeom prst="rect">
-            <a:avLst/>
-          </a:prstGeom>
-          <a:noFill/>
-        </p:spPr>
-        <p:txBody>
-          <a:bodyPr wrap="square" lIns="0" rIns="0" tIns="0" bIns="0" anchor="t">
-            <a:spAutoFit/>
-          </a:bodyPr>
-          <a:lstStyle/>
-          <a:p>
-            <a:pPr algn="l"/>
-            <a:r>
-              <a:rPr sz="1500" b="1" i="0">
-                <a:solidFill>
-                  <a:srgbClr val="1F2433"/>
-                </a:solidFill>
-                <a:latin typeface="Calibri"/>
-              </a:rPr>
-              <a:t>Daily panel, mean of 5 folds. </a:t>
-            </a:r>
-            <a:r>
-              <a:rPr sz="1500" b="0" i="0">
-                <a:solidFill>
-                  <a:srgbClr val="1F2433"/>
-                </a:solidFill>
-                <a:latin typeface="Calibri"/>
-              </a:rPr>
-              <a:t>PR-AUC and Brier skill fall too, on both panels. Unlock schedules do not help pick the most volatile tokens, nor anticipate a token's own volatility jump.</a:t>
             </a:r>
           </a:p>
         </p:txBody>
@@ -7800,7 +6691,7 @@
                 </a:solidFill>
                 <a:latin typeface="Calibri"/>
               </a:rPr>
-              <a:t>12</a:t>
+              <a:t>9</a:t>
             </a:r>
           </a:p>
         </p:txBody>
@@ -8054,7 +6945,7 @@
                 </a:solidFill>
                 <a:latin typeface="Calibri"/>
               </a:rPr>
-              <a:t>ROBUSTNESS</a:t>
+              <a:t>ROBUSTNESS AND CLASSIFICATION</a:t>
             </a:r>
           </a:p>
         </p:txBody>
@@ -8159,7 +7050,7 @@
                 </a:solidFill>
                 <a:latin typeface="Calibri"/>
               </a:rPr>
-              <a:t>13</a:t>
+              <a:t>10</a:t>
             </a:r>
           </a:p>
         </p:txBody>
@@ -9217,8 +8108,8 @@
         </p:nvSpPr>
         <p:spPr>
           <a:xfrm>
-            <a:off x="10332720" y="1828800"/>
-            <a:ext cx="1463040" cy="822960"/>
+            <a:off x="10149840" y="1828800"/>
+            <a:ext cx="1737360" cy="822960"/>
           </a:xfrm>
           <a:prstGeom prst="rect">
             <a:avLst/>
@@ -9252,8 +8143,8 @@
         </p:nvSpPr>
         <p:spPr>
           <a:xfrm>
-            <a:off x="10332720" y="2514600"/>
-            <a:ext cx="1371600" cy="1463040"/>
+            <a:off x="10149840" y="2514600"/>
+            <a:ext cx="1645920" cy="1280160"/>
           </a:xfrm>
           <a:prstGeom prst="rect">
             <a:avLst/>
@@ -9287,8 +8178,8 @@
         </p:nvSpPr>
         <p:spPr>
           <a:xfrm>
-            <a:off x="10332720" y="3840480"/>
-            <a:ext cx="1463040" cy="822960"/>
+            <a:off x="10149840" y="3840480"/>
+            <a:ext cx="1737360" cy="822960"/>
           </a:xfrm>
           <a:prstGeom prst="rect">
             <a:avLst/>
@@ -9309,7 +8200,7 @@
                 </a:solidFill>
                 <a:latin typeface="Cambria"/>
               </a:rPr>
-              <a:t>0.15</a:t>
+              <a:t>-0.002</a:t>
             </a:r>
           </a:p>
         </p:txBody>
@@ -9322,8 +8213,8 @@
         </p:nvSpPr>
         <p:spPr>
           <a:xfrm>
-            <a:off x="10332720" y="4526280"/>
-            <a:ext cx="1371600" cy="1188720"/>
+            <a:off x="10149840" y="4526280"/>
+            <a:ext cx="1645920" cy="1371600"/>
           </a:xfrm>
           <a:prstGeom prst="rect">
             <a:avLst/>
@@ -9344,7 +8235,7 @@
                 </a:solidFill>
                 <a:latin typeface="Calibri"/>
               </a:rPr>
-              <a:t>typical fold-to-fold s.d. of R²oos</a:t>
+              <a:t>logistic AUC change from unlocks: top-20% event (spike: -0.004)</a:t>
             </a:r>
           </a:p>
         </p:txBody>
@@ -9510,7 +8401,7 @@
                 </a:solidFill>
                 <a:latin typeface="Calibri"/>
               </a:rPr>
-              <a:t>14</a:t>
+              <a:t>11</a:t>
             </a:r>
           </a:p>
         </p:txBody>
@@ -10776,2109 +9667,7 @@
                 </a:solidFill>
                 <a:latin typeface="Calibri"/>
               </a:rPr>
-              <a:t>A null result is a valid result: nothing was tuned to make it disappear.</a:t>
-            </a:r>
-          </a:p>
-        </p:txBody>
-      </p:sp>
-    </p:spTree>
-  </p:cSld>
-  <p:clrMapOvr>
-    <a:masterClrMapping/>
-  </p:clrMapOvr>
-</p:sld>
-</file>
-
-<file path=ppt/slides/slide16.xml><?xml version="1.0" encoding="utf-8"?>
-<p:sld xmlns:a="http://schemas.openxmlformats.org/drawingml/2006/main" xmlns:p="http://schemas.openxmlformats.org/presentationml/2006/main" xmlns:r="http://schemas.openxmlformats.org/officeDocument/2006/relationships">
-  <p:cSld>
-    <p:bg>
-      <p:bgPr>
-        <a:solidFill>
-          <a:srgbClr val="FFFFFF"/>
-        </a:solidFill>
-        <a:effectLst/>
-      </p:bgPr>
-    </p:bg>
-    <p:spTree>
-      <p:nvGrpSpPr>
-        <p:cNvPr id="1" name=""/>
-        <p:cNvGrpSpPr/>
-        <p:nvPr/>
-      </p:nvGrpSpPr>
-      <p:grpSpPr/>
-      <p:sp>
-        <p:nvSpPr>
-          <p:cNvPr id="2" name="Kicker"/>
-          <p:cNvSpPr txBox="1"/>
-          <p:nvPr/>
-        </p:nvSpPr>
-        <p:spPr>
-          <a:xfrm>
-            <a:off x="548640" y="320040"/>
-            <a:ext cx="11064240" cy="274320"/>
-          </a:xfrm>
-          <a:prstGeom prst="rect">
-            <a:avLst/>
-          </a:prstGeom>
-          <a:noFill/>
-        </p:spPr>
-        <p:txBody>
-          <a:bodyPr wrap="square" lIns="0" rIns="0" tIns="0" bIns="0" anchor="t">
-            <a:spAutoFit/>
-          </a:bodyPr>
-          <a:lstStyle/>
-          <a:p>
-            <a:pPr algn="l"/>
-            <a:r>
-              <a:rPr sz="1200" b="1" i="0">
-                <a:solidFill>
-                  <a:srgbClr val="EB6A35"/>
-                </a:solidFill>
-                <a:latin typeface="Calibri"/>
-              </a:rPr>
-              <a:t>DISCUSSION</a:t>
-            </a:r>
-          </a:p>
-        </p:txBody>
-      </p:sp>
-      <p:sp>
-        <p:nvSpPr>
-          <p:cNvPr id="3" name="Title"/>
-          <p:cNvSpPr txBox="1"/>
-          <p:nvPr/>
-        </p:nvSpPr>
-        <p:spPr>
-          <a:xfrm>
-            <a:off x="548640" y="594360"/>
-            <a:ext cx="11064240" cy="822960"/>
-          </a:xfrm>
-          <a:prstGeom prst="rect">
-            <a:avLst/>
-          </a:prstGeom>
-          <a:noFill/>
-        </p:spPr>
-        <p:txBody>
-          <a:bodyPr wrap="square" lIns="0" rIns="0" tIns="0" bIns="0" anchor="t">
-            <a:spAutoFit/>
-          </a:bodyPr>
-          <a:lstStyle/>
-          <a:p>
-            <a:pPr algn="l"/>
-            <a:r>
-              <a:rPr sz="3200" b="1" i="0">
-                <a:solidFill>
-                  <a:srgbClr val="1F2433"/>
-                </a:solidFill>
-                <a:latin typeface="Cambria"/>
-              </a:rPr>
-              <a:t>Limitations and next steps</a:t>
-            </a:r>
-          </a:p>
-        </p:txBody>
-      </p:sp>
-      <p:sp>
-        <p:nvSpPr>
-          <p:cNvPr id="4" name="Footer"/>
-          <p:cNvSpPr txBox="1"/>
-          <p:nvPr/>
-        </p:nvSpPr>
-        <p:spPr>
-          <a:xfrm>
-            <a:off x="548640" y="6400800"/>
-            <a:ext cx="7315200" cy="274320"/>
-          </a:xfrm>
-          <a:prstGeom prst="rect">
-            <a:avLst/>
-          </a:prstGeom>
-          <a:noFill/>
-        </p:spPr>
-        <p:txBody>
-          <a:bodyPr wrap="square" lIns="0" rIns="0" tIns="0" bIns="0" anchor="t">
-            <a:spAutoFit/>
-          </a:bodyPr>
-          <a:lstStyle/>
-          <a:p>
-            <a:pPr algn="l"/>
-            <a:r>
-              <a:rPr sz="1000" b="0" i="0">
-                <a:solidFill>
-                  <a:srgbClr val="6B7280"/>
-                </a:solidFill>
-                <a:latin typeface="Calibri"/>
-              </a:rPr>
-              <a:t>MH6805 Group 7  |  Token unlocks and forward volatility</a:t>
-            </a:r>
-          </a:p>
-        </p:txBody>
-      </p:sp>
-      <p:sp>
-        <p:nvSpPr>
-          <p:cNvPr id="5" name="Slide number"/>
-          <p:cNvSpPr txBox="1"/>
-          <p:nvPr/>
-        </p:nvSpPr>
-        <p:spPr>
-          <a:xfrm>
-            <a:off x="10241280" y="6400800"/>
-            <a:ext cx="1399032" cy="274320"/>
-          </a:xfrm>
-          <a:prstGeom prst="rect">
-            <a:avLst/>
-          </a:prstGeom>
-          <a:noFill/>
-        </p:spPr>
-        <p:txBody>
-          <a:bodyPr wrap="square" lIns="0" rIns="0" tIns="0" bIns="0" anchor="t">
-            <a:spAutoFit/>
-          </a:bodyPr>
-          <a:lstStyle/>
-          <a:p>
-            <a:pPr algn="r"/>
-            <a:r>
-              <a:rPr sz="1000" b="0" i="0">
-                <a:solidFill>
-                  <a:srgbClr val="6B7280"/>
-                </a:solidFill>
-                <a:latin typeface="Calibri"/>
-              </a:rPr>
-              <a:t>16</a:t>
-            </a:r>
-          </a:p>
-        </p:txBody>
-      </p:sp>
-      <p:sp>
-        <p:nvSpPr>
-          <p:cNvPr id="6" name="Limitations"/>
-          <p:cNvSpPr/>
-          <p:nvPr/>
-        </p:nvSpPr>
-        <p:spPr>
-          <a:xfrm>
-            <a:off x="548640" y="1737360"/>
-            <a:ext cx="5394960" cy="4389120"/>
-          </a:xfrm>
-          <a:prstGeom prst="roundRect">
-            <a:avLst>
-              <a:gd name="adj" fmla="val 8000"/>
-            </a:avLst>
-          </a:prstGeom>
-          <a:solidFill>
-            <a:srgbClr val="F2F4F7"/>
-          </a:solidFill>
-          <a:ln>
-            <a:noFill/>
-          </a:ln>
-          <a:effectLst/>
-        </p:spPr>
-        <p:style>
-          <a:lnRef idx="1">
-            <a:schemeClr val="accent1"/>
-          </a:lnRef>
-          <a:fillRef idx="3">
-            <a:schemeClr val="accent1"/>
-          </a:fillRef>
-          <a:effectRef idx="2">
-            <a:schemeClr val="accent1"/>
-          </a:effectRef>
-          <a:fontRef idx="minor">
-            <a:schemeClr val="lt1"/>
-          </a:fontRef>
-        </p:style>
-        <p:txBody>
-          <a:bodyPr rtlCol="0" anchor="ctr"/>
-          <a:lstStyle/>
-          <a:p>
-            <a:pPr algn="ctr"/>
-          </a:p>
-        </p:txBody>
-      </p:sp>
-      <p:sp>
-        <p:nvSpPr>
-          <p:cNvPr id="7" name="TextBox 6"/>
-          <p:cNvSpPr txBox="1"/>
-          <p:nvPr/>
-        </p:nvSpPr>
-        <p:spPr>
-          <a:xfrm>
-            <a:off x="868680" y="1965960"/>
-            <a:ext cx="4754880" cy="457200"/>
-          </a:xfrm>
-          <a:prstGeom prst="rect">
-            <a:avLst/>
-          </a:prstGeom>
-          <a:noFill/>
-        </p:spPr>
-        <p:txBody>
-          <a:bodyPr wrap="square" lIns="0" rIns="0" tIns="0" bIns="0" anchor="t">
-            <a:spAutoFit/>
-          </a:bodyPr>
-          <a:lstStyle/>
-          <a:p>
-            <a:pPr algn="l"/>
-            <a:r>
-              <a:rPr sz="2200" b="1" i="0">
-                <a:solidFill>
-                  <a:srgbClr val="141B2D"/>
-                </a:solidFill>
-                <a:latin typeface="Cambria"/>
-              </a:rPr>
-              <a:t>Limitations</a:t>
-            </a:r>
-          </a:p>
-        </p:txBody>
-      </p:sp>
-      <p:sp>
-        <p:nvSpPr>
-          <p:cNvPr id="8" name="Oval 7"/>
-          <p:cNvSpPr/>
-          <p:nvPr/>
-        </p:nvSpPr>
-        <p:spPr>
-          <a:xfrm>
-            <a:off x="868680" y="2697480"/>
-            <a:ext cx="384048" cy="384048"/>
-          </a:xfrm>
-          <a:prstGeom prst="ellipse">
-            <a:avLst/>
-          </a:prstGeom>
-          <a:solidFill>
-            <a:srgbClr val="141B2D"/>
-          </a:solidFill>
-          <a:ln>
-            <a:noFill/>
-          </a:ln>
-          <a:effectLst/>
-        </p:spPr>
-        <p:style>
-          <a:lnRef idx="1">
-            <a:schemeClr val="accent1"/>
-          </a:lnRef>
-          <a:fillRef idx="3">
-            <a:schemeClr val="accent1"/>
-          </a:fillRef>
-          <a:effectRef idx="2">
-            <a:schemeClr val="accent1"/>
-          </a:effectRef>
-          <a:fontRef idx="minor">
-            <a:schemeClr val="lt1"/>
-          </a:fontRef>
-        </p:style>
-        <p:txBody>
-          <a:bodyPr rtlCol="0" anchor="ctr" lIns="0" rIns="0"/>
-          <a:lstStyle/>
-          <a:p>
-            <a:pPr algn="ctr"/>
-            <a:r>
-              <a:rPr sz="1300" b="1">
-                <a:solidFill>
-                  <a:srgbClr val="FFFFFF"/>
-                </a:solidFill>
-                <a:latin typeface="Calibri"/>
-              </a:rPr>
-              <a:t>1</a:t>
-            </a:r>
-          </a:p>
-        </p:txBody>
-      </p:sp>
-      <p:sp>
-        <p:nvSpPr>
-          <p:cNvPr id="9" name="TextBox 8"/>
-          <p:cNvSpPr txBox="1"/>
-          <p:nvPr/>
-        </p:nvSpPr>
-        <p:spPr>
-          <a:xfrm>
-            <a:off x="1417319" y="2697480"/>
-            <a:ext cx="4297680" cy="777240"/>
-          </a:xfrm>
-          <a:prstGeom prst="rect">
-            <a:avLst/>
-          </a:prstGeom>
-          <a:noFill/>
-        </p:spPr>
-        <p:txBody>
-          <a:bodyPr wrap="square" lIns="0" rIns="0" tIns="0" bIns="0" anchor="t">
-            <a:spAutoFit/>
-          </a:bodyPr>
-          <a:lstStyle/>
-          <a:p>
-            <a:pPr algn="l"/>
-            <a:r>
-              <a:rPr sz="1600" b="0" i="0">
-                <a:solidFill>
-                  <a:srgbClr val="1F2433"/>
-                </a:solidFill>
-                <a:latin typeface="Calibri"/>
-              </a:rPr>
-              <a:t>One calm-to-moderate regime (2024-09 to 2026-08), no 2022-style stress</a:t>
-            </a:r>
-          </a:p>
-        </p:txBody>
-      </p:sp>
-      <p:sp>
-        <p:nvSpPr>
-          <p:cNvPr id="10" name="Oval 9"/>
-          <p:cNvSpPr/>
-          <p:nvPr/>
-        </p:nvSpPr>
-        <p:spPr>
-          <a:xfrm>
-            <a:off x="868680" y="3538728"/>
-            <a:ext cx="384048" cy="384048"/>
-          </a:xfrm>
-          <a:prstGeom prst="ellipse">
-            <a:avLst/>
-          </a:prstGeom>
-          <a:solidFill>
-            <a:srgbClr val="141B2D"/>
-          </a:solidFill>
-          <a:ln>
-            <a:noFill/>
-          </a:ln>
-          <a:effectLst/>
-        </p:spPr>
-        <p:style>
-          <a:lnRef idx="1">
-            <a:schemeClr val="accent1"/>
-          </a:lnRef>
-          <a:fillRef idx="3">
-            <a:schemeClr val="accent1"/>
-          </a:fillRef>
-          <a:effectRef idx="2">
-            <a:schemeClr val="accent1"/>
-          </a:effectRef>
-          <a:fontRef idx="minor">
-            <a:schemeClr val="lt1"/>
-          </a:fontRef>
-        </p:style>
-        <p:txBody>
-          <a:bodyPr rtlCol="0" anchor="ctr" lIns="0" rIns="0"/>
-          <a:lstStyle/>
-          <a:p>
-            <a:pPr algn="ctr"/>
-            <a:r>
-              <a:rPr sz="1300" b="1">
-                <a:solidFill>
-                  <a:srgbClr val="FFFFFF"/>
-                </a:solidFill>
-                <a:latin typeface="Calibri"/>
-              </a:rPr>
-              <a:t>2</a:t>
-            </a:r>
-          </a:p>
-        </p:txBody>
-      </p:sp>
-      <p:sp>
-        <p:nvSpPr>
-          <p:cNvPr id="11" name="TextBox 10"/>
-          <p:cNvSpPr txBox="1"/>
-          <p:nvPr/>
-        </p:nvSpPr>
-        <p:spPr>
-          <a:xfrm>
-            <a:off x="1417319" y="3538728"/>
-            <a:ext cx="4297680" cy="777240"/>
-          </a:xfrm>
-          <a:prstGeom prst="rect">
-            <a:avLst/>
-          </a:prstGeom>
-          <a:noFill/>
-        </p:spPr>
-        <p:txBody>
-          <a:bodyPr wrap="square" lIns="0" rIns="0" tIns="0" bIns="0" anchor="t">
-            <a:spAutoFit/>
-          </a:bodyPr>
-          <a:lstStyle/>
-          <a:p>
-            <a:pPr algn="l"/>
-            <a:r>
-              <a:rPr sz="1600" b="0" i="0">
-                <a:solidFill>
-                  <a:srgbClr val="1F2433"/>
-                </a:solidFill>
-                <a:latin typeface="Calibri"/>
-              </a:rPr>
-              <a:t>Schedules as curated on 2026-09-14: revisions are back-filled (biases toward finding an effect)</a:t>
-            </a:r>
-          </a:p>
-        </p:txBody>
-      </p:sp>
-      <p:sp>
-        <p:nvSpPr>
-          <p:cNvPr id="12" name="Oval 11"/>
-          <p:cNvSpPr/>
-          <p:nvPr/>
-        </p:nvSpPr>
-        <p:spPr>
-          <a:xfrm>
-            <a:off x="868680" y="4379976"/>
-            <a:ext cx="384048" cy="384048"/>
-          </a:xfrm>
-          <a:prstGeom prst="ellipse">
-            <a:avLst/>
-          </a:prstGeom>
-          <a:solidFill>
-            <a:srgbClr val="141B2D"/>
-          </a:solidFill>
-          <a:ln>
-            <a:noFill/>
-          </a:ln>
-          <a:effectLst/>
-        </p:spPr>
-        <p:style>
-          <a:lnRef idx="1">
-            <a:schemeClr val="accent1"/>
-          </a:lnRef>
-          <a:fillRef idx="3">
-            <a:schemeClr val="accent1"/>
-          </a:fillRef>
-          <a:effectRef idx="2">
-            <a:schemeClr val="accent1"/>
-          </a:effectRef>
-          <a:fontRef idx="minor">
-            <a:schemeClr val="lt1"/>
-          </a:fontRef>
-        </p:style>
-        <p:txBody>
-          <a:bodyPr rtlCol="0" anchor="ctr" lIns="0" rIns="0"/>
-          <a:lstStyle/>
-          <a:p>
-            <a:pPr algn="ctr"/>
-            <a:r>
-              <a:rPr sz="1300" b="1">
-                <a:solidFill>
-                  <a:srgbClr val="FFFFFF"/>
-                </a:solidFill>
-                <a:latin typeface="Calibri"/>
-              </a:rPr>
-              <a:t>3</a:t>
-            </a:r>
-          </a:p>
-        </p:txBody>
-      </p:sp>
-      <p:sp>
-        <p:nvSpPr>
-          <p:cNvPr id="13" name="TextBox 12"/>
-          <p:cNvSpPr txBox="1"/>
-          <p:nvPr/>
-        </p:nvSpPr>
-        <p:spPr>
-          <a:xfrm>
-            <a:off x="1417319" y="4379976"/>
-            <a:ext cx="4297680" cy="777240"/>
-          </a:xfrm>
-          <a:prstGeom prst="rect">
-            <a:avLst/>
-          </a:prstGeom>
-          <a:noFill/>
-        </p:spPr>
-        <p:txBody>
-          <a:bodyPr wrap="square" lIns="0" rIns="0" tIns="0" bIns="0" anchor="t">
-            <a:spAutoFit/>
-          </a:bodyPr>
-          <a:lstStyle/>
-          <a:p>
-            <a:pPr algn="l"/>
-            <a:r>
-              <a:rPr sz="1600" b="0" i="0">
-                <a:solidFill>
-                  <a:srgbClr val="1F2433"/>
-                </a:solidFill>
-                <a:latin typeface="Calibri"/>
-              </a:rPr>
-              <a:t>Allocation and listing data are snapshots</a:t>
-            </a:r>
-          </a:p>
-        </p:txBody>
-      </p:sp>
-      <p:sp>
-        <p:nvSpPr>
-          <p:cNvPr id="14" name="Oval 13"/>
-          <p:cNvSpPr/>
-          <p:nvPr/>
-        </p:nvSpPr>
-        <p:spPr>
-          <a:xfrm>
-            <a:off x="868680" y="5221224"/>
-            <a:ext cx="384048" cy="384048"/>
-          </a:xfrm>
-          <a:prstGeom prst="ellipse">
-            <a:avLst/>
-          </a:prstGeom>
-          <a:solidFill>
-            <a:srgbClr val="141B2D"/>
-          </a:solidFill>
-          <a:ln>
-            <a:noFill/>
-          </a:ln>
-          <a:effectLst/>
-        </p:spPr>
-        <p:style>
-          <a:lnRef idx="1">
-            <a:schemeClr val="accent1"/>
-          </a:lnRef>
-          <a:fillRef idx="3">
-            <a:schemeClr val="accent1"/>
-          </a:fillRef>
-          <a:effectRef idx="2">
-            <a:schemeClr val="accent1"/>
-          </a:effectRef>
-          <a:fontRef idx="minor">
-            <a:schemeClr val="lt1"/>
-          </a:fontRef>
-        </p:style>
-        <p:txBody>
-          <a:bodyPr rtlCol="0" anchor="ctr" lIns="0" rIns="0"/>
-          <a:lstStyle/>
-          <a:p>
-            <a:pPr algn="ctr"/>
-            <a:r>
-              <a:rPr sz="1300" b="1">
-                <a:solidFill>
-                  <a:srgbClr val="FFFFFF"/>
-                </a:solidFill>
-                <a:latin typeface="Calibri"/>
-              </a:rPr>
-              <a:t>4</a:t>
-            </a:r>
-          </a:p>
-        </p:txBody>
-      </p:sp>
-      <p:sp>
-        <p:nvSpPr>
-          <p:cNvPr id="15" name="TextBox 14"/>
-          <p:cNvSpPr txBox="1"/>
-          <p:nvPr/>
-        </p:nvSpPr>
-        <p:spPr>
-          <a:xfrm>
-            <a:off x="1417319" y="5221224"/>
-            <a:ext cx="4297680" cy="777240"/>
-          </a:xfrm>
-          <a:prstGeom prst="rect">
-            <a:avLst/>
-          </a:prstGeom>
-          <a:noFill/>
-        </p:spPr>
-        <p:txBody>
-          <a:bodyPr wrap="square" lIns="0" rIns="0" tIns="0" bIns="0" anchor="t">
-            <a:spAutoFit/>
-          </a:bodyPr>
-          <a:lstStyle/>
-          <a:p>
-            <a:pPr algn="l"/>
-            <a:r>
-              <a:rPr sz="1600" b="0" i="0">
-                <a:solidFill>
-                  <a:srgbClr val="1F2433"/>
-                </a:solidFill>
-                <a:latin typeface="Calibri"/>
-              </a:rPr>
-              <a:t>176 Binance-listed tokens: larger, more liquid names</a:t>
-            </a:r>
-          </a:p>
-        </p:txBody>
-      </p:sp>
-      <p:sp>
-        <p:nvSpPr>
-          <p:cNvPr id="16" name="Next steps"/>
-          <p:cNvSpPr/>
-          <p:nvPr/>
-        </p:nvSpPr>
-        <p:spPr>
-          <a:xfrm>
-            <a:off x="6217920" y="1737360"/>
-            <a:ext cx="5394960" cy="4389120"/>
-          </a:xfrm>
-          <a:prstGeom prst="roundRect">
-            <a:avLst>
-              <a:gd name="adj" fmla="val 8000"/>
-            </a:avLst>
-          </a:prstGeom>
-          <a:solidFill>
-            <a:srgbClr val="F2F4F7"/>
-          </a:solidFill>
-          <a:ln>
-            <a:noFill/>
-          </a:ln>
-          <a:effectLst/>
-        </p:spPr>
-        <p:style>
-          <a:lnRef idx="1">
-            <a:schemeClr val="accent1"/>
-          </a:lnRef>
-          <a:fillRef idx="3">
-            <a:schemeClr val="accent1"/>
-          </a:fillRef>
-          <a:effectRef idx="2">
-            <a:schemeClr val="accent1"/>
-          </a:effectRef>
-          <a:fontRef idx="minor">
-            <a:schemeClr val="lt1"/>
-          </a:fontRef>
-        </p:style>
-        <p:txBody>
-          <a:bodyPr rtlCol="0" anchor="ctr"/>
-          <a:lstStyle/>
-          <a:p>
-            <a:pPr algn="ctr"/>
-          </a:p>
-        </p:txBody>
-      </p:sp>
-      <p:sp>
-        <p:nvSpPr>
-          <p:cNvPr id="17" name="TextBox 16"/>
-          <p:cNvSpPr txBox="1"/>
-          <p:nvPr/>
-        </p:nvSpPr>
-        <p:spPr>
-          <a:xfrm>
-            <a:off x="6537959" y="1965960"/>
-            <a:ext cx="4754880" cy="457200"/>
-          </a:xfrm>
-          <a:prstGeom prst="rect">
-            <a:avLst/>
-          </a:prstGeom>
-          <a:noFill/>
-        </p:spPr>
-        <p:txBody>
-          <a:bodyPr wrap="square" lIns="0" rIns="0" tIns="0" bIns="0" anchor="t">
-            <a:spAutoFit/>
-          </a:bodyPr>
-          <a:lstStyle/>
-          <a:p>
-            <a:pPr algn="l"/>
-            <a:r>
-              <a:rPr sz="2200" b="1" i="0">
-                <a:solidFill>
-                  <a:srgbClr val="EB6A35"/>
-                </a:solidFill>
-                <a:latin typeface="Cambria"/>
-              </a:rPr>
-              <a:t>Next steps</a:t>
-            </a:r>
-          </a:p>
-        </p:txBody>
-      </p:sp>
-      <p:sp>
-        <p:nvSpPr>
-          <p:cNvPr id="18" name="Oval 17"/>
-          <p:cNvSpPr/>
-          <p:nvPr/>
-        </p:nvSpPr>
-        <p:spPr>
-          <a:xfrm>
-            <a:off x="6537959" y="2697480"/>
-            <a:ext cx="384048" cy="384048"/>
-          </a:xfrm>
-          <a:prstGeom prst="ellipse">
-            <a:avLst/>
-          </a:prstGeom>
-          <a:solidFill>
-            <a:srgbClr val="EB6A35"/>
-          </a:solidFill>
-          <a:ln>
-            <a:noFill/>
-          </a:ln>
-          <a:effectLst/>
-        </p:spPr>
-        <p:style>
-          <a:lnRef idx="1">
-            <a:schemeClr val="accent1"/>
-          </a:lnRef>
-          <a:fillRef idx="3">
-            <a:schemeClr val="accent1"/>
-          </a:fillRef>
-          <a:effectRef idx="2">
-            <a:schemeClr val="accent1"/>
-          </a:effectRef>
-          <a:fontRef idx="minor">
-            <a:schemeClr val="lt1"/>
-          </a:fontRef>
-        </p:style>
-        <p:txBody>
-          <a:bodyPr rtlCol="0" anchor="ctr" lIns="0" rIns="0"/>
-          <a:lstStyle/>
-          <a:p>
-            <a:pPr algn="ctr"/>
-            <a:r>
-              <a:rPr sz="1300" b="1">
-                <a:solidFill>
-                  <a:srgbClr val="FFFFFF"/>
-                </a:solidFill>
-                <a:latin typeface="Calibri"/>
-              </a:rPr>
-              <a:t>1</a:t>
-            </a:r>
-          </a:p>
-        </p:txBody>
-      </p:sp>
-      <p:sp>
-        <p:nvSpPr>
-          <p:cNvPr id="19" name="TextBox 18"/>
-          <p:cNvSpPr txBox="1"/>
-          <p:nvPr/>
-        </p:nvSpPr>
-        <p:spPr>
-          <a:xfrm>
-            <a:off x="7086600" y="2697480"/>
-            <a:ext cx="4297680" cy="777240"/>
-          </a:xfrm>
-          <a:prstGeom prst="rect">
-            <a:avLst/>
-          </a:prstGeom>
-          <a:noFill/>
-        </p:spPr>
-        <p:txBody>
-          <a:bodyPr wrap="square" lIns="0" rIns="0" tIns="0" bIns="0" anchor="t">
-            <a:spAutoFit/>
-          </a:bodyPr>
-          <a:lstStyle/>
-          <a:p>
-            <a:pPr algn="l"/>
-            <a:r>
-              <a:rPr sz="1600" b="0" i="0">
-                <a:solidFill>
-                  <a:srgbClr val="1F2433"/>
-                </a:solidFill>
-                <a:latin typeface="Calibri"/>
-              </a:rPr>
-              <a:t>Event study around the largest cliff unlocks</a:t>
-            </a:r>
-          </a:p>
-        </p:txBody>
-      </p:sp>
-      <p:sp>
-        <p:nvSpPr>
-          <p:cNvPr id="20" name="Oval 19"/>
-          <p:cNvSpPr/>
-          <p:nvPr/>
-        </p:nvSpPr>
-        <p:spPr>
-          <a:xfrm>
-            <a:off x="6537959" y="3538728"/>
-            <a:ext cx="384048" cy="384048"/>
-          </a:xfrm>
-          <a:prstGeom prst="ellipse">
-            <a:avLst/>
-          </a:prstGeom>
-          <a:solidFill>
-            <a:srgbClr val="EB6A35"/>
-          </a:solidFill>
-          <a:ln>
-            <a:noFill/>
-          </a:ln>
-          <a:effectLst/>
-        </p:spPr>
-        <p:style>
-          <a:lnRef idx="1">
-            <a:schemeClr val="accent1"/>
-          </a:lnRef>
-          <a:fillRef idx="3">
-            <a:schemeClr val="accent1"/>
-          </a:fillRef>
-          <a:effectRef idx="2">
-            <a:schemeClr val="accent1"/>
-          </a:effectRef>
-          <a:fontRef idx="minor">
-            <a:schemeClr val="lt1"/>
-          </a:fontRef>
-        </p:style>
-        <p:txBody>
-          <a:bodyPr rtlCol="0" anchor="ctr" lIns="0" rIns="0"/>
-          <a:lstStyle/>
-          <a:p>
-            <a:pPr algn="ctr"/>
-            <a:r>
-              <a:rPr sz="1300" b="1">
-                <a:solidFill>
-                  <a:srgbClr val="FFFFFF"/>
-                </a:solidFill>
-                <a:latin typeface="Calibri"/>
-              </a:rPr>
-              <a:t>2</a:t>
-            </a:r>
-          </a:p>
-        </p:txBody>
-      </p:sp>
-      <p:sp>
-        <p:nvSpPr>
-          <p:cNvPr id="21" name="TextBox 20"/>
-          <p:cNvSpPr txBox="1"/>
-          <p:nvPr/>
-        </p:nvSpPr>
-        <p:spPr>
-          <a:xfrm>
-            <a:off x="7086600" y="3538728"/>
-            <a:ext cx="4297680" cy="777240"/>
-          </a:xfrm>
-          <a:prstGeom prst="rect">
-            <a:avLst/>
-          </a:prstGeom>
-          <a:noFill/>
-        </p:spPr>
-        <p:txBody>
-          <a:bodyPr wrap="square" lIns="0" rIns="0" tIns="0" bIns="0" anchor="t">
-            <a:spAutoFit/>
-          </a:bodyPr>
-          <a:lstStyle/>
-          <a:p>
-            <a:pPr algn="l"/>
-            <a:r>
-              <a:rPr sz="1600" b="0" i="0">
-                <a:solidFill>
-                  <a:srgbClr val="1F2433"/>
-                </a:solidFill>
-                <a:latin typeface="Calibri"/>
-              </a:rPr>
-              <a:t>Intraday data for the hours around each unlock</a:t>
-            </a:r>
-          </a:p>
-        </p:txBody>
-      </p:sp>
-      <p:sp>
-        <p:nvSpPr>
-          <p:cNvPr id="22" name="Oval 21"/>
-          <p:cNvSpPr/>
-          <p:nvPr/>
-        </p:nvSpPr>
-        <p:spPr>
-          <a:xfrm>
-            <a:off x="6537959" y="4379976"/>
-            <a:ext cx="384048" cy="384048"/>
-          </a:xfrm>
-          <a:prstGeom prst="ellipse">
-            <a:avLst/>
-          </a:prstGeom>
-          <a:solidFill>
-            <a:srgbClr val="EB6A35"/>
-          </a:solidFill>
-          <a:ln>
-            <a:noFill/>
-          </a:ln>
-          <a:effectLst/>
-        </p:spPr>
-        <p:style>
-          <a:lnRef idx="1">
-            <a:schemeClr val="accent1"/>
-          </a:lnRef>
-          <a:fillRef idx="3">
-            <a:schemeClr val="accent1"/>
-          </a:fillRef>
-          <a:effectRef idx="2">
-            <a:schemeClr val="accent1"/>
-          </a:effectRef>
-          <a:fontRef idx="minor">
-            <a:schemeClr val="lt1"/>
-          </a:fontRef>
-        </p:style>
-        <p:txBody>
-          <a:bodyPr rtlCol="0" anchor="ctr" lIns="0" rIns="0"/>
-          <a:lstStyle/>
-          <a:p>
-            <a:pPr algn="ctr"/>
-            <a:r>
-              <a:rPr sz="1300" b="1">
-                <a:solidFill>
-                  <a:srgbClr val="FFFFFF"/>
-                </a:solidFill>
-                <a:latin typeface="Calibri"/>
-              </a:rPr>
-              <a:t>3</a:t>
-            </a:r>
-          </a:p>
-        </p:txBody>
-      </p:sp>
-      <p:sp>
-        <p:nvSpPr>
-          <p:cNvPr id="23" name="TextBox 22"/>
-          <p:cNvSpPr txBox="1"/>
-          <p:nvPr/>
-        </p:nvSpPr>
-        <p:spPr>
-          <a:xfrm>
-            <a:off x="7086600" y="4379976"/>
-            <a:ext cx="4297680" cy="777240"/>
-          </a:xfrm>
-          <a:prstGeom prst="rect">
-            <a:avLst/>
-          </a:prstGeom>
-          <a:noFill/>
-        </p:spPr>
-        <p:txBody>
-          <a:bodyPr wrap="square" lIns="0" rIns="0" tIns="0" bIns="0" anchor="t">
-            <a:spAutoFit/>
-          </a:bodyPr>
-          <a:lstStyle/>
-          <a:p>
-            <a:pPr algn="l"/>
-            <a:r>
-              <a:rPr sz="1600" b="0" i="0">
-                <a:solidFill>
-                  <a:srgbClr val="1F2433"/>
-                </a:solidFill>
-                <a:latin typeface="Calibri"/>
-              </a:rPr>
-              <a:t>Interact unlocks with liquidity, depth and funding rates</a:t>
-            </a:r>
-          </a:p>
-        </p:txBody>
-      </p:sp>
-      <p:sp>
-        <p:nvSpPr>
-          <p:cNvPr id="24" name="Oval 23"/>
-          <p:cNvSpPr/>
-          <p:nvPr/>
-        </p:nvSpPr>
-        <p:spPr>
-          <a:xfrm>
-            <a:off x="6537959" y="5221224"/>
-            <a:ext cx="384048" cy="384048"/>
-          </a:xfrm>
-          <a:prstGeom prst="ellipse">
-            <a:avLst/>
-          </a:prstGeom>
-          <a:solidFill>
-            <a:srgbClr val="EB6A35"/>
-          </a:solidFill>
-          <a:ln>
-            <a:noFill/>
-          </a:ln>
-          <a:effectLst/>
-        </p:spPr>
-        <p:style>
-          <a:lnRef idx="1">
-            <a:schemeClr val="accent1"/>
-          </a:lnRef>
-          <a:fillRef idx="3">
-            <a:schemeClr val="accent1"/>
-          </a:fillRef>
-          <a:effectRef idx="2">
-            <a:schemeClr val="accent1"/>
-          </a:effectRef>
-          <a:fontRef idx="minor">
-            <a:schemeClr val="lt1"/>
-          </a:fontRef>
-        </p:style>
-        <p:txBody>
-          <a:bodyPr rtlCol="0" anchor="ctr" lIns="0" rIns="0"/>
-          <a:lstStyle/>
-          <a:p>
-            <a:pPr algn="ctr"/>
-            <a:r>
-              <a:rPr sz="1300" b="1">
-                <a:solidFill>
-                  <a:srgbClr val="FFFFFF"/>
-                </a:solidFill>
-                <a:latin typeface="Calibri"/>
-              </a:rPr>
-              <a:t>4</a:t>
-            </a:r>
-          </a:p>
-        </p:txBody>
-      </p:sp>
-      <p:sp>
-        <p:nvSpPr>
-          <p:cNvPr id="25" name="TextBox 24"/>
-          <p:cNvSpPr txBox="1"/>
-          <p:nvPr/>
-        </p:nvSpPr>
-        <p:spPr>
-          <a:xfrm>
-            <a:off x="7086600" y="5221224"/>
-            <a:ext cx="4297680" cy="777240"/>
-          </a:xfrm>
-          <a:prstGeom prst="rect">
-            <a:avLst/>
-          </a:prstGeom>
-          <a:noFill/>
-        </p:spPr>
-        <p:txBody>
-          <a:bodyPr wrap="square" lIns="0" rIns="0" tIns="0" bIns="0" anchor="t">
-            <a:spAutoFit/>
-          </a:bodyPr>
-          <a:lstStyle/>
-          <a:p>
-            <a:pPr algn="l"/>
-            <a:r>
-              <a:rPr sz="1600" b="0" i="0">
-                <a:solidFill>
-                  <a:srgbClr val="1F2433"/>
-                </a:solidFill>
-                <a:latin typeface="Calibri"/>
-              </a:rPr>
-              <a:t>Point-in-time schedule snapshots; boosted trees and HAR models</a:t>
-            </a:r>
-          </a:p>
-        </p:txBody>
-      </p:sp>
-    </p:spTree>
-  </p:cSld>
-  <p:clrMapOvr>
-    <a:masterClrMapping/>
-  </p:clrMapOvr>
-</p:sld>
-</file>
-
-<file path=ppt/slides/slide17.xml><?xml version="1.0" encoding="utf-8"?>
-<p:sld xmlns:a="http://schemas.openxmlformats.org/drawingml/2006/main" xmlns:p="http://schemas.openxmlformats.org/presentationml/2006/main" xmlns:r="http://schemas.openxmlformats.org/officeDocument/2006/relationships">
-  <p:cSld>
-    <p:bg>
-      <p:bgPr>
-        <a:solidFill>
-          <a:srgbClr val="141B2D"/>
-        </a:solidFill>
-        <a:effectLst/>
-      </p:bgPr>
-    </p:bg>
-    <p:spTree>
-      <p:nvGrpSpPr>
-        <p:cNvPr id="1" name=""/>
-        <p:cNvGrpSpPr/>
-        <p:nvPr/>
-      </p:nvGrpSpPr>
-      <p:grpSpPr/>
-      <p:sp>
-        <p:nvSpPr>
-          <p:cNvPr id="2" name="TextBox 1"/>
-          <p:cNvSpPr txBox="1"/>
-          <p:nvPr/>
-        </p:nvSpPr>
-        <p:spPr>
-          <a:xfrm>
-            <a:off x="731520" y="1828800"/>
-            <a:ext cx="10515600" cy="1097280"/>
-          </a:xfrm>
-          <a:prstGeom prst="rect">
-            <a:avLst/>
-          </a:prstGeom>
-          <a:noFill/>
-        </p:spPr>
-        <p:txBody>
-          <a:bodyPr wrap="square" lIns="0" rIns="0" tIns="0" bIns="0" anchor="t">
-            <a:spAutoFit/>
-          </a:bodyPr>
-          <a:lstStyle/>
-          <a:p>
-            <a:pPr algn="l"/>
-            <a:r>
-              <a:rPr sz="4800" b="1" i="0">
-                <a:solidFill>
-                  <a:srgbClr val="FFFFFF"/>
-                </a:solidFill>
-                <a:latin typeface="Cambria"/>
-              </a:rPr>
-              <a:t>Thank you. Questions?</a:t>
-            </a:r>
-          </a:p>
-        </p:txBody>
-      </p:sp>
-      <p:sp>
-        <p:nvSpPr>
-          <p:cNvPr id="3" name="TextBox 2"/>
-          <p:cNvSpPr txBox="1"/>
-          <p:nvPr/>
-        </p:nvSpPr>
-        <p:spPr>
-          <a:xfrm>
-            <a:off x="731520" y="3108960"/>
-            <a:ext cx="10515600" cy="548640"/>
-          </a:xfrm>
-          <a:prstGeom prst="rect">
-            <a:avLst/>
-          </a:prstGeom>
-          <a:noFill/>
-        </p:spPr>
-        <p:txBody>
-          <a:bodyPr wrap="square" lIns="0" rIns="0" tIns="0" bIns="0" anchor="t">
-            <a:spAutoFit/>
-          </a:bodyPr>
-          <a:lstStyle/>
-          <a:p>
-            <a:pPr algn="l"/>
-            <a:r>
-              <a:rPr sz="1800" b="0" i="0">
-                <a:solidFill>
-                  <a:srgbClr val="C9D3E6"/>
-                </a:solidFill>
-                <a:latin typeface="Calibri"/>
-              </a:rPr>
-              <a:t>Code, per-fold results and figures: github.com/watersalamander/MH6805A-Project-Group7</a:t>
-            </a:r>
-          </a:p>
-        </p:txBody>
-      </p:sp>
-      <p:sp>
-        <p:nvSpPr>
-          <p:cNvPr id="4" name="TextBox 3"/>
-          <p:cNvSpPr txBox="1"/>
-          <p:nvPr/>
-        </p:nvSpPr>
-        <p:spPr>
-          <a:xfrm>
-            <a:off x="731520" y="4206240"/>
-            <a:ext cx="10515600" cy="365760"/>
-          </a:xfrm>
-          <a:prstGeom prst="rect">
-            <a:avLst/>
-          </a:prstGeom>
-          <a:noFill/>
-        </p:spPr>
-        <p:txBody>
-          <a:bodyPr wrap="square" lIns="0" rIns="0" tIns="0" bIns="0" anchor="t">
-            <a:spAutoFit/>
-          </a:bodyPr>
-          <a:lstStyle/>
-          <a:p>
-            <a:pPr algn="l"/>
-            <a:r>
-              <a:rPr sz="1200" b="1" i="0">
-                <a:solidFill>
-                  <a:srgbClr val="EB6A35"/>
-                </a:solidFill>
-                <a:latin typeface="Calibri"/>
-              </a:rPr>
-              <a:t>CONTRIBUTIONS</a:t>
-            </a:r>
-          </a:p>
-        </p:txBody>
-      </p:sp>
-      <p:sp>
-        <p:nvSpPr>
-          <p:cNvPr id="5" name="TextBox 4"/>
-          <p:cNvSpPr txBox="1"/>
-          <p:nvPr/>
-        </p:nvSpPr>
-        <p:spPr>
-          <a:xfrm>
-            <a:off x="731520" y="4572000"/>
-            <a:ext cx="10515600" cy="1280160"/>
-          </a:xfrm>
-          <a:prstGeom prst="rect">
-            <a:avLst/>
-          </a:prstGeom>
-          <a:noFill/>
-        </p:spPr>
-        <p:txBody>
-          <a:bodyPr wrap="square" lIns="0" rIns="0" tIns="0" bIns="0" anchor="t">
-            <a:spAutoFit/>
-          </a:bodyPr>
-          <a:lstStyle/>
-          <a:p>
-            <a:pPr algn="l"/>
-            <a:r>
-              <a:rPr sz="1600" b="1" i="0">
-                <a:solidFill>
-                  <a:srgbClr val="FF9F80"/>
-                </a:solidFill>
-                <a:latin typeface="Calibri"/>
-              </a:rPr>
-              <a:t>[Member 1]: [part / %]     [Member 2]: [part / %]     [Member 3]: [part / %]</a:t>
-            </a:r>
-          </a:p>
-        </p:txBody>
-      </p:sp>
-    </p:spTree>
-  </p:cSld>
-  <p:clrMapOvr>
-    <a:masterClrMapping/>
-  </p:clrMapOvr>
-</p:sld>
-</file>
-
-<file path=ppt/slides/slide2.xml><?xml version="1.0" encoding="utf-8"?>
-<p:sld xmlns:a="http://schemas.openxmlformats.org/drawingml/2006/main" xmlns:p="http://schemas.openxmlformats.org/presentationml/2006/main" xmlns:r="http://schemas.openxmlformats.org/officeDocument/2006/relationships">
-  <p:cSld>
-    <p:bg>
-      <p:bgPr>
-        <a:solidFill>
-          <a:srgbClr val="FFFFFF"/>
-        </a:solidFill>
-        <a:effectLst/>
-      </p:bgPr>
-    </p:bg>
-    <p:spTree>
-      <p:nvGrpSpPr>
-        <p:cNvPr id="1" name=""/>
-        <p:cNvGrpSpPr/>
-        <p:nvPr/>
-      </p:nvGrpSpPr>
-      <p:grpSpPr/>
-      <p:sp>
-        <p:nvSpPr>
-          <p:cNvPr id="2" name="Kicker"/>
-          <p:cNvSpPr txBox="1"/>
-          <p:nvPr/>
-        </p:nvSpPr>
-        <p:spPr>
-          <a:xfrm>
-            <a:off x="548640" y="320040"/>
-            <a:ext cx="11064240" cy="274320"/>
-          </a:xfrm>
-          <a:prstGeom prst="rect">
-            <a:avLst/>
-          </a:prstGeom>
-          <a:noFill/>
-        </p:spPr>
-        <p:txBody>
-          <a:bodyPr wrap="square" lIns="0" rIns="0" tIns="0" bIns="0" anchor="t">
-            <a:spAutoFit/>
-          </a:bodyPr>
-          <a:lstStyle/>
-          <a:p>
-            <a:pPr algn="l"/>
-            <a:r>
-              <a:rPr sz="1200" b="1" i="0">
-                <a:solidFill>
-                  <a:srgbClr val="EB6A35"/>
-                </a:solidFill>
-                <a:latin typeface="Calibri"/>
-              </a:rPr>
-              <a:t>MOTIVATION</a:t>
-            </a:r>
-          </a:p>
-        </p:txBody>
-      </p:sp>
-      <p:sp>
-        <p:nvSpPr>
-          <p:cNvPr id="3" name="Title"/>
-          <p:cNvSpPr txBox="1"/>
-          <p:nvPr/>
-        </p:nvSpPr>
-        <p:spPr>
-          <a:xfrm>
-            <a:off x="548640" y="594360"/>
-            <a:ext cx="11064240" cy="822960"/>
-          </a:xfrm>
-          <a:prstGeom prst="rect">
-            <a:avLst/>
-          </a:prstGeom>
-          <a:noFill/>
-        </p:spPr>
-        <p:txBody>
-          <a:bodyPr wrap="square" lIns="0" rIns="0" tIns="0" bIns="0" anchor="t">
-            <a:spAutoFit/>
-          </a:bodyPr>
-          <a:lstStyle/>
-          <a:p>
-            <a:pPr algn="l"/>
-            <a:r>
-              <a:rPr sz="3200" b="1" i="0">
-                <a:solidFill>
-                  <a:srgbClr val="1F2433"/>
-                </a:solidFill>
-                <a:latin typeface="Cambria"/>
-              </a:rPr>
-              <a:t>Unlocks are widely watched as volatility events</a:t>
-            </a:r>
-          </a:p>
-        </p:txBody>
-      </p:sp>
-      <p:sp>
-        <p:nvSpPr>
-          <p:cNvPr id="4" name="Footer"/>
-          <p:cNvSpPr txBox="1"/>
-          <p:nvPr/>
-        </p:nvSpPr>
-        <p:spPr>
-          <a:xfrm>
-            <a:off x="548640" y="6400800"/>
-            <a:ext cx="7315200" cy="274320"/>
-          </a:xfrm>
-          <a:prstGeom prst="rect">
-            <a:avLst/>
-          </a:prstGeom>
-          <a:noFill/>
-        </p:spPr>
-        <p:txBody>
-          <a:bodyPr wrap="square" lIns="0" rIns="0" tIns="0" bIns="0" anchor="t">
-            <a:spAutoFit/>
-          </a:bodyPr>
-          <a:lstStyle/>
-          <a:p>
-            <a:pPr algn="l"/>
-            <a:r>
-              <a:rPr sz="1000" b="0" i="0">
-                <a:solidFill>
-                  <a:srgbClr val="6B7280"/>
-                </a:solidFill>
-                <a:latin typeface="Calibri"/>
-              </a:rPr>
-              <a:t>MH6805 Group 7  |  Token unlocks and forward volatility</a:t>
-            </a:r>
-          </a:p>
-        </p:txBody>
-      </p:sp>
-      <p:sp>
-        <p:nvSpPr>
-          <p:cNvPr id="5" name="Slide number"/>
-          <p:cNvSpPr txBox="1"/>
-          <p:nvPr/>
-        </p:nvSpPr>
-        <p:spPr>
-          <a:xfrm>
-            <a:off x="10241280" y="6400800"/>
-            <a:ext cx="1399032" cy="274320"/>
-          </a:xfrm>
-          <a:prstGeom prst="rect">
-            <a:avLst/>
-          </a:prstGeom>
-          <a:noFill/>
-        </p:spPr>
-        <p:txBody>
-          <a:bodyPr wrap="square" lIns="0" rIns="0" tIns="0" bIns="0" anchor="t">
-            <a:spAutoFit/>
-          </a:bodyPr>
-          <a:lstStyle/>
-          <a:p>
-            <a:pPr algn="r"/>
-            <a:r>
-              <a:rPr sz="1000" b="0" i="0">
-                <a:solidFill>
-                  <a:srgbClr val="6B7280"/>
-                </a:solidFill>
-                <a:latin typeface="Calibri"/>
-              </a:rPr>
-              <a:t>2</a:t>
-            </a:r>
-          </a:p>
-        </p:txBody>
-      </p:sp>
-      <p:sp>
-        <p:nvSpPr>
-          <p:cNvPr id="6" name="Step card 1"/>
-          <p:cNvSpPr/>
-          <p:nvPr/>
-        </p:nvSpPr>
-        <p:spPr>
-          <a:xfrm>
-            <a:off x="548640" y="1828800"/>
-            <a:ext cx="2606040" cy="3566160"/>
-          </a:xfrm>
-          <a:prstGeom prst="roundRect">
-            <a:avLst>
-              <a:gd name="adj" fmla="val 8000"/>
-            </a:avLst>
-          </a:prstGeom>
-          <a:solidFill>
-            <a:srgbClr val="F2F4F7"/>
-          </a:solidFill>
-          <a:ln>
-            <a:noFill/>
-          </a:ln>
-          <a:effectLst/>
-        </p:spPr>
-        <p:style>
-          <a:lnRef idx="1">
-            <a:schemeClr val="accent1"/>
-          </a:lnRef>
-          <a:fillRef idx="3">
-            <a:schemeClr val="accent1"/>
-          </a:fillRef>
-          <a:effectRef idx="2">
-            <a:schemeClr val="accent1"/>
-          </a:effectRef>
-          <a:fontRef idx="minor">
-            <a:schemeClr val="lt1"/>
-          </a:fontRef>
-        </p:style>
-        <p:txBody>
-          <a:bodyPr rtlCol="0" anchor="ctr"/>
-          <a:lstStyle/>
-          <a:p>
-            <a:pPr algn="ctr"/>
-          </a:p>
-        </p:txBody>
-      </p:sp>
-      <p:sp>
-        <p:nvSpPr>
-          <p:cNvPr id="7" name="Oval 6"/>
-          <p:cNvSpPr/>
-          <p:nvPr/>
-        </p:nvSpPr>
-        <p:spPr>
-          <a:xfrm>
-            <a:off x="822959" y="2103120"/>
-            <a:ext cx="548640" cy="548640"/>
-          </a:xfrm>
-          <a:prstGeom prst="ellipse">
-            <a:avLst/>
-          </a:prstGeom>
-          <a:solidFill>
-            <a:srgbClr val="141B2D"/>
-          </a:solidFill>
-          <a:ln>
-            <a:noFill/>
-          </a:ln>
-          <a:effectLst/>
-        </p:spPr>
-        <p:style>
-          <a:lnRef idx="1">
-            <a:schemeClr val="accent1"/>
-          </a:lnRef>
-          <a:fillRef idx="3">
-            <a:schemeClr val="accent1"/>
-          </a:fillRef>
-          <a:effectRef idx="2">
-            <a:schemeClr val="accent1"/>
-          </a:effectRef>
-          <a:fontRef idx="minor">
-            <a:schemeClr val="lt1"/>
-          </a:fontRef>
-        </p:style>
-        <p:txBody>
-          <a:bodyPr rtlCol="0" anchor="ctr" lIns="0" rIns="0"/>
-          <a:lstStyle/>
-          <a:p>
-            <a:pPr algn="ctr"/>
-            <a:r>
-              <a:rPr sz="1800" b="1">
-                <a:solidFill>
-                  <a:srgbClr val="FFFFFF"/>
-                </a:solidFill>
-                <a:latin typeface="Calibri"/>
-              </a:rPr>
-              <a:t>1</a:t>
-            </a:r>
-          </a:p>
-        </p:txBody>
-      </p:sp>
-      <p:sp>
-        <p:nvSpPr>
-          <p:cNvPr id="8" name="TextBox 7"/>
-          <p:cNvSpPr txBox="1"/>
-          <p:nvPr/>
-        </p:nvSpPr>
-        <p:spPr>
-          <a:xfrm>
-            <a:off x="822959" y="2880360"/>
-            <a:ext cx="2103120" cy="731520"/>
-          </a:xfrm>
-          <a:prstGeom prst="rect">
-            <a:avLst/>
-          </a:prstGeom>
-          <a:noFill/>
-        </p:spPr>
-        <p:txBody>
-          <a:bodyPr wrap="square" lIns="0" rIns="0" tIns="0" bIns="0" anchor="t">
-            <a:spAutoFit/>
-          </a:bodyPr>
-          <a:lstStyle/>
-          <a:p>
-            <a:pPr algn="l"/>
-            <a:r>
-              <a:rPr sz="1900" b="1" i="0">
-                <a:solidFill>
-                  <a:srgbClr val="1F2433"/>
-                </a:solidFill>
-                <a:latin typeface="Cambria"/>
-              </a:rPr>
-              <a:t>Supply is locked</a:t>
-            </a:r>
-          </a:p>
-        </p:txBody>
-      </p:sp>
-      <p:sp>
-        <p:nvSpPr>
-          <p:cNvPr id="9" name="TextBox 8"/>
-          <p:cNvSpPr txBox="1"/>
-          <p:nvPr/>
-        </p:nvSpPr>
-        <p:spPr>
-          <a:xfrm>
-            <a:off x="822959" y="3657600"/>
-            <a:ext cx="2103120" cy="1645920"/>
-          </a:xfrm>
-          <a:prstGeom prst="rect">
-            <a:avLst/>
-          </a:prstGeom>
-          <a:noFill/>
-        </p:spPr>
-        <p:txBody>
-          <a:bodyPr wrap="square" lIns="0" rIns="0" tIns="0" bIns="0" anchor="t">
-            <a:spAutoFit/>
-          </a:bodyPr>
-          <a:lstStyle/>
-          <a:p>
-            <a:pPr algn="l"/>
-            <a:r>
-              <a:rPr sz="1500" b="0" i="0">
-                <a:solidFill>
-                  <a:srgbClr val="6B7280"/>
-                </a:solidFill>
-                <a:latin typeface="Calibri"/>
-              </a:rPr>
-              <a:t>Team, investor and ecosystem allocations vest over months or years</a:t>
-            </a:r>
-          </a:p>
-        </p:txBody>
-      </p:sp>
-      <p:sp>
-        <p:nvSpPr>
-          <p:cNvPr id="10" name="Step card 2"/>
-          <p:cNvSpPr/>
-          <p:nvPr/>
-        </p:nvSpPr>
-        <p:spPr>
-          <a:xfrm>
-            <a:off x="3364992" y="1828800"/>
-            <a:ext cx="2606040" cy="3566160"/>
-          </a:xfrm>
-          <a:prstGeom prst="roundRect">
-            <a:avLst>
-              <a:gd name="adj" fmla="val 8000"/>
-            </a:avLst>
-          </a:prstGeom>
-          <a:solidFill>
-            <a:srgbClr val="F2F4F7"/>
-          </a:solidFill>
-          <a:ln>
-            <a:noFill/>
-          </a:ln>
-          <a:effectLst/>
-        </p:spPr>
-        <p:style>
-          <a:lnRef idx="1">
-            <a:schemeClr val="accent1"/>
-          </a:lnRef>
-          <a:fillRef idx="3">
-            <a:schemeClr val="accent1"/>
-          </a:fillRef>
-          <a:effectRef idx="2">
-            <a:schemeClr val="accent1"/>
-          </a:effectRef>
-          <a:fontRef idx="minor">
-            <a:schemeClr val="lt1"/>
-          </a:fontRef>
-        </p:style>
-        <p:txBody>
-          <a:bodyPr rtlCol="0" anchor="ctr"/>
-          <a:lstStyle/>
-          <a:p>
-            <a:pPr algn="ctr"/>
-          </a:p>
-        </p:txBody>
-      </p:sp>
-      <p:sp>
-        <p:nvSpPr>
-          <p:cNvPr id="11" name="Oval 10"/>
-          <p:cNvSpPr/>
-          <p:nvPr/>
-        </p:nvSpPr>
-        <p:spPr>
-          <a:xfrm>
-            <a:off x="3639312" y="2103120"/>
-            <a:ext cx="548640" cy="548640"/>
-          </a:xfrm>
-          <a:prstGeom prst="ellipse">
-            <a:avLst/>
-          </a:prstGeom>
-          <a:solidFill>
-            <a:srgbClr val="141B2D"/>
-          </a:solidFill>
-          <a:ln>
-            <a:noFill/>
-          </a:ln>
-          <a:effectLst/>
-        </p:spPr>
-        <p:style>
-          <a:lnRef idx="1">
-            <a:schemeClr val="accent1"/>
-          </a:lnRef>
-          <a:fillRef idx="3">
-            <a:schemeClr val="accent1"/>
-          </a:fillRef>
-          <a:effectRef idx="2">
-            <a:schemeClr val="accent1"/>
-          </a:effectRef>
-          <a:fontRef idx="minor">
-            <a:schemeClr val="lt1"/>
-          </a:fontRef>
-        </p:style>
-        <p:txBody>
-          <a:bodyPr rtlCol="0" anchor="ctr" lIns="0" rIns="0"/>
-          <a:lstStyle/>
-          <a:p>
-            <a:pPr algn="ctr"/>
-            <a:r>
-              <a:rPr sz="1800" b="1">
-                <a:solidFill>
-                  <a:srgbClr val="FFFFFF"/>
-                </a:solidFill>
-                <a:latin typeface="Calibri"/>
-              </a:rPr>
-              <a:t>2</a:t>
-            </a:r>
-          </a:p>
-        </p:txBody>
-      </p:sp>
-      <p:sp>
-        <p:nvSpPr>
-          <p:cNvPr id="12" name="TextBox 11"/>
-          <p:cNvSpPr txBox="1"/>
-          <p:nvPr/>
-        </p:nvSpPr>
-        <p:spPr>
-          <a:xfrm>
-            <a:off x="3639312" y="2880360"/>
-            <a:ext cx="2103120" cy="731520"/>
-          </a:xfrm>
-          <a:prstGeom prst="rect">
-            <a:avLst/>
-          </a:prstGeom>
-          <a:noFill/>
-        </p:spPr>
-        <p:txBody>
-          <a:bodyPr wrap="square" lIns="0" rIns="0" tIns="0" bIns="0" anchor="t">
-            <a:spAutoFit/>
-          </a:bodyPr>
-          <a:lstStyle/>
-          <a:p>
-            <a:pPr algn="l"/>
-            <a:r>
-              <a:rPr sz="1900" b="1" i="0">
-                <a:solidFill>
-                  <a:srgbClr val="1F2433"/>
-                </a:solidFill>
-                <a:latin typeface="Cambria"/>
-              </a:rPr>
-              <a:t>Schedule is public</a:t>
-            </a:r>
-          </a:p>
-        </p:txBody>
-      </p:sp>
-      <p:sp>
-        <p:nvSpPr>
-          <p:cNvPr id="13" name="TextBox 12"/>
-          <p:cNvSpPr txBox="1"/>
-          <p:nvPr/>
-        </p:nvSpPr>
-        <p:spPr>
-          <a:xfrm>
-            <a:off x="3639312" y="3657600"/>
-            <a:ext cx="2103120" cy="1645920"/>
-          </a:xfrm>
-          <a:prstGeom prst="rect">
-            <a:avLst/>
-          </a:prstGeom>
-          <a:noFill/>
-        </p:spPr>
-        <p:txBody>
-          <a:bodyPr wrap="square" lIns="0" rIns="0" tIns="0" bIns="0" anchor="t">
-            <a:spAutoFit/>
-          </a:bodyPr>
-          <a:lstStyle/>
-          <a:p>
-            <a:pPr algn="l"/>
-            <a:r>
-              <a:rPr sz="1500" b="0" i="0">
-                <a:solidFill>
-                  <a:srgbClr val="6B7280"/>
-                </a:solidFill>
-                <a:latin typeface="Calibri"/>
-              </a:rPr>
-              <a:t>Unlock dates and sizes are published in advance (Tokenomist tracks 176 of our tokens)</a:t>
-            </a:r>
-          </a:p>
-        </p:txBody>
-      </p:sp>
-      <p:sp>
-        <p:nvSpPr>
-          <p:cNvPr id="14" name="Step card 3"/>
-          <p:cNvSpPr/>
-          <p:nvPr/>
-        </p:nvSpPr>
-        <p:spPr>
-          <a:xfrm>
-            <a:off x="6181344" y="1828800"/>
-            <a:ext cx="2606040" cy="3566160"/>
-          </a:xfrm>
-          <a:prstGeom prst="roundRect">
-            <a:avLst>
-              <a:gd name="adj" fmla="val 8000"/>
-            </a:avLst>
-          </a:prstGeom>
-          <a:solidFill>
-            <a:srgbClr val="F2F4F7"/>
-          </a:solidFill>
-          <a:ln>
-            <a:noFill/>
-          </a:ln>
-          <a:effectLst/>
-        </p:spPr>
-        <p:style>
-          <a:lnRef idx="1">
-            <a:schemeClr val="accent1"/>
-          </a:lnRef>
-          <a:fillRef idx="3">
-            <a:schemeClr val="accent1"/>
-          </a:fillRef>
-          <a:effectRef idx="2">
-            <a:schemeClr val="accent1"/>
-          </a:effectRef>
-          <a:fontRef idx="minor">
-            <a:schemeClr val="lt1"/>
-          </a:fontRef>
-        </p:style>
-        <p:txBody>
-          <a:bodyPr rtlCol="0" anchor="ctr"/>
-          <a:lstStyle/>
-          <a:p>
-            <a:pPr algn="ctr"/>
-          </a:p>
-        </p:txBody>
-      </p:sp>
-      <p:sp>
-        <p:nvSpPr>
-          <p:cNvPr id="15" name="Oval 14"/>
-          <p:cNvSpPr/>
-          <p:nvPr/>
-        </p:nvSpPr>
-        <p:spPr>
-          <a:xfrm>
-            <a:off x="6455664" y="2103120"/>
-            <a:ext cx="548640" cy="548640"/>
-          </a:xfrm>
-          <a:prstGeom prst="ellipse">
-            <a:avLst/>
-          </a:prstGeom>
-          <a:solidFill>
-            <a:srgbClr val="141B2D"/>
-          </a:solidFill>
-          <a:ln>
-            <a:noFill/>
-          </a:ln>
-          <a:effectLst/>
-        </p:spPr>
-        <p:style>
-          <a:lnRef idx="1">
-            <a:schemeClr val="accent1"/>
-          </a:lnRef>
-          <a:fillRef idx="3">
-            <a:schemeClr val="accent1"/>
-          </a:fillRef>
-          <a:effectRef idx="2">
-            <a:schemeClr val="accent1"/>
-          </a:effectRef>
-          <a:fontRef idx="minor">
-            <a:schemeClr val="lt1"/>
-          </a:fontRef>
-        </p:style>
-        <p:txBody>
-          <a:bodyPr rtlCol="0" anchor="ctr" lIns="0" rIns="0"/>
-          <a:lstStyle/>
-          <a:p>
-            <a:pPr algn="ctr"/>
-            <a:r>
-              <a:rPr sz="1800" b="1">
-                <a:solidFill>
-                  <a:srgbClr val="FFFFFF"/>
-                </a:solidFill>
-                <a:latin typeface="Calibri"/>
-              </a:rPr>
-              <a:t>3</a:t>
-            </a:r>
-          </a:p>
-        </p:txBody>
-      </p:sp>
-      <p:sp>
-        <p:nvSpPr>
-          <p:cNvPr id="16" name="TextBox 15"/>
-          <p:cNvSpPr txBox="1"/>
-          <p:nvPr/>
-        </p:nvSpPr>
-        <p:spPr>
-          <a:xfrm>
-            <a:off x="6455664" y="2880360"/>
-            <a:ext cx="2103120" cy="731520"/>
-          </a:xfrm>
-          <a:prstGeom prst="rect">
-            <a:avLst/>
-          </a:prstGeom>
-          <a:noFill/>
-        </p:spPr>
-        <p:txBody>
-          <a:bodyPr wrap="square" lIns="0" rIns="0" tIns="0" bIns="0" anchor="t">
-            <a:spAutoFit/>
-          </a:bodyPr>
-          <a:lstStyle/>
-          <a:p>
-            <a:pPr algn="l"/>
-            <a:r>
-              <a:rPr sz="1900" b="1" i="0">
-                <a:solidFill>
-                  <a:srgbClr val="1F2433"/>
-                </a:solidFill>
-                <a:latin typeface="Cambria"/>
-              </a:rPr>
-              <a:t>Narrative: more sellers</a:t>
-            </a:r>
-          </a:p>
-        </p:txBody>
-      </p:sp>
-      <p:sp>
-        <p:nvSpPr>
-          <p:cNvPr id="17" name="TextBox 16"/>
-          <p:cNvSpPr txBox="1"/>
-          <p:nvPr/>
-        </p:nvSpPr>
-        <p:spPr>
-          <a:xfrm>
-            <a:off x="6455664" y="3657600"/>
-            <a:ext cx="2103120" cy="1645920"/>
-          </a:xfrm>
-          <a:prstGeom prst="rect">
-            <a:avLst/>
-          </a:prstGeom>
-          <a:noFill/>
-        </p:spPr>
-        <p:txBody>
-          <a:bodyPr wrap="square" lIns="0" rIns="0" tIns="0" bIns="0" anchor="t">
-            <a:spAutoFit/>
-          </a:bodyPr>
-          <a:lstStyle/>
-          <a:p>
-            <a:pPr algn="l"/>
-            <a:r>
-              <a:rPr sz="1500" b="0" i="0">
-                <a:solidFill>
-                  <a:srgbClr val="6B7280"/>
-                </a:solidFill>
-                <a:latin typeface="Calibri"/>
-              </a:rPr>
-              <a:t>New supply reaches holders who may sell, so traders expect price swings</a:t>
-            </a:r>
-          </a:p>
-        </p:txBody>
-      </p:sp>
-      <p:sp>
-        <p:nvSpPr>
-          <p:cNvPr id="18" name="Step card 4"/>
-          <p:cNvSpPr/>
-          <p:nvPr/>
-        </p:nvSpPr>
-        <p:spPr>
-          <a:xfrm>
-            <a:off x="8997696" y="1828800"/>
-            <a:ext cx="2606040" cy="3566160"/>
-          </a:xfrm>
-          <a:prstGeom prst="roundRect">
-            <a:avLst>
-              <a:gd name="adj" fmla="val 8000"/>
-            </a:avLst>
-          </a:prstGeom>
-          <a:solidFill>
-            <a:srgbClr val="F2F4F7"/>
-          </a:solidFill>
-          <a:ln>
-            <a:noFill/>
-          </a:ln>
-          <a:effectLst/>
-        </p:spPr>
-        <p:style>
-          <a:lnRef idx="1">
-            <a:schemeClr val="accent1"/>
-          </a:lnRef>
-          <a:fillRef idx="3">
-            <a:schemeClr val="accent1"/>
-          </a:fillRef>
-          <a:effectRef idx="2">
-            <a:schemeClr val="accent1"/>
-          </a:effectRef>
-          <a:fontRef idx="minor">
-            <a:schemeClr val="lt1"/>
-          </a:fontRef>
-        </p:style>
-        <p:txBody>
-          <a:bodyPr rtlCol="0" anchor="ctr"/>
-          <a:lstStyle/>
-          <a:p>
-            <a:pPr algn="ctr"/>
-          </a:p>
-        </p:txBody>
-      </p:sp>
-      <p:sp>
-        <p:nvSpPr>
-          <p:cNvPr id="19" name="Oval 18"/>
-          <p:cNvSpPr/>
-          <p:nvPr/>
-        </p:nvSpPr>
-        <p:spPr>
-          <a:xfrm>
-            <a:off x="9272016" y="2103120"/>
-            <a:ext cx="548640" cy="548640"/>
-          </a:xfrm>
-          <a:prstGeom prst="ellipse">
-            <a:avLst/>
-          </a:prstGeom>
-          <a:solidFill>
-            <a:srgbClr val="EB6A35"/>
-          </a:solidFill>
-          <a:ln>
-            <a:noFill/>
-          </a:ln>
-          <a:effectLst/>
-        </p:spPr>
-        <p:style>
-          <a:lnRef idx="1">
-            <a:schemeClr val="accent1"/>
-          </a:lnRef>
-          <a:fillRef idx="3">
-            <a:schemeClr val="accent1"/>
-          </a:fillRef>
-          <a:effectRef idx="2">
-            <a:schemeClr val="accent1"/>
-          </a:effectRef>
-          <a:fontRef idx="minor">
-            <a:schemeClr val="lt1"/>
-          </a:fontRef>
-        </p:style>
-        <p:txBody>
-          <a:bodyPr rtlCol="0" anchor="ctr" lIns="0" rIns="0"/>
-          <a:lstStyle/>
-          <a:p>
-            <a:pPr algn="ctr"/>
-            <a:r>
-              <a:rPr sz="1800" b="1">
-                <a:solidFill>
-                  <a:srgbClr val="FFFFFF"/>
-                </a:solidFill>
-                <a:latin typeface="Calibri"/>
-              </a:rPr>
-              <a:t>4</a:t>
-            </a:r>
-          </a:p>
-        </p:txBody>
-      </p:sp>
-      <p:sp>
-        <p:nvSpPr>
-          <p:cNvPr id="20" name="TextBox 19"/>
-          <p:cNvSpPr txBox="1"/>
-          <p:nvPr/>
-        </p:nvSpPr>
-        <p:spPr>
-          <a:xfrm>
-            <a:off x="9272016" y="2880360"/>
-            <a:ext cx="2103120" cy="731520"/>
-          </a:xfrm>
-          <a:prstGeom prst="rect">
-            <a:avLst/>
-          </a:prstGeom>
-          <a:noFill/>
-        </p:spPr>
-        <p:txBody>
-          <a:bodyPr wrap="square" lIns="0" rIns="0" tIns="0" bIns="0" anchor="t">
-            <a:spAutoFit/>
-          </a:bodyPr>
-          <a:lstStyle/>
-          <a:p>
-            <a:pPr algn="l"/>
-            <a:r>
-              <a:rPr sz="1900" b="1" i="0">
-                <a:solidFill>
-                  <a:srgbClr val="1F2433"/>
-                </a:solidFill>
-                <a:latin typeface="Cambria"/>
-              </a:rPr>
-              <a:t>But volatility persists</a:t>
-            </a:r>
-          </a:p>
-        </p:txBody>
-      </p:sp>
-      <p:sp>
-        <p:nvSpPr>
-          <p:cNvPr id="21" name="TextBox 20"/>
-          <p:cNvSpPr txBox="1"/>
-          <p:nvPr/>
-        </p:nvSpPr>
-        <p:spPr>
-          <a:xfrm>
-            <a:off x="9272016" y="3657600"/>
-            <a:ext cx="2103120" cy="1645920"/>
-          </a:xfrm>
-          <a:prstGeom prst="rect">
-            <a:avLst/>
-          </a:prstGeom>
-          <a:noFill/>
-        </p:spPr>
-        <p:txBody>
-          <a:bodyPr wrap="square" lIns="0" rIns="0" tIns="0" bIns="0" anchor="t">
-            <a:spAutoFit/>
-          </a:bodyPr>
-          <a:lstStyle/>
-          <a:p>
-            <a:pPr algn="l"/>
-            <a:r>
-              <a:rPr sz="1500" b="0" i="0">
-                <a:solidFill>
-                  <a:srgbClr val="6B7280"/>
-                </a:solidFill>
-                <a:latin typeface="Calibri"/>
-              </a:rPr>
-              <a:t>Recent volatility is already a strong forecast, so the bar for a new feature is high</a:t>
-            </a:r>
-          </a:p>
-        </p:txBody>
-      </p:sp>
-      <p:sp>
-        <p:nvSpPr>
-          <p:cNvPr id="22" name="TextBox 21"/>
-          <p:cNvSpPr txBox="1"/>
-          <p:nvPr/>
-        </p:nvSpPr>
-        <p:spPr>
-          <a:xfrm>
-            <a:off x="548640" y="5715000"/>
-            <a:ext cx="11064240" cy="457200"/>
-          </a:xfrm>
-          <a:prstGeom prst="rect">
-            <a:avLst/>
-          </a:prstGeom>
-          <a:noFill/>
-        </p:spPr>
-        <p:txBody>
-          <a:bodyPr wrap="square" lIns="0" rIns="0" tIns="0" bIns="0" anchor="t">
-            <a:spAutoFit/>
-          </a:bodyPr>
-          <a:lstStyle/>
-          <a:p>
-            <a:pPr algn="l"/>
-            <a:r>
-              <a:rPr sz="1800" b="1" i="0">
-                <a:solidFill>
-                  <a:srgbClr val="1F2433"/>
-                </a:solidFill>
-                <a:latin typeface="Calibri"/>
-              </a:rPr>
-              <a:t>Our question: </a:t>
-            </a:r>
-            <a:r>
-              <a:rPr sz="1800" b="0" i="0">
-                <a:solidFill>
-                  <a:srgbClr val="1F2433"/>
-                </a:solidFill>
-                <a:latin typeface="Calibri"/>
-              </a:rPr>
-              <a:t>does the unlock calendar add forecasting power for 14-day forward volatility </a:t>
-            </a:r>
-            <a:r>
-              <a:rPr sz="1800" b="1" i="0">
-                <a:solidFill>
-                  <a:srgbClr val="EB6A35"/>
-                </a:solidFill>
-                <a:latin typeface="Calibri"/>
-              </a:rPr>
-              <a:t>beyond</a:t>
-            </a:r>
-            <a:r>
-              <a:rPr sz="1800" b="0" i="0">
-                <a:solidFill>
-                  <a:srgbClr val="1F2433"/>
-                </a:solidFill>
-                <a:latin typeface="Calibri"/>
-              </a:rPr>
-              <a:t> volatility persistence and the market regime?</a:t>
+              <a:t>Limits: one 2024–26 regime; schedules as curated in Sept 2026, so revisions are back-filled.   Thank you. Questions?</a:t>
             </a:r>
           </a:p>
         </p:txBody>
@@ -12939,7 +9728,7 @@
                 </a:solidFill>
                 <a:latin typeface="Calibri"/>
               </a:rPr>
-              <a:t>RESEARCH DESIGN</a:t>
+              <a:t>QUESTION AND DESIGN</a:t>
             </a:r>
           </a:p>
         </p:txBody>
@@ -12974,7 +9763,7 @@
                 </a:solidFill>
                 <a:latin typeface="Cambria"/>
               </a:rPr>
-              <a:t>One paired comparison answers the question</a:t>
+              <a:t>Do unlocks add anything beyond persistence?</a:t>
             </a:r>
           </a:p>
         </p:txBody>
@@ -13044,7 +9833,7 @@
                 </a:solidFill>
                 <a:latin typeface="Calibri"/>
               </a:rPr>
-              <a:t>3</a:t>
+              <a:t>2</a:t>
             </a:r>
           </a:p>
         </p:txBody>
@@ -13574,721 +10363,7 @@
                 </a:solidFill>
                 <a:latin typeface="Calibri"/>
               </a:rPr>
-              <a:t>Target: log of annualized realized volatility over the next 14 days. Metric: R² out-of-sample vs the persistence forecast (0 = ties “next 14 days look like the last 14”).</a:t>
-            </a:r>
-          </a:p>
-        </p:txBody>
-      </p:sp>
-    </p:spTree>
-  </p:cSld>
-  <p:clrMapOvr>
-    <a:masterClrMapping/>
-  </p:clrMapOvr>
-</p:sld>
-</file>
-
-<file path=ppt/slides/slide4.xml><?xml version="1.0" encoding="utf-8"?>
-<p:sld xmlns:a="http://schemas.openxmlformats.org/drawingml/2006/main" xmlns:p="http://schemas.openxmlformats.org/presentationml/2006/main" xmlns:r="http://schemas.openxmlformats.org/officeDocument/2006/relationships">
-  <p:cSld>
-    <p:bg>
-      <p:bgPr>
-        <a:solidFill>
-          <a:srgbClr val="FFFFFF"/>
-        </a:solidFill>
-        <a:effectLst/>
-      </p:bgPr>
-    </p:bg>
-    <p:spTree>
-      <p:nvGrpSpPr>
-        <p:cNvPr id="1" name=""/>
-        <p:cNvGrpSpPr/>
-        <p:nvPr/>
-      </p:nvGrpSpPr>
-      <p:grpSpPr/>
-      <p:sp>
-        <p:nvSpPr>
-          <p:cNvPr id="2" name="Kicker"/>
-          <p:cNvSpPr txBox="1"/>
-          <p:nvPr/>
-        </p:nvSpPr>
-        <p:spPr>
-          <a:xfrm>
-            <a:off x="548640" y="320040"/>
-            <a:ext cx="11064240" cy="274320"/>
-          </a:xfrm>
-          <a:prstGeom prst="rect">
-            <a:avLst/>
-          </a:prstGeom>
-          <a:noFill/>
-        </p:spPr>
-        <p:txBody>
-          <a:bodyPr wrap="square" lIns="0" rIns="0" tIns="0" bIns="0" anchor="t">
-            <a:spAutoFit/>
-          </a:bodyPr>
-          <a:lstStyle/>
-          <a:p>
-            <a:pPr algn="l"/>
-            <a:r>
-              <a:rPr sz="1200" b="1" i="0">
-                <a:solidFill>
-                  <a:srgbClr val="EB6A35"/>
-                </a:solidFill>
-                <a:latin typeface="Calibri"/>
-              </a:rPr>
-              <a:t>DATASET</a:t>
-            </a:r>
-          </a:p>
-        </p:txBody>
-      </p:sp>
-      <p:sp>
-        <p:nvSpPr>
-          <p:cNvPr id="3" name="Title"/>
-          <p:cNvSpPr txBox="1"/>
-          <p:nvPr/>
-        </p:nvSpPr>
-        <p:spPr>
-          <a:xfrm>
-            <a:off x="548640" y="594360"/>
-            <a:ext cx="11064240" cy="822960"/>
-          </a:xfrm>
-          <a:prstGeom prst="rect">
-            <a:avLst/>
-          </a:prstGeom>
-          <a:noFill/>
-        </p:spPr>
-        <p:txBody>
-          <a:bodyPr wrap="square" lIns="0" rIns="0" tIns="0" bIns="0" anchor="t">
-            <a:spAutoFit/>
-          </a:bodyPr>
-          <a:lstStyle/>
-          <a:p>
-            <a:pPr algn="l"/>
-            <a:r>
-              <a:rPr sz="3200" b="1" i="0">
-                <a:solidFill>
-                  <a:srgbClr val="1F2433"/>
-                </a:solidFill>
-                <a:latin typeface="Cambria"/>
-              </a:rPr>
-              <a:t>A daily panel of 176 tokens over two years</a:t>
-            </a:r>
-          </a:p>
-        </p:txBody>
-      </p:sp>
-      <p:sp>
-        <p:nvSpPr>
-          <p:cNvPr id="4" name="Footer"/>
-          <p:cNvSpPr txBox="1"/>
-          <p:nvPr/>
-        </p:nvSpPr>
-        <p:spPr>
-          <a:xfrm>
-            <a:off x="548640" y="6400800"/>
-            <a:ext cx="7315200" cy="274320"/>
-          </a:xfrm>
-          <a:prstGeom prst="rect">
-            <a:avLst/>
-          </a:prstGeom>
-          <a:noFill/>
-        </p:spPr>
-        <p:txBody>
-          <a:bodyPr wrap="square" lIns="0" rIns="0" tIns="0" bIns="0" anchor="t">
-            <a:spAutoFit/>
-          </a:bodyPr>
-          <a:lstStyle/>
-          <a:p>
-            <a:pPr algn="l"/>
-            <a:r>
-              <a:rPr sz="1000" b="0" i="0">
-                <a:solidFill>
-                  <a:srgbClr val="6B7280"/>
-                </a:solidFill>
-                <a:latin typeface="Calibri"/>
-              </a:rPr>
-              <a:t>MH6805 Group 7  |  Token unlocks and forward volatility</a:t>
-            </a:r>
-          </a:p>
-        </p:txBody>
-      </p:sp>
-      <p:sp>
-        <p:nvSpPr>
-          <p:cNvPr id="5" name="Slide number"/>
-          <p:cNvSpPr txBox="1"/>
-          <p:nvPr/>
-        </p:nvSpPr>
-        <p:spPr>
-          <a:xfrm>
-            <a:off x="10241280" y="6400800"/>
-            <a:ext cx="1399032" cy="274320"/>
-          </a:xfrm>
-          <a:prstGeom prst="rect">
-            <a:avLst/>
-          </a:prstGeom>
-          <a:noFill/>
-        </p:spPr>
-        <p:txBody>
-          <a:bodyPr wrap="square" lIns="0" rIns="0" tIns="0" bIns="0" anchor="t">
-            <a:spAutoFit/>
-          </a:bodyPr>
-          <a:lstStyle/>
-          <a:p>
-            <a:pPr algn="r"/>
-            <a:r>
-              <a:rPr sz="1000" b="0" i="0">
-                <a:solidFill>
-                  <a:srgbClr val="6B7280"/>
-                </a:solidFill>
-                <a:latin typeface="Calibri"/>
-              </a:rPr>
-              <a:t>4</a:t>
-            </a:r>
-          </a:p>
-        </p:txBody>
-      </p:sp>
-      <p:sp>
-        <p:nvSpPr>
-          <p:cNvPr id="6" name="TextBox 5"/>
-          <p:cNvSpPr txBox="1"/>
-          <p:nvPr/>
-        </p:nvSpPr>
-        <p:spPr>
-          <a:xfrm>
-            <a:off x="548640" y="1920240"/>
-            <a:ext cx="2651760" cy="1005840"/>
-          </a:xfrm>
-          <a:prstGeom prst="rect">
-            <a:avLst/>
-          </a:prstGeom>
-          <a:noFill/>
-        </p:spPr>
-        <p:txBody>
-          <a:bodyPr wrap="square" lIns="0" rIns="0" tIns="0" bIns="0" anchor="t">
-            <a:spAutoFit/>
-          </a:bodyPr>
-          <a:lstStyle/>
-          <a:p>
-            <a:pPr algn="l"/>
-            <a:r>
-              <a:rPr sz="4400" b="1" i="0">
-                <a:solidFill>
-                  <a:srgbClr val="EB6A35"/>
-                </a:solidFill>
-                <a:latin typeface="Cambria"/>
-              </a:rPr>
-              <a:t>176</a:t>
-            </a:r>
-          </a:p>
-        </p:txBody>
-      </p:sp>
-      <p:sp>
-        <p:nvSpPr>
-          <p:cNvPr id="7" name="TextBox 6"/>
-          <p:cNvSpPr txBox="1"/>
-          <p:nvPr/>
-        </p:nvSpPr>
-        <p:spPr>
-          <a:xfrm>
-            <a:off x="548640" y="2971800"/>
-            <a:ext cx="2651760" cy="365760"/>
-          </a:xfrm>
-          <a:prstGeom prst="rect">
-            <a:avLst/>
-          </a:prstGeom>
-          <a:noFill/>
-        </p:spPr>
-        <p:txBody>
-          <a:bodyPr wrap="square" lIns="0" rIns="0" tIns="0" bIns="0" anchor="t">
-            <a:spAutoFit/>
-          </a:bodyPr>
-          <a:lstStyle/>
-          <a:p>
-            <a:pPr algn="l"/>
-            <a:r>
-              <a:rPr sz="1800" b="1" i="0">
-                <a:solidFill>
-                  <a:srgbClr val="1F2433"/>
-                </a:solidFill>
-                <a:latin typeface="Calibri"/>
-              </a:rPr>
-              <a:t>tokens</a:t>
-            </a:r>
-          </a:p>
-        </p:txBody>
-      </p:sp>
-      <p:sp>
-        <p:nvSpPr>
-          <p:cNvPr id="8" name="TextBox 7"/>
-          <p:cNvSpPr txBox="1"/>
-          <p:nvPr/>
-        </p:nvSpPr>
-        <p:spPr>
-          <a:xfrm>
-            <a:off x="548640" y="3429000"/>
-            <a:ext cx="2514600" cy="1280160"/>
-          </a:xfrm>
-          <a:prstGeom prst="rect">
-            <a:avLst/>
-          </a:prstGeom>
-          <a:noFill/>
-        </p:spPr>
-        <p:txBody>
-          <a:bodyPr wrap="square" lIns="0" rIns="0" tIns="0" bIns="0" anchor="t">
-            <a:spAutoFit/>
-          </a:bodyPr>
-          <a:lstStyle/>
-          <a:p>
-            <a:pPr algn="l"/>
-            <a:r>
-              <a:rPr sz="1500" b="0" i="0">
-                <a:solidFill>
-                  <a:srgbClr val="6B7280"/>
-                </a:solidFill>
-                <a:latin typeface="Calibri"/>
-              </a:rPr>
-              <a:t>with a Tokenomist schedule and a Binance USDT pair</a:t>
-            </a:r>
-          </a:p>
-        </p:txBody>
-      </p:sp>
-      <p:sp>
-        <p:nvSpPr>
-          <p:cNvPr id="9" name="TextBox 8"/>
-          <p:cNvSpPr txBox="1"/>
-          <p:nvPr/>
-        </p:nvSpPr>
-        <p:spPr>
-          <a:xfrm>
-            <a:off x="3364992" y="1920240"/>
-            <a:ext cx="2651760" cy="1005840"/>
-          </a:xfrm>
-          <a:prstGeom prst="rect">
-            <a:avLst/>
-          </a:prstGeom>
-          <a:noFill/>
-        </p:spPr>
-        <p:txBody>
-          <a:bodyPr wrap="square" lIns="0" rIns="0" tIns="0" bIns="0" anchor="t">
-            <a:spAutoFit/>
-          </a:bodyPr>
-          <a:lstStyle/>
-          <a:p>
-            <a:pPr algn="l"/>
-            <a:r>
-              <a:rPr sz="4400" b="1" i="0">
-                <a:solidFill>
-                  <a:srgbClr val="141B2D"/>
-                </a:solidFill>
-                <a:latin typeface="Cambria"/>
-              </a:rPr>
-              <a:t>101,393</a:t>
-            </a:r>
-          </a:p>
-        </p:txBody>
-      </p:sp>
-      <p:sp>
-        <p:nvSpPr>
-          <p:cNvPr id="10" name="TextBox 9"/>
-          <p:cNvSpPr txBox="1"/>
-          <p:nvPr/>
-        </p:nvSpPr>
-        <p:spPr>
-          <a:xfrm>
-            <a:off x="3364992" y="2971800"/>
-            <a:ext cx="2651760" cy="365760"/>
-          </a:xfrm>
-          <a:prstGeom prst="rect">
-            <a:avLst/>
-          </a:prstGeom>
-          <a:noFill/>
-        </p:spPr>
-        <p:txBody>
-          <a:bodyPr wrap="square" lIns="0" rIns="0" tIns="0" bIns="0" anchor="t">
-            <a:spAutoFit/>
-          </a:bodyPr>
-          <a:lstStyle/>
-          <a:p>
-            <a:pPr algn="l"/>
-            <a:r>
-              <a:rPr sz="1800" b="1" i="0">
-                <a:solidFill>
-                  <a:srgbClr val="1F2433"/>
-                </a:solidFill>
-                <a:latin typeface="Calibri"/>
-              </a:rPr>
-              <a:t>token-days</a:t>
-            </a:r>
-          </a:p>
-        </p:txBody>
-      </p:sp>
-      <p:sp>
-        <p:nvSpPr>
-          <p:cNvPr id="11" name="TextBox 10"/>
-          <p:cNvSpPr txBox="1"/>
-          <p:nvPr/>
-        </p:nvSpPr>
-        <p:spPr>
-          <a:xfrm>
-            <a:off x="3364992" y="3429000"/>
-            <a:ext cx="2514600" cy="1280160"/>
-          </a:xfrm>
-          <a:prstGeom prst="rect">
-            <a:avLst/>
-          </a:prstGeom>
-          <a:noFill/>
-        </p:spPr>
-        <p:txBody>
-          <a:bodyPr wrap="square" lIns="0" rIns="0" tIns="0" bIns="0" anchor="t">
-            <a:spAutoFit/>
-          </a:bodyPr>
-          <a:lstStyle/>
-          <a:p>
-            <a:pPr algn="l"/>
-            <a:r>
-              <a:rPr sz="1500" b="0" i="0">
-                <a:solidFill>
-                  <a:srgbClr val="6B7280"/>
-                </a:solidFill>
-                <a:latin typeface="Calibri"/>
-              </a:rPr>
-              <a:t>2024-09-14 to 2026-08-15, median 701 days per token</a:t>
-            </a:r>
-          </a:p>
-        </p:txBody>
-      </p:sp>
-      <p:sp>
-        <p:nvSpPr>
-          <p:cNvPr id="12" name="TextBox 11"/>
-          <p:cNvSpPr txBox="1"/>
-          <p:nvPr/>
-        </p:nvSpPr>
-        <p:spPr>
-          <a:xfrm>
-            <a:off x="6181344" y="1920240"/>
-            <a:ext cx="2651760" cy="1005840"/>
-          </a:xfrm>
-          <a:prstGeom prst="rect">
-            <a:avLst/>
-          </a:prstGeom>
-          <a:noFill/>
-        </p:spPr>
-        <p:txBody>
-          <a:bodyPr wrap="square" lIns="0" rIns="0" tIns="0" bIns="0" anchor="t">
-            <a:spAutoFit/>
-          </a:bodyPr>
-          <a:lstStyle/>
-          <a:p>
-            <a:pPr algn="l"/>
-            <a:r>
-              <a:rPr sz="4400" b="1" i="0">
-                <a:solidFill>
-                  <a:srgbClr val="141B2D"/>
-                </a:solidFill>
-                <a:latin typeface="Cambria"/>
-              </a:rPr>
-              <a:t>32</a:t>
-            </a:r>
-          </a:p>
-        </p:txBody>
-      </p:sp>
-      <p:sp>
-        <p:nvSpPr>
-          <p:cNvPr id="13" name="TextBox 12"/>
-          <p:cNvSpPr txBox="1"/>
-          <p:nvPr/>
-        </p:nvSpPr>
-        <p:spPr>
-          <a:xfrm>
-            <a:off x="6181344" y="2971800"/>
-            <a:ext cx="2651760" cy="365760"/>
-          </a:xfrm>
-          <a:prstGeom prst="rect">
-            <a:avLst/>
-          </a:prstGeom>
-          <a:noFill/>
-        </p:spPr>
-        <p:txBody>
-          <a:bodyPr wrap="square" lIns="0" rIns="0" tIns="0" bIns="0" anchor="t">
-            <a:spAutoFit/>
-          </a:bodyPr>
-          <a:lstStyle/>
-          <a:p>
-            <a:pPr algn="l"/>
-            <a:r>
-              <a:rPr sz="1800" b="1" i="0">
-                <a:solidFill>
-                  <a:srgbClr val="1F2433"/>
-                </a:solidFill>
-                <a:latin typeface="Calibri"/>
-              </a:rPr>
-              <a:t>features</a:t>
-            </a:r>
-          </a:p>
-        </p:txBody>
-      </p:sp>
-      <p:sp>
-        <p:nvSpPr>
-          <p:cNvPr id="14" name="TextBox 13"/>
-          <p:cNvSpPr txBox="1"/>
-          <p:nvPr/>
-        </p:nvSpPr>
-        <p:spPr>
-          <a:xfrm>
-            <a:off x="6181344" y="3429000"/>
-            <a:ext cx="2514600" cy="1280160"/>
-          </a:xfrm>
-          <a:prstGeom prst="rect">
-            <a:avLst/>
-          </a:prstGeom>
-          <a:noFill/>
-        </p:spPr>
-        <p:txBody>
-          <a:bodyPr wrap="square" lIns="0" rIns="0" tIns="0" bIns="0" anchor="t">
-            <a:spAutoFit/>
-          </a:bodyPr>
-          <a:lstStyle/>
-          <a:p>
-            <a:pPr algn="l"/>
-            <a:r>
-              <a:rPr sz="1500" b="0" i="0">
-                <a:solidFill>
-                  <a:srgbClr val="6B7280"/>
-                </a:solidFill>
-                <a:latin typeface="Calibri"/>
-              </a:rPr>
-              <a:t>9 controls, 13 emission, 10 static; no missing values after cleaning</a:t>
-            </a:r>
-          </a:p>
-        </p:txBody>
-      </p:sp>
-      <p:sp>
-        <p:nvSpPr>
-          <p:cNvPr id="15" name="TextBox 14"/>
-          <p:cNvSpPr txBox="1"/>
-          <p:nvPr/>
-        </p:nvSpPr>
-        <p:spPr>
-          <a:xfrm>
-            <a:off x="8997696" y="1920240"/>
-            <a:ext cx="2651760" cy="1005840"/>
-          </a:xfrm>
-          <a:prstGeom prst="rect">
-            <a:avLst/>
-          </a:prstGeom>
-          <a:noFill/>
-        </p:spPr>
-        <p:txBody>
-          <a:bodyPr wrap="square" lIns="0" rIns="0" tIns="0" bIns="0" anchor="t">
-            <a:spAutoFit/>
-          </a:bodyPr>
-          <a:lstStyle/>
-          <a:p>
-            <a:pPr algn="l"/>
-            <a:r>
-              <a:rPr sz="4400" b="1" i="0">
-                <a:solidFill>
-                  <a:srgbClr val="141B2D"/>
-                </a:solidFill>
-                <a:latin typeface="Cambria"/>
-              </a:rPr>
-              <a:t>5</a:t>
-            </a:r>
-          </a:p>
-        </p:txBody>
-      </p:sp>
-      <p:sp>
-        <p:nvSpPr>
-          <p:cNvPr id="16" name="TextBox 15"/>
-          <p:cNvSpPr txBox="1"/>
-          <p:nvPr/>
-        </p:nvSpPr>
-        <p:spPr>
-          <a:xfrm>
-            <a:off x="8997696" y="2971800"/>
-            <a:ext cx="2651760" cy="365760"/>
-          </a:xfrm>
-          <a:prstGeom prst="rect">
-            <a:avLst/>
-          </a:prstGeom>
-          <a:noFill/>
-        </p:spPr>
-        <p:txBody>
-          <a:bodyPr wrap="square" lIns="0" rIns="0" tIns="0" bIns="0" anchor="t">
-            <a:spAutoFit/>
-          </a:bodyPr>
-          <a:lstStyle/>
-          <a:p>
-            <a:pPr algn="l"/>
-            <a:r>
-              <a:rPr sz="1800" b="1" i="0">
-                <a:solidFill>
-                  <a:srgbClr val="1F2433"/>
-                </a:solidFill>
-                <a:latin typeface="Calibri"/>
-              </a:rPr>
-              <a:t>walk-forward folds</a:t>
-            </a:r>
-          </a:p>
-        </p:txBody>
-      </p:sp>
-      <p:sp>
-        <p:nvSpPr>
-          <p:cNvPr id="17" name="TextBox 16"/>
-          <p:cNvSpPr txBox="1"/>
-          <p:nvPr/>
-        </p:nvSpPr>
-        <p:spPr>
-          <a:xfrm>
-            <a:off x="8997696" y="3429000"/>
-            <a:ext cx="2514600" cy="1280160"/>
-          </a:xfrm>
-          <a:prstGeom prst="rect">
-            <a:avLst/>
-          </a:prstGeom>
-          <a:noFill/>
-        </p:spPr>
-        <p:txBody>
-          <a:bodyPr wrap="square" lIns="0" rIns="0" tIns="0" bIns="0" anchor="t">
-            <a:spAutoFit/>
-          </a:bodyPr>
-          <a:lstStyle/>
-          <a:p>
-            <a:pPr algn="l"/>
-            <a:r>
-              <a:rPr sz="1500" b="0" i="0">
-                <a:solidFill>
-                  <a:srgbClr val="6B7280"/>
-                </a:solidFill>
-                <a:latin typeface="Calibri"/>
-              </a:rPr>
-              <a:t>90-day test windows after a 30-day embargo; rows never shuffled</a:t>
-            </a:r>
-          </a:p>
-        </p:txBody>
-      </p:sp>
-      <p:sp>
-        <p:nvSpPr>
-          <p:cNvPr id="18" name="Sources"/>
-          <p:cNvSpPr/>
-          <p:nvPr/>
-        </p:nvSpPr>
-        <p:spPr>
-          <a:xfrm>
-            <a:off x="548640" y="4892040"/>
-            <a:ext cx="11064240" cy="1234440"/>
-          </a:xfrm>
-          <a:prstGeom prst="roundRect">
-            <a:avLst>
-              <a:gd name="adj" fmla="val 8000"/>
-            </a:avLst>
-          </a:prstGeom>
-          <a:solidFill>
-            <a:srgbClr val="F2F4F7"/>
-          </a:solidFill>
-          <a:ln>
-            <a:noFill/>
-          </a:ln>
-          <a:effectLst/>
-        </p:spPr>
-        <p:style>
-          <a:lnRef idx="1">
-            <a:schemeClr val="accent1"/>
-          </a:lnRef>
-          <a:fillRef idx="3">
-            <a:schemeClr val="accent1"/>
-          </a:fillRef>
-          <a:effectRef idx="2">
-            <a:schemeClr val="accent1"/>
-          </a:effectRef>
-          <a:fontRef idx="minor">
-            <a:schemeClr val="lt1"/>
-          </a:fontRef>
-        </p:style>
-        <p:txBody>
-          <a:bodyPr rtlCol="0" anchor="ctr"/>
-          <a:lstStyle/>
-          <a:p>
-            <a:pPr algn="ctr"/>
-          </a:p>
-        </p:txBody>
-      </p:sp>
-      <p:sp>
-        <p:nvSpPr>
-          <p:cNvPr id="19" name="TextBox 18"/>
-          <p:cNvSpPr txBox="1"/>
-          <p:nvPr/>
-        </p:nvSpPr>
-        <p:spPr>
-          <a:xfrm>
-            <a:off x="822960" y="5074920"/>
-            <a:ext cx="10515600" cy="914400"/>
-          </a:xfrm>
-          <a:prstGeom prst="rect">
-            <a:avLst/>
-          </a:prstGeom>
-          <a:noFill/>
-        </p:spPr>
-        <p:txBody>
-          <a:bodyPr wrap="square" lIns="0" rIns="0" tIns="0" bIns="0" anchor="t">
-            <a:spAutoFit/>
-          </a:bodyPr>
-          <a:lstStyle/>
-          <a:p>
-            <a:pPr algn="l">
-              <a:spcAft>
-                <a:spcPts val="600"/>
-              </a:spcAft>
-            </a:pPr>
-            <a:r>
-              <a:rPr sz="1500" b="1" i="0">
-                <a:solidFill>
-                  <a:srgbClr val="1F2433"/>
-                </a:solidFill>
-                <a:latin typeface="Calibri"/>
-              </a:rPr>
-              <a:t>Prices: </a:t>
-            </a:r>
-            <a:r>
-              <a:rPr sz="1500" b="0" i="0">
-                <a:solidFill>
-                  <a:srgbClr val="1F2433"/>
-                </a:solidFill>
-                <a:latin typeface="Calibri"/>
-              </a:rPr>
-              <a:t>Binance spot daily klines (open, high, low, close).  </a:t>
-            </a:r>
-            <a:r>
-              <a:rPr sz="1500" b="1" i="0">
-                <a:solidFill>
-                  <a:srgbClr val="1F2433"/>
-                </a:solidFill>
-                <a:latin typeface="Calibri"/>
-              </a:rPr>
-              <a:t>Unlocks: </a:t>
-            </a:r>
-            <a:r>
-              <a:rPr sz="1500" b="0" i="0">
-                <a:solidFill>
-                  <a:srgbClr val="1F2433"/>
-                </a:solidFill>
-                <a:latin typeface="Calibri"/>
-              </a:rPr>
-              <a:t>Tokenomist API daily emission, unlock events and allocations, pulled 2026-09-14.</a:t>
-            </a:r>
-          </a:p>
-          <a:p>
-            <a:pPr algn="l">
-              <a:spcAft>
-                <a:spcPts val="600"/>
-              </a:spcAft>
-            </a:pPr>
-            <a:r>
-              <a:rPr sz="1500" b="0" i="0">
-                <a:solidFill>
-                  <a:srgbClr val="6B7280"/>
-                </a:solidFill>
-                <a:latin typeface="Calibri"/>
-              </a:rPr>
-              <a:t>Weekly panel (14,623 rows) used as a robustness check because daily 14-day targets overlap.</a:t>
+              <a:t>Why ask: traders treat big unlocks as volatility events, and the schedule is public in advance. Y = log forward 14-day realized volatility; metric = out-of-sample R² vs the persistence forecast.</a:t>
             </a:r>
           </a:p>
         </p:txBody>
@@ -14349,7 +10424,7 @@
                 </a:solidFill>
                 <a:latin typeface="Calibri"/>
               </a:rPr>
-              <a:t>EXPLORATORY ANALYSIS</a:t>
+              <a:t>DATA AND FIRST LOOK</a:t>
             </a:r>
           </a:p>
         </p:txBody>
@@ -14454,7 +10529,7 @@
                 </a:solidFill>
                 <a:latin typeface="Calibri"/>
               </a:rPr>
-              <a:t>5</a:t>
+              <a:t>3</a:t>
             </a:r>
           </a:p>
         </p:txBody>
@@ -14475,8 +10550,8 @@
         </p:blipFill>
         <p:spPr>
           <a:xfrm>
-            <a:off x="548640" y="1600200"/>
-            <a:ext cx="7152668" cy="4572000"/>
+            <a:off x="548640" y="2240280"/>
+            <a:ext cx="6151294" cy="3931920"/>
           </a:xfrm>
           <a:prstGeom prst="rect">
             <a:avLst/>
@@ -14485,154 +10560,14 @@
       </p:pic>
       <p:sp>
         <p:nvSpPr>
-          <p:cNvPr id="7" name="TextBox 6"/>
-          <p:cNvSpPr txBox="1"/>
-          <p:nvPr/>
-        </p:nvSpPr>
-        <p:spPr>
-          <a:xfrm>
-            <a:off x="7955279" y="1737360"/>
-            <a:ext cx="3657600" cy="731520"/>
-          </a:xfrm>
-          <a:prstGeom prst="rect">
-            <a:avLst/>
-          </a:prstGeom>
-          <a:noFill/>
-        </p:spPr>
-        <p:txBody>
-          <a:bodyPr wrap="square" lIns="0" rIns="0" tIns="0" bIns="0" anchor="t">
-            <a:spAutoFit/>
-          </a:bodyPr>
-          <a:lstStyle/>
-          <a:p>
-            <a:pPr algn="l"/>
-            <a:r>
-              <a:rPr sz="4400" b="1" i="0">
-                <a:solidFill>
-                  <a:srgbClr val="141B2D"/>
-                </a:solidFill>
-                <a:latin typeface="Cambria"/>
-              </a:rPr>
-              <a:t>0.14</a:t>
-            </a:r>
-          </a:p>
-        </p:txBody>
-      </p:sp>
-      <p:sp>
-        <p:nvSpPr>
-          <p:cNvPr id="8" name="TextBox 7"/>
-          <p:cNvSpPr txBox="1"/>
-          <p:nvPr/>
-        </p:nvSpPr>
-        <p:spPr>
-          <a:xfrm>
-            <a:off x="7955279" y="2514600"/>
-            <a:ext cx="3657600" cy="731520"/>
-          </a:xfrm>
-          <a:prstGeom prst="rect">
-            <a:avLst/>
-          </a:prstGeom>
-          <a:noFill/>
-        </p:spPr>
-        <p:txBody>
-          <a:bodyPr wrap="square" lIns="0" rIns="0" tIns="0" bIns="0" anchor="t">
-            <a:spAutoFit/>
-          </a:bodyPr>
-          <a:lstStyle/>
-          <a:p>
-            <a:pPr algn="l"/>
-            <a:r>
-              <a:rPr sz="1500" b="0" i="0">
-                <a:solidFill>
-                  <a:srgbClr val="6B7280"/>
-                </a:solidFill>
-                <a:latin typeface="Calibri"/>
-              </a:rPr>
-              <a:t>pooled Spearman ρ between 30-day unlock pressure and forward volatility</a:t>
-            </a:r>
-          </a:p>
-        </p:txBody>
-      </p:sp>
-      <p:sp>
-        <p:nvSpPr>
-          <p:cNvPr id="9" name="TextBox 8"/>
-          <p:cNvSpPr txBox="1"/>
-          <p:nvPr/>
-        </p:nvSpPr>
-        <p:spPr>
-          <a:xfrm>
-            <a:off x="7955279" y="3246120"/>
-            <a:ext cx="3657600" cy="731520"/>
-          </a:xfrm>
-          <a:prstGeom prst="rect">
-            <a:avLst/>
-          </a:prstGeom>
-          <a:noFill/>
-        </p:spPr>
-        <p:txBody>
-          <a:bodyPr wrap="square" lIns="0" rIns="0" tIns="0" bIns="0" anchor="t">
-            <a:spAutoFit/>
-          </a:bodyPr>
-          <a:lstStyle/>
-          <a:p>
-            <a:pPr algn="l"/>
-            <a:r>
-              <a:rPr sz="4400" b="1" i="0">
-                <a:solidFill>
-                  <a:srgbClr val="141B2D"/>
-                </a:solidFill>
-                <a:latin typeface="Cambria"/>
-              </a:rPr>
-              <a:t>74%</a:t>
-            </a:r>
-          </a:p>
-        </p:txBody>
-      </p:sp>
-      <p:sp>
-        <p:nvSpPr>
-          <p:cNvPr id="10" name="TextBox 9"/>
-          <p:cNvSpPr txBox="1"/>
-          <p:nvPr/>
-        </p:nvSpPr>
-        <p:spPr>
-          <a:xfrm>
-            <a:off x="7955279" y="4023360"/>
-            <a:ext cx="3657600" cy="731520"/>
-          </a:xfrm>
-          <a:prstGeom prst="rect">
-            <a:avLst/>
-          </a:prstGeom>
-          <a:noFill/>
-        </p:spPr>
-        <p:txBody>
-          <a:bodyPr wrap="square" lIns="0" rIns="0" tIns="0" bIns="0" anchor="t">
-            <a:spAutoFit/>
-          </a:bodyPr>
-          <a:lstStyle/>
-          <a:p>
-            <a:pPr algn="l"/>
-            <a:r>
-              <a:rPr sz="1500" b="0" i="0">
-                <a:solidFill>
-                  <a:srgbClr val="6B7280"/>
-                </a:solidFill>
-                <a:latin typeface="Calibri"/>
-              </a:rPr>
-              <a:t>of tokens show a positive correlation (per-token median ρ = 0.22)</a:t>
-            </a:r>
-          </a:p>
-        </p:txBody>
-      </p:sp>
-      <p:sp>
-        <p:nvSpPr>
-          <p:cNvPr id="11" name="But"/>
+          <p:cNvPr id="7" name="Data strip"/>
           <p:cNvSpPr/>
           <p:nvPr/>
         </p:nvSpPr>
         <p:spPr>
           <a:xfrm>
-            <a:off x="7955279" y="4846320"/>
-            <a:ext cx="3657600" cy="1280160"/>
+            <a:off x="548640" y="1554480"/>
+            <a:ext cx="11064240" cy="502920"/>
           </a:xfrm>
           <a:prstGeom prst="roundRect">
             <a:avLst>
@@ -14640,7 +10575,7 @@
             </a:avLst>
           </a:prstGeom>
           <a:solidFill>
-            <a:srgbClr val="FDECE4"/>
+            <a:srgbClr val="F2F4F7"/>
           </a:solidFill>
           <a:ln>
             <a:noFill/>
@@ -14671,14 +10606,280 @@
       </p:sp>
       <p:sp>
         <p:nvSpPr>
+          <p:cNvPr id="8" name="TextBox 7"/>
+          <p:cNvSpPr txBox="1"/>
+          <p:nvPr/>
+        </p:nvSpPr>
+        <p:spPr>
+          <a:xfrm>
+            <a:off x="777240" y="1554480"/>
+            <a:ext cx="10698480" cy="502920"/>
+          </a:xfrm>
+          <a:prstGeom prst="rect">
+            <a:avLst/>
+          </a:prstGeom>
+          <a:noFill/>
+        </p:spPr>
+        <p:txBody>
+          <a:bodyPr wrap="square" lIns="0" rIns="0" tIns="0" bIns="0" anchor="ctr">
+            <a:spAutoFit/>
+          </a:bodyPr>
+          <a:lstStyle/>
+          <a:p>
+            <a:pPr algn="l"/>
+            <a:r>
+              <a:rPr sz="1400" b="1" i="0">
+                <a:solidFill>
+                  <a:srgbClr val="1F2433"/>
+                </a:solidFill>
+                <a:latin typeface="Calibri"/>
+              </a:rPr>
+              <a:t>176 tokens</a:t>
+            </a:r>
+            <a:r>
+              <a:rPr sz="1400" b="0" i="0">
+                <a:solidFill>
+                  <a:srgbClr val="1F2433"/>
+                </a:solidFill>
+                <a:latin typeface="Calibri"/>
+              </a:rPr>
+              <a:t>  ·  101,393 token-days, 2024-09-14 to 2026-08-15  ·  </a:t>
+            </a:r>
+            <a:r>
+              <a:rPr sz="1400" b="1" i="0">
+                <a:solidFill>
+                  <a:srgbClr val="1F2433"/>
+                </a:solidFill>
+                <a:latin typeface="Calibri"/>
+              </a:rPr>
+              <a:t>prices: </a:t>
+            </a:r>
+            <a:r>
+              <a:rPr sz="1400" b="0" i="0">
+                <a:solidFill>
+                  <a:srgbClr val="1F2433"/>
+                </a:solidFill>
+                <a:latin typeface="Calibri"/>
+              </a:rPr>
+              <a:t>Binance daily klines  ·  </a:t>
+            </a:r>
+            <a:r>
+              <a:rPr sz="1400" b="1" i="0">
+                <a:solidFill>
+                  <a:srgbClr val="1F2433"/>
+                </a:solidFill>
+                <a:latin typeface="Calibri"/>
+              </a:rPr>
+              <a:t>unlocks: </a:t>
+            </a:r>
+            <a:r>
+              <a:rPr sz="1400" b="0" i="0">
+                <a:solidFill>
+                  <a:srgbClr val="1F2433"/>
+                </a:solidFill>
+                <a:latin typeface="Calibri"/>
+              </a:rPr>
+              <a:t>Tokenomist schedules  ·  32 features</a:t>
+            </a:r>
+          </a:p>
+        </p:txBody>
+      </p:sp>
+      <p:sp>
+        <p:nvSpPr>
+          <p:cNvPr id="9" name="TextBox 8"/>
+          <p:cNvSpPr txBox="1"/>
+          <p:nvPr/>
+        </p:nvSpPr>
+        <p:spPr>
+          <a:xfrm>
+            <a:off x="7955279" y="2286000"/>
+            <a:ext cx="3657600" cy="731520"/>
+          </a:xfrm>
+          <a:prstGeom prst="rect">
+            <a:avLst/>
+          </a:prstGeom>
+          <a:noFill/>
+        </p:spPr>
+        <p:txBody>
+          <a:bodyPr wrap="square" lIns="0" rIns="0" tIns="0" bIns="0" anchor="t">
+            <a:spAutoFit/>
+          </a:bodyPr>
+          <a:lstStyle/>
+          <a:p>
+            <a:pPr algn="l"/>
+            <a:r>
+              <a:rPr sz="4000" b="1" i="0">
+                <a:solidFill>
+                  <a:srgbClr val="141B2D"/>
+                </a:solidFill>
+                <a:latin typeface="Cambria"/>
+              </a:rPr>
+              <a:t>0.14</a:t>
+            </a:r>
+          </a:p>
+        </p:txBody>
+      </p:sp>
+      <p:sp>
+        <p:nvSpPr>
+          <p:cNvPr id="10" name="TextBox 9"/>
+          <p:cNvSpPr txBox="1"/>
+          <p:nvPr/>
+        </p:nvSpPr>
+        <p:spPr>
+          <a:xfrm>
+            <a:off x="7955279" y="2971800"/>
+            <a:ext cx="3657600" cy="731520"/>
+          </a:xfrm>
+          <a:prstGeom prst="rect">
+            <a:avLst/>
+          </a:prstGeom>
+          <a:noFill/>
+        </p:spPr>
+        <p:txBody>
+          <a:bodyPr wrap="square" lIns="0" rIns="0" tIns="0" bIns="0" anchor="t">
+            <a:spAutoFit/>
+          </a:bodyPr>
+          <a:lstStyle/>
+          <a:p>
+            <a:pPr algn="l"/>
+            <a:r>
+              <a:rPr sz="1400" b="0" i="0">
+                <a:solidFill>
+                  <a:srgbClr val="6B7280"/>
+                </a:solidFill>
+                <a:latin typeface="Calibri"/>
+              </a:rPr>
+              <a:t>pooled Spearman ρ between 30-day unlock pressure and forward volatility</a:t>
+            </a:r>
+          </a:p>
+        </p:txBody>
+      </p:sp>
+      <p:sp>
+        <p:nvSpPr>
+          <p:cNvPr id="11" name="TextBox 10"/>
+          <p:cNvSpPr txBox="1"/>
+          <p:nvPr/>
+        </p:nvSpPr>
+        <p:spPr>
+          <a:xfrm>
+            <a:off x="7955279" y="3657600"/>
+            <a:ext cx="3657600" cy="731520"/>
+          </a:xfrm>
+          <a:prstGeom prst="rect">
+            <a:avLst/>
+          </a:prstGeom>
+          <a:noFill/>
+        </p:spPr>
+        <p:txBody>
+          <a:bodyPr wrap="square" lIns="0" rIns="0" tIns="0" bIns="0" anchor="t">
+            <a:spAutoFit/>
+          </a:bodyPr>
+          <a:lstStyle/>
+          <a:p>
+            <a:pPr algn="l"/>
+            <a:r>
+              <a:rPr sz="4000" b="1" i="0">
+                <a:solidFill>
+                  <a:srgbClr val="141B2D"/>
+                </a:solidFill>
+                <a:latin typeface="Cambria"/>
+              </a:rPr>
+              <a:t>74%</a:t>
+            </a:r>
+          </a:p>
+        </p:txBody>
+      </p:sp>
+      <p:sp>
+        <p:nvSpPr>
           <p:cNvPr id="12" name="TextBox 11"/>
           <p:cNvSpPr txBox="1"/>
           <p:nvPr/>
         </p:nvSpPr>
         <p:spPr>
           <a:xfrm>
-            <a:off x="8183879" y="4983480"/>
-            <a:ext cx="3200400" cy="1051560"/>
+            <a:off x="7955279" y="4343400"/>
+            <a:ext cx="3657600" cy="731520"/>
+          </a:xfrm>
+          <a:prstGeom prst="rect">
+            <a:avLst/>
+          </a:prstGeom>
+          <a:noFill/>
+        </p:spPr>
+        <p:txBody>
+          <a:bodyPr wrap="square" lIns="0" rIns="0" tIns="0" bIns="0" anchor="t">
+            <a:spAutoFit/>
+          </a:bodyPr>
+          <a:lstStyle/>
+          <a:p>
+            <a:pPr algn="l"/>
+            <a:r>
+              <a:rPr sz="1400" b="0" i="0">
+                <a:solidFill>
+                  <a:srgbClr val="6B7280"/>
+                </a:solidFill>
+                <a:latin typeface="Calibri"/>
+              </a:rPr>
+              <a:t>of tokens show a positive correlation (per-token median ρ = 0.22)</a:t>
+            </a:r>
+          </a:p>
+        </p:txBody>
+      </p:sp>
+      <p:sp>
+        <p:nvSpPr>
+          <p:cNvPr id="13" name="But"/>
+          <p:cNvSpPr/>
+          <p:nvPr/>
+        </p:nvSpPr>
+        <p:spPr>
+          <a:xfrm>
+            <a:off x="7955279" y="5074920"/>
+            <a:ext cx="3657600" cy="1097280"/>
+          </a:xfrm>
+          <a:prstGeom prst="roundRect">
+            <a:avLst>
+              <a:gd name="adj" fmla="val 8000"/>
+            </a:avLst>
+          </a:prstGeom>
+          <a:solidFill>
+            <a:srgbClr val="FDECE4"/>
+          </a:solidFill>
+          <a:ln>
+            <a:noFill/>
+          </a:ln>
+          <a:effectLst/>
+        </p:spPr>
+        <p:style>
+          <a:lnRef idx="1">
+            <a:schemeClr val="accent1"/>
+          </a:lnRef>
+          <a:fillRef idx="3">
+            <a:schemeClr val="accent1"/>
+          </a:fillRef>
+          <a:effectRef idx="2">
+            <a:schemeClr val="accent1"/>
+          </a:effectRef>
+          <a:fontRef idx="minor">
+            <a:schemeClr val="lt1"/>
+          </a:fontRef>
+        </p:style>
+        <p:txBody>
+          <a:bodyPr rtlCol="0" anchor="ctr"/>
+          <a:lstStyle/>
+          <a:p>
+            <a:pPr algn="ctr"/>
+          </a:p>
+        </p:txBody>
+      </p:sp>
+      <p:sp>
+        <p:nvSpPr>
+          <p:cNvPr id="14" name="TextBox 13"/>
+          <p:cNvSpPr txBox="1"/>
+          <p:nvPr/>
+        </p:nvSpPr>
+        <p:spPr>
+          <a:xfrm>
+            <a:off x="8183879" y="5166360"/>
+            <a:ext cx="3200400" cy="914400"/>
           </a:xfrm>
           <a:prstGeom prst="rect">
             <a:avLst/>
@@ -14874,7 +11075,7 @@
                 </a:solidFill>
                 <a:latin typeface="Calibri"/>
               </a:rPr>
-              <a:t>6</a:t>
+              <a:t>4</a:t>
             </a:r>
           </a:p>
         </p:txBody>
@@ -16368,7 +12569,7 @@
                 </a:solidFill>
                 <a:latin typeface="Calibri"/>
               </a:rPr>
-              <a:t>7</a:t>
+              <a:t>5</a:t>
             </a:r>
           </a:p>
         </p:txBody>
@@ -17650,7 +13851,7 @@
                 </a:solidFill>
                 <a:latin typeface="Calibri"/>
               </a:rPr>
-              <a:t>8</a:t>
+              <a:t>6</a:t>
             </a:r>
           </a:p>
         </p:txBody>
@@ -18044,7 +14245,7 @@
                 </a:solidFill>
                 <a:latin typeface="Calibri"/>
               </a:rPr>
-              <a:t>9</a:t>
+              <a:t>7</a:t>
             </a:r>
           </a:p>
         </p:txBody>

</xml_diff>

<commit_message>
Presentation script for the 8-minute talk; speaker notes built from it
report/PRESENTATION_SCRIPT.md: word-for-word script for the 12 slides, about
940 words (7 min 20 s at 130 wpm), 300-330 words per member, with per-slide
timings, hand-overs and short Q&A answers. build_slides.py now writes each
slide's speaker notes from the script, so the two cannot drift apart.
</commit_message>
<xml_diff>
--- a/report/Group7_Presentation_DRAFT.pptx
+++ b/report/Group7_Presentation_DRAFT.pptx
@@ -1792,13 +1792,13 @@
           <a:lstStyle/>
           <a:p>
             <a:r>
-              <a:t>Speaker: [Member 1]</a:t>
+              <a:t>Speaker: [Member 1]  (~20 s)</a:t>
             </a:r>
           </a:p>
           <a:p/>
           <a:p>
             <a:r>
-              <a:t>Introduce the group and the question in one sentence: crypto tokens publish their unlock calendars in advance; we test whether that calendar helps forecast how volatile a token will be over the next two weeks, beyond what its recent volatility already tells us.</a:t>
+              <a:t>Good morning, we are Group 7: [Member 1], [Member 2] and [Member 3]. Crypto tokens publish their unlock calendars months in advance. Our question: does that calendar help predict how volatile a token will be over the next two weeks?</a:t>
             </a:r>
           </a:p>
         </p:txBody>
@@ -1868,13 +1868,19 @@
           <a:lstStyle/>
           <a:p>
             <a:r>
-              <a:t>Speaker: [Member 2]</a:t>
+              <a:t>Speaker: [Member 2]  (~45 s)</a:t>
             </a:r>
           </a:p>
           <a:p/>
           <a:p>
             <a:r>
-              <a:t>We explain each model with the tool that suits it. Random Forest permutation importance: shuffling all controls costs three times more test RMSE than shuffling all 13 emission features, and partial dependence on unlock pressure is flat. Coefficients: the largest unlock coefficient is positive, as the narrative says, but five times smaller than trailing volatility, and Elastic Net drops everything in two folds. A shallow tree never splits on an unlock feature. Neighbours: for the most unlock-heavy token-day there is no comparable history, so KNN falls back on trailing volatility. Hand over: on average the answer is no; [Member 3] shows where the remaining errors are and whether any of this matters in practice.</a:t>
+              <a:t>We also looked inside each model with the tool that suits it. In the Random Forest, shuffling the controls hurts three times more than shuffling all emission features. In LightGBM, controls take 92% of the split gain. Ridge's largest unlock coefficient is positive, as the story predicts, but five times smaller than trailing volatility. A shallow tree never splits on an unlock feature. And for the most unlock-heavy token, KNN finds no comparable history at all.</a:t>
+            </a:r>
+          </a:p>
+          <a:p/>
+          <a:p>
+            <a:r>
+              <a:t>So on average the answer is no. [Member 3] will show where the remaining errors are, and whether this matters in practice.</a:t>
             </a:r>
           </a:p>
         </p:txBody>
@@ -1944,13 +1950,19 @@
           <a:lstStyle/>
           <a:p>
             <a:r>
-              <a:t>Speaker: [Member 3]</a:t>
+              <a:t>Speaker: [Member 3]  (~45 s)</a:t>
             </a:r>
           </a:p>
           <a:p/>
           <a:p>
             <a:r>
-              <a:t>We pool all test rows and ask where the errors are. If unlock features carried signal, FULL should beat CONTROLS where more than 5% of the float unlocks, or where a cliff is two weeks away. The opposite happens: positive bars mean adding unlock features made the forecast worse. What remains is regression to the mean: too high for tokens that turn calm, too low for tokens that spike. The models' real gain over persistence is fewer large misses.</a:t>
+              <a:t>Thank you. If unlocks carried signal, it would show where unlocks are largest. Bars above zero mean the unlock features made forecasts worse. Where more than 5% of the float unlocks within a month, they make Ridge and the Random Forest worse, and LightGBM gains nothing. The same two models are also worse just before a cliff unlock.</a:t>
+            </a:r>
+          </a:p>
+          <a:p/>
+          <a:p>
+            <a:r>
+              <a:t>What the models really fix is large mistakes. Forecasts off by more than a factor of two fall from 18% under persistence to 12%. Most misses that remain are over-forecasts for tokens that suddenly calm down.</a:t>
             </a:r>
           </a:p>
         </p:txBody>
@@ -2020,13 +2032,19 @@
           <a:lstStyle/>
           <a:p>
             <a:r>
-              <a:t>Speaker: [Member 3]</a:t>
+              <a:t>Speaker: [Member 3]  (~25 s)</a:t>
             </a:r>
           </a:p>
           <a:p/>
           <a:p>
             <a:r>
-              <a:t>We re-ran the comparison on the weekly panel, on three alternative volatility targets and on the tokens Tokenomist curates by hand, where schedules should be most accurate. The largest gain anywhere is +0.017, for the Random Forest on the curated subsample, still about a tenth of the fold-to-fold spread. Ridge on the Parkinson target is the only case that wins all five folds, by 0.011. LightGBM shows the same picture, and on the small weekly panel it falls just below the training mean. Classification tells the same story: logistic regression on controls beats ranking by recent volatility (AUC 0.69 vs 0.65), and adding unlock features lowers AUC for both high-volatility events.</a:t>
+              <a:t>The result holds with weekly data, three other volatility measures, and only the hand-curated tokens. The largest gain anywhere is 0.017, a tenth of the fold-to-fold spread.</a:t>
+            </a:r>
+          </a:p>
+          <a:p/>
+          <a:p>
+            <a:r>
+              <a:t>Classification agrees. Logistic regression on controls spots the most volatile tokens better than ranking by recent volatility, but unlock features slightly lower its AUC.</a:t>
             </a:r>
           </a:p>
         </p:txBody>
@@ -2096,13 +2114,19 @@
           <a:lstStyle/>
           <a:p>
             <a:r>
-              <a:t>Speaker: [Member 3]</a:t>
+              <a:t>Speaker: [Member 3]  (~40 s)</a:t>
             </a:r>
           </a:p>
           <a:p/>
           <a:p>
             <a:r>
-              <a:t>Translate the errors into volatility points. The typical error is large for every forecast, and on the median the model is no better than persistence. What it does buy is fewer forecasts that are off by a factor of two, which is what matters for margin and position limits. Unlock features add nothing to that and cost a data subscription and a maintenance pipeline, so our recommendation to a risk desk is not to pay for them as a volatility input, and to keep a human in the loop for the cases on the right.</a:t>
+              <a:t>Is any of this useful in practice? Errors are still large: the typical miss is about 0.27 volatility points, a third of the level, and on a typical day the model is no closer than persistence. Its value is avoiding the big misses that matter for margins and position limits.</a:t>
+            </a:r>
+          </a:p>
+          <a:p/>
+          <a:p>
+            <a:r>
+              <a:t>Unlock features add nothing there, yet cost a data subscription and a pipeline. Our advice to a risk desk: don't pay for them as a volatility input, and keep a person in the loop for the cases on the right.</a:t>
             </a:r>
           </a:p>
         </p:txBody>
@@ -2172,13 +2196,39 @@
           <a:lstStyle/>
           <a:p>
             <a:r>
-              <a:t>Speaker: [Member 3]</a:t>
+              <a:t>Speaker: [Member 3]  (~35 s)</a:t>
             </a:r>
           </a:p>
           <a:p/>
           <a:p>
             <a:r>
-              <a:t>State the answer plainly: once you know a token's recent volatility and the market regime, its unlock calendar does not help forecast the next two weeks. Give the interpretation: the unconditional correlation comes from young, volatile tokens having big unlocks. Practical takeaway: do not bump a volatility forecast just because an unlock is coming. Limitations in one breath: one calm-to-moderate regime, and back-filled schedule revisions, which can only flatter the unlock features. Then invite questions; each member takes questions on their own block.</a:t>
+              <a:t>To conclude:</a:t>
+            </a:r>
+          </a:p>
+          <a:p>
+            <a:r>
+              <a:t>• The raw link is real, but trailing volatility already explains it.</a:t>
+            </a:r>
+          </a:p>
+          <a:p>
+            <a:r>
+              <a:t>• Six models agree.</a:t>
+            </a:r>
+          </a:p>
+          <a:p>
+            <a:r>
+              <a:t>• The best forecaster is a simple Ridge model on the controls.</a:t>
+            </a:r>
+          </a:p>
+          <a:p>
+            <a:r>
+              <a:t>• This fits an efficient market: schedules are public months ahead, so the effect is likely priced in early.</a:t>
+            </a:r>
+          </a:p>
+          <a:p/>
+          <a:p>
+            <a:r>
+              <a:t>Our limits are one market regime and today's schedule versions, which can only flatter unlocks. Thank you. We are happy to take questions.</a:t>
             </a:r>
           </a:p>
         </p:txBody>
@@ -2248,13 +2298,19 @@
           <a:lstStyle/>
           <a:p>
             <a:r>
-              <a:t>Speaker: [Member 1]</a:t>
+              <a:t>Speaker: [Member 1]  (~45 s)</a:t>
             </a:r>
           </a:p>
           <a:p/>
           <a:p>
             <a:r>
-              <a:t>Motivation: most token supply is locked at launch and released on a published schedule, and traders treat big unlocks as volatility events. The schedule is public in advance, so it is a legitimate forward-looking input, but volatility is very persistent, so the bar is high. Design: every model is trained twice with the same rows, folds and tuning grid: once on the nine controls and once with the 23 unlock and static features added. The difference in out-of-sample R squared is the finding. We decided up front that a null result is a valid result and we did not tune to change it.</a:t>
+              <a:t>Most of a token's supply is locked at launch and released on a published schedule, and traders treat a big unlock as a volatility event, because new supply may be sold. The catch is that volatility is very persistent: last fortnight already predicts the next one well. So we ask whether unlocks add anything beyond that.</a:t>
+            </a:r>
+          </a:p>
+          <a:p/>
+          <a:p>
+            <a:r>
+              <a:t>One comparison answers it. Every model is trained twice on the same rows and folds: once on nine controls, such as trailing volatility and the BTC regime, and once with 23 unlock and allocation features added. The difference in out-of-sample R-squared is our finding.</a:t>
             </a:r>
           </a:p>
         </p:txBody>
@@ -2324,13 +2380,19 @@
           <a:lstStyle/>
           <a:p>
             <a:r>
-              <a:t>Speaker: [Member 1]</a:t>
+              <a:t>Speaker: [Member 1]  (~40 s)</a:t>
             </a:r>
           </a:p>
           <a:p/>
           <a:p>
             <a:r>
-              <a:t>Data first: 176 tokens, one row per token per day from September 2024 to August 2026, prices from Binance and unlock schedules from Tokenomist; every feature is known at the close of the day. Then the hook: unconditionally, there is a relationship. Forward volatility climbs from about 0.97 in the lowest unlock decile to 1.14 in the highest, and the correlation is positive for three quarters of tokens. But heavy-unlock tokens are young, small and already volatile, so the question is whether this survives once trailing volatility is in the model.</a:t>
+              <a:t>Our data covers 176 tokens, daily, from September 2024 to August 2026: about 101,000 token-days, with prices from Binance and unlock schedules from Tokenomist.</a:t>
+            </a:r>
+          </a:p>
+          <a:p/>
+          <a:p>
+            <a:r>
+              <a:t>The raw data does show a link. Sort token-days by how much of the float unlocks in the next month, and forward volatility rises from about 0.97 in the lowest decile to 1.14 in the highest. The correlation is positive for 74% of tokens. But heavy-unlock tokens are also young and already volatile. Is this just persistence in disguise?</a:t>
             </a:r>
           </a:p>
         </p:txBody>
@@ -2400,13 +2462,25 @@
           <a:lstStyle/>
           <a:p>
             <a:r>
-              <a:t>Speaker: [Member 1]</a:t>
+              <a:t>Speaker: [Member 1]  (~50 s)</a:t>
             </a:r>
           </a:p>
           <a:p/>
           <a:p>
             <a:r>
-              <a:t>Five folds cut by calendar date, all tokens pooled. Training expands; a 30-day embargo separates train from test because the target looks 14 days ahead. Inside each fold the last 90 days of training are the validation slice used for tuning; the winner is refit on all training data and scored once on the next 90 days. Scalers live inside the sklearn pipeline, so nothing is fit on test data. Hand over: with the protocol fixed, [Member 2] shows what six models do under it.</a:t>
+              <a:t>To test that fairly, we never shuffle. Five walk-forward folds are cut by date: each model trains on the past, skips a 30-day gap because the target looks 14 days ahead, and is tested on the next 90 days.</a:t>
+            </a:r>
+          </a:p>
+          <a:p/>
+          <a:p>
+            <a:r>
+              <a:t>Each candidate, meaning pre-processing, model and settings together, is chosen on a validation slice at the end of the training window. It is then refit and scored once on test, and no model was changed after seeing test results. Two simple baselines, persistence and the training mean, are scored on exactly the same rows.</a:t>
+            </a:r>
+          </a:p>
+          <a:p/>
+          <a:p>
+            <a:r>
+              <a:t>With the protocol fixed, [Member 2] will show what six models do under it.</a:t>
             </a:r>
           </a:p>
         </p:txBody>
@@ -2476,13 +2550,39 @@
           <a:lstStyle/>
           <a:p>
             <a:r>
-              <a:t>Speaker: [Member 2]</a:t>
+              <a:t>Speaker: [Member 2]  (~30 s)</a:t>
             </a:r>
           </a:p>
           <a:p/>
           <a:p>
             <a:r>
-              <a:t>Each model sees identical rows, folds and features. KNN tests a local, similarity-based view; Random Forest can find non-linear effects and interactions, for example unlocks mattering only in calm markets, and LightGBM boosts small trees on the residuals; Ridge and Elastic Net are strong linear benchmarks, and Elastic Net can drop features entirely; logistic regression re-asks the question as classifying high-volatility events. Note what tuning chose: very large neighbourhoods, large leaves and strong penalties, all signs of a noisy target.</a:t>
+              <a:t>Thank you. We ran six models on that same harness:</a:t>
+            </a:r>
+          </a:p>
+          <a:p>
+            <a:r>
+              <a:t>• K-nearest neighbours, for similarity;</a:t>
+            </a:r>
+          </a:p>
+          <a:p>
+            <a:r>
+              <a:t>• Random Forest and LightGBM, for non-linear effects;</a:t>
+            </a:r>
+          </a:p>
+          <a:p>
+            <a:r>
+              <a:t>• Ridge and Elastic Net, as linear benchmarks (Elastic Net can drop features entirely);</a:t>
+            </a:r>
+          </a:p>
+          <a:p>
+            <a:r>
+              <a:t>• logistic regression, for classifying high-volatility events.</a:t>
+            </a:r>
+          </a:p>
+          <a:p/>
+          <a:p>
+            <a:r>
+              <a:t>Notice what validation chose: huge neighbourhoods, large leaves, strong penalties, the slowest boosting. That already hints that the target is noisy relative to the signal.</a:t>
             </a:r>
           </a:p>
         </p:txBody>
@@ -2552,13 +2652,19 @@
           <a:lstStyle/>
           <a:p>
             <a:r>
-              <a:t>Speaker: [Member 2]</a:t>
+              <a:t>Speaker: [Member 2]  (~30 s)</a:t>
             </a:r>
           </a:p>
           <a:p/>
           <a:p>
             <a:r>
-              <a:t>Read the chart pair by pair: blue is controls only, orange adds the unlock and static features. Every model clears the training-mean benchmark of 0.17 and the persistence benchmark of zero. But within each pair the bars are almost identical. Ridge on controls alone is as good as anything we built.</a:t>
+              <a:t>Here is the headline. Blue is controls only, orange adds the unlock features. Every model beats persistence and the training-mean baseline of 0.17, with out-of-sample R-squared between 0.22 and 0.27. Ridge on controls alone is as good as anything we built.</a:t>
+            </a:r>
+          </a:p>
+          <a:p/>
+          <a:p>
+            <a:r>
+              <a:t>But compare each blue bar with its orange partner. Adding 23 unlock features raises R-squared by only 0.001 to 0.006.</a:t>
             </a:r>
           </a:p>
         </p:txBody>
@@ -2628,13 +2734,19 @@
           <a:lstStyle/>
           <a:p>
             <a:r>
-              <a:t>Speaker: [Member 2]</a:t>
+              <a:t>Speaker: [Member 2]  (~35 s)</a:t>
             </a:r>
           </a:p>
           <a:p/>
           <a:p>
             <a:r>
-              <a:t>This is the per-fold paired difference. For the Random Forest the unlock block helps in the two oldest folds and hurts in the three most recent, which are trained on the most data. KNN swings even more. Linear models barely move because they shrink the unlock coefficients to almost zero. Meanwhile R squared itself varies by about 0.15 from fold to fold, so a difference of 0.006 is far inside the noise.</a:t>
+              <a:t>Is even that gain real? Fold by fold, in calendar order, the Random Forest gains about 0.03 in the two oldest folds, then loses in the three most recent, which have the most training data. KNN swings more, and LightGBM gains in just one fold.</a:t>
+            </a:r>
+          </a:p>
+          <a:p/>
+          <a:p>
+            <a:r>
+              <a:t>Meanwhile R-squared itself moves by about 0.15 from fold to fold, 25 times the largest average gain. A gain that flips sign like this is noise, not signal.</a:t>
             </a:r>
           </a:p>
         </p:txBody>

</xml_diff>

<commit_message>
Drop logistic regression; add benchmarks slide and per-feature RF importance chart
The team cut the logistic-regression classifier for time. Remove it from the
pipeline: scripts/06_logistic.py, its results and figure, notebook section 8
(later sections renumbered), the report/slide builders and the docs.
Regression results are unaffected (logistic had its own CSV that nothing else
read), so no rerun is needed.

Presentation follow-ups that mirror the shared Canva deck:
- new slide 5 explaining the two benchmarks (persistence, training mean);
  script and work split renumbered to 13 slides, hand-over moved to slide 5
- slide 9 now uses a per-feature permutation-importance chart (top 10, plain
  labels); report/build/fig_rf_importance_slide.py regenerates it
</commit_message>
<xml_diff>
--- a/report/Group7_Presentation_DRAFT.pptx
+++ b/report/Group7_Presentation_DRAFT.pptx
@@ -13,10 +13,10 @@
     <p:sldId id="263" r:id="rId15"/>
     <p:sldId id="264" r:id="rId16"/>
     <p:sldId id="265" r:id="rId17"/>
+    <p:sldId id="266" r:id="rId18"/>
     <p:sldId id="267" r:id="rId19"/>
     <p:sldId id="268" r:id="rId20"/>
     <p:sldId id="269" r:id="rId21"/>
-    <p:sldId id="270" r:id="rId22"/>
   </p:sldIdLst>
   <p:sldSz cx="12191695" cy="6858000" type="screen4x3"/>
   <p:notesSz cx="6858000" cy="9144000"/>
@@ -1905,6 +1905,88 @@
 </p:notes>
 </file>
 
+<file path=ppt/notesSlides/notesSlide11.xml><?xml version="1.0" encoding="utf-8"?>
+<p:notes xmlns:a="http://schemas.openxmlformats.org/drawingml/2006/main" xmlns:p="http://schemas.openxmlformats.org/presentationml/2006/main" xmlns:r="http://schemas.openxmlformats.org/officeDocument/2006/relationships">
+  <p:cSld>
+    <p:spTree>
+      <p:nvGrpSpPr>
+        <p:cNvPr id="1" name=""/>
+        <p:cNvGrpSpPr/>
+        <p:nvPr/>
+      </p:nvGrpSpPr>
+      <p:grpSpPr>
+        <a:xfrm>
+          <a:off x="0" y="0"/>
+          <a:ext cx="0" cy="0"/>
+          <a:chOff x="0" y="0"/>
+          <a:chExt cx="0" cy="0"/>
+        </a:xfrm>
+      </p:grpSpPr>
+      <p:sp>
+        <p:nvSpPr>
+          <p:cNvPr id="2" name="Slide Image Placeholder 1"/>
+          <p:cNvSpPr>
+            <a:spLocks noGrp="1"/>
+          </p:cNvSpPr>
+          <p:nvPr>
+            <p:ph type="sldImg" idx="2"/>
+          </p:nvPr>
+        </p:nvSpPr>
+        <p:spPr/>
+      </p:sp>
+      <p:sp>
+        <p:nvSpPr>
+          <p:cNvPr id="3" name="Notes Placeholder 2"/>
+          <p:cNvSpPr>
+            <a:spLocks noGrp="1"/>
+          </p:cNvSpPr>
+          <p:nvPr>
+            <p:ph type="body" idx="3" sz="quarter"/>
+          </p:nvPr>
+        </p:nvSpPr>
+        <p:spPr/>
+        <p:txBody>
+          <a:bodyPr/>
+          <a:lstStyle/>
+          <a:p>
+            <a:r>
+              <a:t>Speaker: [Member 3]  (~45 s)</a:t>
+            </a:r>
+          </a:p>
+          <a:p/>
+          <a:p>
+            <a:r>
+              <a:t>Thank you. If unlocks carried signal, it would show where unlocks are largest. Bars above zero mean the unlock features made forecasts worse. Where more than 5% of the float unlocks within a month, they make Ridge and the Random Forest worse, and LightGBM gains nothing. The same two models are also worse just before a cliff unlock.</a:t>
+            </a:r>
+          </a:p>
+          <a:p/>
+          <a:p>
+            <a:r>
+              <a:t>What the models really fix is large mistakes. Forecasts off by more than a factor of two fall from 18% under persistence to 12%. Most misses that remain are over-forecasts for tokens that suddenly calm down.</a:t>
+            </a:r>
+          </a:p>
+        </p:txBody>
+      </p:sp>
+      <p:sp>
+        <p:nvSpPr>
+          <p:cNvPr id="4" name="Slide Number Placeholder 3"/>
+          <p:cNvSpPr>
+            <a:spLocks noGrp="1"/>
+          </p:cNvSpPr>
+          <p:nvPr>
+            <p:ph type="sldNum" idx="5" sz="quarter"/>
+          </p:nvPr>
+        </p:nvSpPr>
+        <p:spPr/>
+      </p:sp>
+    </p:spTree>
+  </p:cSld>
+  <p:clrMapOvr>
+    <a:masterClrMapping/>
+  </p:clrMapOvr>
+</p:notes>
+</file>
+
 <file path=ppt/notesSlides/notesSlide12.xml><?xml version="1.0" encoding="utf-8"?>
 <p:notes xmlns:a="http://schemas.openxmlformats.org/drawingml/2006/main" xmlns:p="http://schemas.openxmlformats.org/presentationml/2006/main" xmlns:r="http://schemas.openxmlformats.org/officeDocument/2006/relationships">
   <p:cSld>
@@ -1950,19 +2032,13 @@
           <a:lstStyle/>
           <a:p>
             <a:r>
-              <a:t>Speaker: [Member 3]  (~45 s)</a:t>
+              <a:t>Speaker: [Member 3]  (~25 s)</a:t>
             </a:r>
           </a:p>
           <a:p/>
           <a:p>
             <a:r>
-              <a:t>Thank you. If unlocks carried signal, it would show where unlocks are largest. Bars above zero mean the unlock features made forecasts worse. Where more than 5% of the float unlocks within a month, they make Ridge and the Random Forest worse, and LightGBM gains nothing. The same two models are also worse just before a cliff unlock.</a:t>
-            </a:r>
-          </a:p>
-          <a:p/>
-          <a:p>
-            <a:r>
-              <a:t>What the models really fix is large mistakes. Forecasts off by more than a factor of two fall from 18% under persistence to 12%. Most misses that remain are over-forecasts for tokens that suddenly calm down.</a:t>
+              <a:t>The result holds with weekly data, three other volatility measures, and only the hand-curated tokens. The largest gain anywhere is 0.017, a tenth of the fold-to-fold spread.</a:t>
             </a:r>
           </a:p>
         </p:txBody>
@@ -2032,19 +2108,19 @@
           <a:lstStyle/>
           <a:p>
             <a:r>
-              <a:t>Speaker: [Member 3]  (~25 s)</a:t>
+              <a:t>Speaker: [Member 3]  (~40 s)</a:t>
             </a:r>
           </a:p>
           <a:p/>
           <a:p>
             <a:r>
-              <a:t>The result holds with weekly data, three other volatility measures, and only the hand-curated tokens. The largest gain anywhere is 0.017, a tenth of the fold-to-fold spread.</a:t>
+              <a:t>Is any of this useful in practice? Errors are still large: the typical miss is about 0.27 volatility points, a third of the level, and on a typical day the model is no closer than persistence. Its value is avoiding the big misses that matter for margins and position limits.</a:t>
             </a:r>
           </a:p>
           <a:p/>
           <a:p>
             <a:r>
-              <a:t>Classification agrees. Logistic regression on controls spots the most volatile tokens better than ranking by recent volatility, but unlock features slightly lower its AUC.</a:t>
+              <a:t>Unlock features add nothing there, yet cost a data subscription and a pipeline. Our advice to a risk desk: don't pay for them as a volatility input, and keep a person in the loop for the cases on the right.</a:t>
             </a:r>
           </a:p>
         </p:txBody>
@@ -2114,94 +2190,12 @@
           <a:lstStyle/>
           <a:p>
             <a:r>
-              <a:t>Speaker: [Member 3]  (~40 s)</a:t>
+              <a:t>Speaker: [Member 3]  (~35 s)</a:t>
             </a:r>
           </a:p>
           <a:p/>
           <a:p>
             <a:r>
-              <a:t>Is any of this useful in practice? Errors are still large: the typical miss is about 0.27 volatility points, a third of the level, and on a typical day the model is no closer than persistence. Its value is avoiding the big misses that matter for margins and position limits.</a:t>
-            </a:r>
-          </a:p>
-          <a:p/>
-          <a:p>
-            <a:r>
-              <a:t>Unlock features add nothing there, yet cost a data subscription and a pipeline. Our advice to a risk desk: don't pay for them as a volatility input, and keep a person in the loop for the cases on the right.</a:t>
-            </a:r>
-          </a:p>
-        </p:txBody>
-      </p:sp>
-      <p:sp>
-        <p:nvSpPr>
-          <p:cNvPr id="4" name="Slide Number Placeholder 3"/>
-          <p:cNvSpPr>
-            <a:spLocks noGrp="1"/>
-          </p:cNvSpPr>
-          <p:nvPr>
-            <p:ph type="sldNum" idx="5" sz="quarter"/>
-          </p:nvPr>
-        </p:nvSpPr>
-        <p:spPr/>
-      </p:sp>
-    </p:spTree>
-  </p:cSld>
-  <p:clrMapOvr>
-    <a:masterClrMapping/>
-  </p:clrMapOvr>
-</p:notes>
-</file>
-
-<file path=ppt/notesSlides/notesSlide15.xml><?xml version="1.0" encoding="utf-8"?>
-<p:notes xmlns:a="http://schemas.openxmlformats.org/drawingml/2006/main" xmlns:p="http://schemas.openxmlformats.org/presentationml/2006/main" xmlns:r="http://schemas.openxmlformats.org/officeDocument/2006/relationships">
-  <p:cSld>
-    <p:spTree>
-      <p:nvGrpSpPr>
-        <p:cNvPr id="1" name=""/>
-        <p:cNvGrpSpPr/>
-        <p:nvPr/>
-      </p:nvGrpSpPr>
-      <p:grpSpPr>
-        <a:xfrm>
-          <a:off x="0" y="0"/>
-          <a:ext cx="0" cy="0"/>
-          <a:chOff x="0" y="0"/>
-          <a:chExt cx="0" cy="0"/>
-        </a:xfrm>
-      </p:grpSpPr>
-      <p:sp>
-        <p:nvSpPr>
-          <p:cNvPr id="2" name="Slide Image Placeholder 1"/>
-          <p:cNvSpPr>
-            <a:spLocks noGrp="1"/>
-          </p:cNvSpPr>
-          <p:nvPr>
-            <p:ph type="sldImg" idx="2"/>
-          </p:nvPr>
-        </p:nvSpPr>
-        <p:spPr/>
-      </p:sp>
-      <p:sp>
-        <p:nvSpPr>
-          <p:cNvPr id="3" name="Notes Placeholder 2"/>
-          <p:cNvSpPr>
-            <a:spLocks noGrp="1"/>
-          </p:cNvSpPr>
-          <p:nvPr>
-            <p:ph type="body" idx="3" sz="quarter"/>
-          </p:nvPr>
-        </p:nvSpPr>
-        <p:spPr/>
-        <p:txBody>
-          <a:bodyPr/>
-          <a:lstStyle/>
-          <a:p>
-            <a:r>
-              <a:t>Speaker: [Member 3]  (~35 s)</a:t>
-            </a:r>
-          </a:p>
-          <a:p/>
-          <a:p>
-            <a:r>
               <a:t>To conclude:</a:t>
             </a:r>
           </a:p>
@@ -2212,7 +2206,7 @@
           </a:p>
           <a:p>
             <a:r>
-              <a:t>• Six models agree.</a:t>
+              <a:t>• Five models agree.</a:t>
             </a:r>
           </a:p>
           <a:p>
@@ -2480,7 +2474,7 @@
           <a:p/>
           <a:p>
             <a:r>
-              <a:t>With the protocol fixed, [Member 2] will show what six models do under it.</a:t>
+              <a:t>With the protocol fixed, [Member 2] will show what five models do under it.</a:t>
             </a:r>
           </a:p>
         </p:txBody>
@@ -2556,7 +2550,7 @@
           <a:p/>
           <a:p>
             <a:r>
-              <a:t>Thank you. We ran six models on that same harness:</a:t>
+              <a:t>Thank you. We ran five models on that same harness:</a:t>
             </a:r>
           </a:p>
           <a:p>
@@ -2571,12 +2565,7 @@
           </a:p>
           <a:p>
             <a:r>
-              <a:t>• Ridge and Elastic Net, as linear benchmarks (Elastic Net can drop features entirely);</a:t>
-            </a:r>
-          </a:p>
-          <a:p>
-            <a:r>
-              <a:t>• logistic regression, for classifying high-volatility events.</a:t>
+              <a:t>• Ridge and Elastic Net, as linear benchmarks (Elastic Net can drop features entirely).</a:t>
             </a:r>
           </a:p>
           <a:p/>
@@ -5860,7 +5849,7 @@
                 </a:solidFill>
                 <a:latin typeface="Calibri"/>
               </a:rPr>
-              <a:t>Walk-forward evidence from 176 tokens and six machine-learning models</a:t>
+              <a:t>Walk-forward evidence from 176 tokens and five machine-learning models</a:t>
             </a:r>
           </a:p>
         </p:txBody>
@@ -6650,6 +6639,365 @@
 </p:sld>
 </file>
 
+<file path=ppt/slides/slide11.xml><?xml version="1.0" encoding="utf-8"?>
+<p:sld xmlns:a="http://schemas.openxmlformats.org/drawingml/2006/main" xmlns:p="http://schemas.openxmlformats.org/presentationml/2006/main" xmlns:r="http://schemas.openxmlformats.org/officeDocument/2006/relationships">
+  <p:cSld>
+    <p:bg>
+      <p:bgPr>
+        <a:solidFill>
+          <a:srgbClr val="FFFFFF"/>
+        </a:solidFill>
+        <a:effectLst/>
+      </p:bgPr>
+    </p:bg>
+    <p:spTree>
+      <p:nvGrpSpPr>
+        <p:cNvPr id="1" name=""/>
+        <p:cNvGrpSpPr/>
+        <p:nvPr/>
+      </p:nvGrpSpPr>
+      <p:grpSpPr/>
+      <p:sp>
+        <p:nvSpPr>
+          <p:cNvPr id="2" name="Kicker"/>
+          <p:cNvSpPr txBox="1"/>
+          <p:nvPr/>
+        </p:nvSpPr>
+        <p:spPr>
+          <a:xfrm>
+            <a:off x="548640" y="320040"/>
+            <a:ext cx="11064240" cy="274320"/>
+          </a:xfrm>
+          <a:prstGeom prst="rect">
+            <a:avLst/>
+          </a:prstGeom>
+          <a:noFill/>
+        </p:spPr>
+        <p:txBody>
+          <a:bodyPr wrap="square" lIns="0" rIns="0" tIns="0" bIns="0" anchor="t">
+            <a:spAutoFit/>
+          </a:bodyPr>
+          <a:lstStyle/>
+          <a:p>
+            <a:pPr algn="l"/>
+            <a:r>
+              <a:rPr sz="1200" b="1" i="0">
+                <a:solidFill>
+                  <a:srgbClr val="EB6A35"/>
+                </a:solidFill>
+                <a:latin typeface="Calibri"/>
+              </a:rPr>
+              <a:t>WHICH MISTAKES REMAIN?</a:t>
+            </a:r>
+          </a:p>
+        </p:txBody>
+      </p:sp>
+      <p:sp>
+        <p:nvSpPr>
+          <p:cNvPr id="3" name="Title"/>
+          <p:cNvSpPr txBox="1"/>
+          <p:nvPr/>
+        </p:nvSpPr>
+        <p:spPr>
+          <a:xfrm>
+            <a:off x="548640" y="594360"/>
+            <a:ext cx="11064240" cy="822960"/>
+          </a:xfrm>
+          <a:prstGeom prst="rect">
+            <a:avLst/>
+          </a:prstGeom>
+          <a:noFill/>
+        </p:spPr>
+        <p:txBody>
+          <a:bodyPr wrap="square" lIns="0" rIns="0" tIns="0" bIns="0" anchor="t">
+            <a:spAutoFit/>
+          </a:bodyPr>
+          <a:lstStyle/>
+          <a:p>
+            <a:pPr algn="l"/>
+            <a:r>
+              <a:rPr sz="3200" b="1" i="0">
+                <a:solidFill>
+                  <a:srgbClr val="1F2433"/>
+                </a:solidFill>
+                <a:latin typeface="Cambria"/>
+              </a:rPr>
+              <a:t>Unlock features do not help even where unlocks are big</a:t>
+            </a:r>
+          </a:p>
+        </p:txBody>
+      </p:sp>
+      <p:sp>
+        <p:nvSpPr>
+          <p:cNvPr id="4" name="Footer"/>
+          <p:cNvSpPr txBox="1"/>
+          <p:nvPr/>
+        </p:nvSpPr>
+        <p:spPr>
+          <a:xfrm>
+            <a:off x="548640" y="6400800"/>
+            <a:ext cx="7315200" cy="274320"/>
+          </a:xfrm>
+          <a:prstGeom prst="rect">
+            <a:avLst/>
+          </a:prstGeom>
+          <a:noFill/>
+        </p:spPr>
+        <p:txBody>
+          <a:bodyPr wrap="square" lIns="0" rIns="0" tIns="0" bIns="0" anchor="t">
+            <a:spAutoFit/>
+          </a:bodyPr>
+          <a:lstStyle/>
+          <a:p>
+            <a:pPr algn="l"/>
+            <a:r>
+              <a:rPr sz="1000" b="0" i="0">
+                <a:solidFill>
+                  <a:srgbClr val="6B7280"/>
+                </a:solidFill>
+                <a:latin typeface="Calibri"/>
+              </a:rPr>
+              <a:t>MH6805 Group 7  |  Token unlocks and forward volatility</a:t>
+            </a:r>
+          </a:p>
+        </p:txBody>
+      </p:sp>
+      <p:sp>
+        <p:nvSpPr>
+          <p:cNvPr id="5" name="Slide number"/>
+          <p:cNvSpPr txBox="1"/>
+          <p:nvPr/>
+        </p:nvSpPr>
+        <p:spPr>
+          <a:xfrm>
+            <a:off x="10241280" y="6400800"/>
+            <a:ext cx="1399032" cy="274320"/>
+          </a:xfrm>
+          <a:prstGeom prst="rect">
+            <a:avLst/>
+          </a:prstGeom>
+          <a:noFill/>
+        </p:spPr>
+        <p:txBody>
+          <a:bodyPr wrap="square" lIns="0" rIns="0" tIns="0" bIns="0" anchor="t">
+            <a:spAutoFit/>
+          </a:bodyPr>
+          <a:lstStyle/>
+          <a:p>
+            <a:pPr algn="r"/>
+            <a:r>
+              <a:rPr sz="1000" b="0" i="0">
+                <a:solidFill>
+                  <a:srgbClr val="6B7280"/>
+                </a:solidFill>
+                <a:latin typeface="Calibri"/>
+              </a:rPr>
+              <a:t>9</a:t>
+            </a:r>
+          </a:p>
+        </p:txBody>
+      </p:sp>
+      <p:graphicFrame>
+        <p:nvGraphicFramePr>
+          <p:cNvPr id="6" name="Chart 5"/>
+          <p:cNvGraphicFramePr>
+            <a:graphicFrameLocks noGrp="1"/>
+          </p:cNvGraphicFramePr>
+          <p:nvPr/>
+        </p:nvGraphicFramePr>
+        <p:xfrm>
+          <a:off x="548640" y="2011680"/>
+          <a:ext cx="7589520" cy="4160520"/>
+        </p:xfrm>
+        <a:graphic>
+          <a:graphicData uri="http://schemas.openxmlformats.org/drawingml/2006/chart">
+            <c:chart xmlns:c="http://schemas.openxmlformats.org/drawingml/2006/chart" r:id="rId3"/>
+          </a:graphicData>
+        </a:graphic>
+      </p:graphicFrame>
+      <p:sp>
+        <p:nvSpPr>
+          <p:cNvPr id="7" name="TextBox 6"/>
+          <p:cNvSpPr txBox="1"/>
+          <p:nvPr/>
+        </p:nvSpPr>
+        <p:spPr>
+          <a:xfrm>
+            <a:off x="548640" y="1645920"/>
+            <a:ext cx="7589520" cy="365760"/>
+          </a:xfrm>
+          <a:prstGeom prst="rect">
+            <a:avLst/>
+          </a:prstGeom>
+          <a:noFill/>
+        </p:spPr>
+        <p:txBody>
+          <a:bodyPr wrap="square" lIns="0" rIns="0" tIns="0" bIns="0" anchor="t">
+            <a:spAutoFit/>
+          </a:bodyPr>
+          <a:lstStyle/>
+          <a:p>
+            <a:pPr algn="l"/>
+            <a:r>
+              <a:rPr sz="1400" b="1" i="0">
+                <a:solidFill>
+                  <a:srgbClr val="1F2433"/>
+                </a:solidFill>
+                <a:latin typeface="Calibri"/>
+              </a:rPr>
+              <a:t>Change in test RMSE from adding unlock features (positive = worse), by 30-day unlock share of float</a:t>
+            </a:r>
+          </a:p>
+        </p:txBody>
+      </p:sp>
+      <p:sp>
+        <p:nvSpPr>
+          <p:cNvPr id="8" name="TextBox 7"/>
+          <p:cNvSpPr txBox="1"/>
+          <p:nvPr/>
+        </p:nvSpPr>
+        <p:spPr>
+          <a:xfrm>
+            <a:off x="8503920" y="1737360"/>
+            <a:ext cx="3200400" cy="640080"/>
+          </a:xfrm>
+          <a:prstGeom prst="rect">
+            <a:avLst/>
+          </a:prstGeom>
+          <a:noFill/>
+        </p:spPr>
+        <p:txBody>
+          <a:bodyPr wrap="square" lIns="0" rIns="0" tIns="0" bIns="0" anchor="t">
+            <a:spAutoFit/>
+          </a:bodyPr>
+          <a:lstStyle/>
+          <a:p>
+            <a:pPr algn="l"/>
+            <a:r>
+              <a:rPr sz="3200" b="1" i="0">
+                <a:solidFill>
+                  <a:srgbClr val="141B2D"/>
+                </a:solidFill>
+                <a:latin typeface="Cambria"/>
+              </a:rPr>
+              <a:t>18% → 12%</a:t>
+            </a:r>
+          </a:p>
+        </p:txBody>
+      </p:sp>
+      <p:sp>
+        <p:nvSpPr>
+          <p:cNvPr id="9" name="TextBox 8"/>
+          <p:cNvSpPr txBox="1"/>
+          <p:nvPr/>
+        </p:nvSpPr>
+        <p:spPr>
+          <a:xfrm>
+            <a:off x="8503920" y="2423160"/>
+            <a:ext cx="3108960" cy="1097280"/>
+          </a:xfrm>
+          <a:prstGeom prst="rect">
+            <a:avLst/>
+          </a:prstGeom>
+          <a:noFill/>
+        </p:spPr>
+        <p:txBody>
+          <a:bodyPr wrap="square" lIns="0" rIns="0" tIns="0" bIns="0" anchor="t">
+            <a:spAutoFit/>
+          </a:bodyPr>
+          <a:lstStyle/>
+          <a:p>
+            <a:pPr algn="l"/>
+            <a:r>
+              <a:rPr sz="1500" b="0" i="0">
+                <a:solidFill>
+                  <a:srgbClr val="6B7280"/>
+                </a:solidFill>
+                <a:latin typeface="Calibri"/>
+              </a:rPr>
+              <a:t>forecasts off by more than 2×: persistence vs Ridge. The real gain is fewer large misses</a:t>
+            </a:r>
+          </a:p>
+        </p:txBody>
+      </p:sp>
+      <p:sp>
+        <p:nvSpPr>
+          <p:cNvPr id="10" name="TextBox 9"/>
+          <p:cNvSpPr txBox="1"/>
+          <p:nvPr/>
+        </p:nvSpPr>
+        <p:spPr>
+          <a:xfrm>
+            <a:off x="8503920" y="3886200"/>
+            <a:ext cx="3200400" cy="640080"/>
+          </a:xfrm>
+          <a:prstGeom prst="rect">
+            <a:avLst/>
+          </a:prstGeom>
+          <a:noFill/>
+        </p:spPr>
+        <p:txBody>
+          <a:bodyPr wrap="square" lIns="0" rIns="0" tIns="0" bIns="0" anchor="t">
+            <a:spAutoFit/>
+          </a:bodyPr>
+          <a:lstStyle/>
+          <a:p>
+            <a:pPr algn="l"/>
+            <a:r>
+              <a:rPr sz="3200" b="1" i="0">
+                <a:solidFill>
+                  <a:srgbClr val="EB6A35"/>
+                </a:solidFill>
+                <a:latin typeface="Cambria"/>
+              </a:rPr>
+              <a:t>62%</a:t>
+            </a:r>
+          </a:p>
+        </p:txBody>
+      </p:sp>
+      <p:sp>
+        <p:nvSpPr>
+          <p:cNvPr id="11" name="TextBox 10"/>
+          <p:cNvSpPr txBox="1"/>
+          <p:nvPr/>
+        </p:nvSpPr>
+        <p:spPr>
+          <a:xfrm>
+            <a:off x="8503920" y="4572000"/>
+            <a:ext cx="3108960" cy="1097280"/>
+          </a:xfrm>
+          <a:prstGeom prst="rect">
+            <a:avLst/>
+          </a:prstGeom>
+          <a:noFill/>
+        </p:spPr>
+        <p:txBody>
+          <a:bodyPr wrap="square" lIns="0" rIns="0" tIns="0" bIns="0" anchor="t">
+            <a:spAutoFit/>
+          </a:bodyPr>
+          <a:lstStyle/>
+          <a:p>
+            <a:pPr algn="l"/>
+            <a:r>
+              <a:rPr sz="1500" b="0" i="0">
+                <a:solidFill>
+                  <a:srgbClr val="6B7280"/>
+                </a:solidFill>
+                <a:latin typeface="Calibri"/>
+              </a:rPr>
+              <a:t>of remaining 2× misses are over-forecasts: volatility collapsed. The rest are spikes no feature sees</a:t>
+            </a:r>
+          </a:p>
+        </p:txBody>
+      </p:sp>
+    </p:spTree>
+  </p:cSld>
+  <p:clrMapOvr>
+    <a:masterClrMapping/>
+  </p:clrMapOvr>
+</p:sld>
+</file>
+
 <file path=ppt/slides/slide12.xml><?xml version="1.0" encoding="utf-8"?>
 <p:sld xmlns:a="http://schemas.openxmlformats.org/drawingml/2006/main" xmlns:p="http://schemas.openxmlformats.org/presentationml/2006/main" xmlns:r="http://schemas.openxmlformats.org/officeDocument/2006/relationships">
   <p:cSld>
@@ -6698,366 +7046,7 @@
                 </a:solidFill>
                 <a:latin typeface="Calibri"/>
               </a:rPr>
-              <a:t>WHICH MISTAKES REMAIN?</a:t>
-            </a:r>
-          </a:p>
-        </p:txBody>
-      </p:sp>
-      <p:sp>
-        <p:nvSpPr>
-          <p:cNvPr id="3" name="Title"/>
-          <p:cNvSpPr txBox="1"/>
-          <p:nvPr/>
-        </p:nvSpPr>
-        <p:spPr>
-          <a:xfrm>
-            <a:off x="548640" y="594360"/>
-            <a:ext cx="11064240" cy="822960"/>
-          </a:xfrm>
-          <a:prstGeom prst="rect">
-            <a:avLst/>
-          </a:prstGeom>
-          <a:noFill/>
-        </p:spPr>
-        <p:txBody>
-          <a:bodyPr wrap="square" lIns="0" rIns="0" tIns="0" bIns="0" anchor="t">
-            <a:spAutoFit/>
-          </a:bodyPr>
-          <a:lstStyle/>
-          <a:p>
-            <a:pPr algn="l"/>
-            <a:r>
-              <a:rPr sz="3200" b="1" i="0">
-                <a:solidFill>
-                  <a:srgbClr val="1F2433"/>
-                </a:solidFill>
-                <a:latin typeface="Cambria"/>
-              </a:rPr>
-              <a:t>Unlock features do not help even where unlocks are big</a:t>
-            </a:r>
-          </a:p>
-        </p:txBody>
-      </p:sp>
-      <p:sp>
-        <p:nvSpPr>
-          <p:cNvPr id="4" name="Footer"/>
-          <p:cNvSpPr txBox="1"/>
-          <p:nvPr/>
-        </p:nvSpPr>
-        <p:spPr>
-          <a:xfrm>
-            <a:off x="548640" y="6400800"/>
-            <a:ext cx="7315200" cy="274320"/>
-          </a:xfrm>
-          <a:prstGeom prst="rect">
-            <a:avLst/>
-          </a:prstGeom>
-          <a:noFill/>
-        </p:spPr>
-        <p:txBody>
-          <a:bodyPr wrap="square" lIns="0" rIns="0" tIns="0" bIns="0" anchor="t">
-            <a:spAutoFit/>
-          </a:bodyPr>
-          <a:lstStyle/>
-          <a:p>
-            <a:pPr algn="l"/>
-            <a:r>
-              <a:rPr sz="1000" b="0" i="0">
-                <a:solidFill>
-                  <a:srgbClr val="6B7280"/>
-                </a:solidFill>
-                <a:latin typeface="Calibri"/>
-              </a:rPr>
-              <a:t>MH6805 Group 7  |  Token unlocks and forward volatility</a:t>
-            </a:r>
-          </a:p>
-        </p:txBody>
-      </p:sp>
-      <p:sp>
-        <p:nvSpPr>
-          <p:cNvPr id="5" name="Slide number"/>
-          <p:cNvSpPr txBox="1"/>
-          <p:nvPr/>
-        </p:nvSpPr>
-        <p:spPr>
-          <a:xfrm>
-            <a:off x="10241280" y="6400800"/>
-            <a:ext cx="1399032" cy="274320"/>
-          </a:xfrm>
-          <a:prstGeom prst="rect">
-            <a:avLst/>
-          </a:prstGeom>
-          <a:noFill/>
-        </p:spPr>
-        <p:txBody>
-          <a:bodyPr wrap="square" lIns="0" rIns="0" tIns="0" bIns="0" anchor="t">
-            <a:spAutoFit/>
-          </a:bodyPr>
-          <a:lstStyle/>
-          <a:p>
-            <a:pPr algn="r"/>
-            <a:r>
-              <a:rPr sz="1000" b="0" i="0">
-                <a:solidFill>
-                  <a:srgbClr val="6B7280"/>
-                </a:solidFill>
-                <a:latin typeface="Calibri"/>
-              </a:rPr>
-              <a:t>9</a:t>
-            </a:r>
-          </a:p>
-        </p:txBody>
-      </p:sp>
-      <p:graphicFrame>
-        <p:nvGraphicFramePr>
-          <p:cNvPr id="6" name="Chart 5"/>
-          <p:cNvGraphicFramePr>
-            <a:graphicFrameLocks noGrp="1"/>
-          </p:cNvGraphicFramePr>
-          <p:nvPr/>
-        </p:nvGraphicFramePr>
-        <p:xfrm>
-          <a:off x="548640" y="2011680"/>
-          <a:ext cx="7589520" cy="4160520"/>
-        </p:xfrm>
-        <a:graphic>
-          <a:graphicData uri="http://schemas.openxmlformats.org/drawingml/2006/chart">
-            <c:chart xmlns:c="http://schemas.openxmlformats.org/drawingml/2006/chart" r:id="rId3"/>
-          </a:graphicData>
-        </a:graphic>
-      </p:graphicFrame>
-      <p:sp>
-        <p:nvSpPr>
-          <p:cNvPr id="7" name="TextBox 6"/>
-          <p:cNvSpPr txBox="1"/>
-          <p:nvPr/>
-        </p:nvSpPr>
-        <p:spPr>
-          <a:xfrm>
-            <a:off x="548640" y="1645920"/>
-            <a:ext cx="7589520" cy="365760"/>
-          </a:xfrm>
-          <a:prstGeom prst="rect">
-            <a:avLst/>
-          </a:prstGeom>
-          <a:noFill/>
-        </p:spPr>
-        <p:txBody>
-          <a:bodyPr wrap="square" lIns="0" rIns="0" tIns="0" bIns="0" anchor="t">
-            <a:spAutoFit/>
-          </a:bodyPr>
-          <a:lstStyle/>
-          <a:p>
-            <a:pPr algn="l"/>
-            <a:r>
-              <a:rPr sz="1400" b="1" i="0">
-                <a:solidFill>
-                  <a:srgbClr val="1F2433"/>
-                </a:solidFill>
-                <a:latin typeface="Calibri"/>
-              </a:rPr>
-              <a:t>Change in test RMSE from adding unlock features (positive = worse), by 30-day unlock share of float</a:t>
-            </a:r>
-          </a:p>
-        </p:txBody>
-      </p:sp>
-      <p:sp>
-        <p:nvSpPr>
-          <p:cNvPr id="8" name="TextBox 7"/>
-          <p:cNvSpPr txBox="1"/>
-          <p:nvPr/>
-        </p:nvSpPr>
-        <p:spPr>
-          <a:xfrm>
-            <a:off x="8503920" y="1737360"/>
-            <a:ext cx="3200400" cy="640080"/>
-          </a:xfrm>
-          <a:prstGeom prst="rect">
-            <a:avLst/>
-          </a:prstGeom>
-          <a:noFill/>
-        </p:spPr>
-        <p:txBody>
-          <a:bodyPr wrap="square" lIns="0" rIns="0" tIns="0" bIns="0" anchor="t">
-            <a:spAutoFit/>
-          </a:bodyPr>
-          <a:lstStyle/>
-          <a:p>
-            <a:pPr algn="l"/>
-            <a:r>
-              <a:rPr sz="3200" b="1" i="0">
-                <a:solidFill>
-                  <a:srgbClr val="141B2D"/>
-                </a:solidFill>
-                <a:latin typeface="Cambria"/>
-              </a:rPr>
-              <a:t>18% → 12%</a:t>
-            </a:r>
-          </a:p>
-        </p:txBody>
-      </p:sp>
-      <p:sp>
-        <p:nvSpPr>
-          <p:cNvPr id="9" name="TextBox 8"/>
-          <p:cNvSpPr txBox="1"/>
-          <p:nvPr/>
-        </p:nvSpPr>
-        <p:spPr>
-          <a:xfrm>
-            <a:off x="8503920" y="2423160"/>
-            <a:ext cx="3108960" cy="1097280"/>
-          </a:xfrm>
-          <a:prstGeom prst="rect">
-            <a:avLst/>
-          </a:prstGeom>
-          <a:noFill/>
-        </p:spPr>
-        <p:txBody>
-          <a:bodyPr wrap="square" lIns="0" rIns="0" tIns="0" bIns="0" anchor="t">
-            <a:spAutoFit/>
-          </a:bodyPr>
-          <a:lstStyle/>
-          <a:p>
-            <a:pPr algn="l"/>
-            <a:r>
-              <a:rPr sz="1500" b="0" i="0">
-                <a:solidFill>
-                  <a:srgbClr val="6B7280"/>
-                </a:solidFill>
-                <a:latin typeface="Calibri"/>
-              </a:rPr>
-              <a:t>forecasts off by more than 2×: persistence vs Ridge. The real gain is fewer large misses</a:t>
-            </a:r>
-          </a:p>
-        </p:txBody>
-      </p:sp>
-      <p:sp>
-        <p:nvSpPr>
-          <p:cNvPr id="10" name="TextBox 9"/>
-          <p:cNvSpPr txBox="1"/>
-          <p:nvPr/>
-        </p:nvSpPr>
-        <p:spPr>
-          <a:xfrm>
-            <a:off x="8503920" y="3886200"/>
-            <a:ext cx="3200400" cy="640080"/>
-          </a:xfrm>
-          <a:prstGeom prst="rect">
-            <a:avLst/>
-          </a:prstGeom>
-          <a:noFill/>
-        </p:spPr>
-        <p:txBody>
-          <a:bodyPr wrap="square" lIns="0" rIns="0" tIns="0" bIns="0" anchor="t">
-            <a:spAutoFit/>
-          </a:bodyPr>
-          <a:lstStyle/>
-          <a:p>
-            <a:pPr algn="l"/>
-            <a:r>
-              <a:rPr sz="3200" b="1" i="0">
-                <a:solidFill>
-                  <a:srgbClr val="EB6A35"/>
-                </a:solidFill>
-                <a:latin typeface="Cambria"/>
-              </a:rPr>
-              <a:t>62%</a:t>
-            </a:r>
-          </a:p>
-        </p:txBody>
-      </p:sp>
-      <p:sp>
-        <p:nvSpPr>
-          <p:cNvPr id="11" name="TextBox 10"/>
-          <p:cNvSpPr txBox="1"/>
-          <p:nvPr/>
-        </p:nvSpPr>
-        <p:spPr>
-          <a:xfrm>
-            <a:off x="8503920" y="4572000"/>
-            <a:ext cx="3108960" cy="1097280"/>
-          </a:xfrm>
-          <a:prstGeom prst="rect">
-            <a:avLst/>
-          </a:prstGeom>
-          <a:noFill/>
-        </p:spPr>
-        <p:txBody>
-          <a:bodyPr wrap="square" lIns="0" rIns="0" tIns="0" bIns="0" anchor="t">
-            <a:spAutoFit/>
-          </a:bodyPr>
-          <a:lstStyle/>
-          <a:p>
-            <a:pPr algn="l"/>
-            <a:r>
-              <a:rPr sz="1500" b="0" i="0">
-                <a:solidFill>
-                  <a:srgbClr val="6B7280"/>
-                </a:solidFill>
-                <a:latin typeface="Calibri"/>
-              </a:rPr>
-              <a:t>of remaining 2× misses are over-forecasts: volatility collapsed. The rest are spikes no feature sees</a:t>
-            </a:r>
-          </a:p>
-        </p:txBody>
-      </p:sp>
-    </p:spTree>
-  </p:cSld>
-  <p:clrMapOvr>
-    <a:masterClrMapping/>
-  </p:clrMapOvr>
-</p:sld>
-</file>
-
-<file path=ppt/slides/slide13.xml><?xml version="1.0" encoding="utf-8"?>
-<p:sld xmlns:a="http://schemas.openxmlformats.org/drawingml/2006/main" xmlns:p="http://schemas.openxmlformats.org/presentationml/2006/main" xmlns:r="http://schemas.openxmlformats.org/officeDocument/2006/relationships">
-  <p:cSld>
-    <p:bg>
-      <p:bgPr>
-        <a:solidFill>
-          <a:srgbClr val="FFFFFF"/>
-        </a:solidFill>
-        <a:effectLst/>
-      </p:bgPr>
-    </p:bg>
-    <p:spTree>
-      <p:nvGrpSpPr>
-        <p:cNvPr id="1" name=""/>
-        <p:cNvGrpSpPr/>
-        <p:nvPr/>
-      </p:nvGrpSpPr>
-      <p:grpSpPr/>
-      <p:sp>
-        <p:nvSpPr>
-          <p:cNvPr id="2" name="Kicker"/>
-          <p:cNvSpPr txBox="1"/>
-          <p:nvPr/>
-        </p:nvSpPr>
-        <p:spPr>
-          <a:xfrm>
-            <a:off x="548640" y="320040"/>
-            <a:ext cx="11064240" cy="274320"/>
-          </a:xfrm>
-          <a:prstGeom prst="rect">
-            <a:avLst/>
-          </a:prstGeom>
-          <a:noFill/>
-        </p:spPr>
-        <p:txBody>
-          <a:bodyPr wrap="square" lIns="0" rIns="0" tIns="0" bIns="0" anchor="t">
-            <a:spAutoFit/>
-          </a:bodyPr>
-          <a:lstStyle/>
-          <a:p>
-            <a:pPr algn="l"/>
-            <a:r>
-              <a:rPr sz="1200" b="1" i="0">
-                <a:solidFill>
-                  <a:srgbClr val="EB6A35"/>
-                </a:solidFill>
-                <a:latin typeface="Calibri"/>
-              </a:rPr>
-              <a:t>ROBUSTNESS AND CLASSIFICATION</a:t>
+              <a:t>ROBUSTNESS</a:t>
             </a:r>
           </a:p>
         </p:txBody>
@@ -8312,7 +8301,7 @@
                 </a:solidFill>
                 <a:latin typeface="Cambria"/>
               </a:rPr>
-              <a:t>-0.002</a:t>
+              <a:t>±0.15</a:t>
             </a:r>
           </a:p>
         </p:txBody>
@@ -8347,7 +8336,7 @@
                 </a:solidFill>
                 <a:latin typeface="Calibri"/>
               </a:rPr>
-              <a:t>logistic AUC change from unlocks: top-20% event (spike: -0.004)</a:t>
+              <a:t>fold-to-fold s.d. of R²oos itself, about ten times the largest gain</a:t>
             </a:r>
           </a:p>
         </p:txBody>
@@ -8360,7 +8349,7 @@
 </p:sld>
 </file>
 
-<file path=ppt/slides/slide14.xml><?xml version="1.0" encoding="utf-8"?>
+<file path=ppt/slides/slide13.xml><?xml version="1.0" encoding="utf-8"?>
 <p:sld xmlns:a="http://schemas.openxmlformats.org/drawingml/2006/main" xmlns:p="http://schemas.openxmlformats.org/presentationml/2006/main" xmlns:r="http://schemas.openxmlformats.org/officeDocument/2006/relationships">
   <p:cSld>
     <p:bg>
@@ -9169,7 +9158,7 @@
 </p:sld>
 </file>
 
-<file path=ppt/slides/slide15.xml><?xml version="1.0" encoding="utf-8"?>
+<file path=ppt/slides/slide14.xml><?xml version="1.0" encoding="utf-8"?>
 <p:sld xmlns:a="http://schemas.openxmlformats.org/drawingml/2006/main" xmlns:p="http://schemas.openxmlformats.org/presentationml/2006/main" xmlns:r="http://schemas.openxmlformats.org/officeDocument/2006/relationships">
   <p:cSld>
     <p:bg>
@@ -9463,7 +9452,7 @@
                 </a:solidFill>
                 <a:latin typeface="Cambria"/>
               </a:rPr>
-              <a:t>Six models agree</a:t>
+              <a:t>Five models agree</a:t>
             </a:r>
           </a:p>
         </p:txBody>
@@ -9498,7 +9487,7 @@
                 </a:solidFill>
                 <a:latin typeface="Calibri"/>
               </a:rPr>
-              <a:t>Regressors gain only +0.001 to +0.006 R², with unstable sign; logistic AUC falls slightly.</a:t>
+              <a:t>They gain only +0.001 to +0.006 R², and the sign flips between folds.</a:t>
             </a:r>
           </a:p>
         </p:txBody>
@@ -12611,7 +12600,7 @@
                 </a:solidFill>
                 <a:latin typeface="Cambria"/>
               </a:rPr>
-              <a:t>Six models, one shared harness</a:t>
+              <a:t>Five models, one shared harness</a:t>
             </a:r>
           </a:p>
         </p:txBody>
@@ -12695,7 +12684,7 @@
         <p:spPr>
           <a:xfrm>
             <a:off x="548640" y="1783080"/>
-            <a:ext cx="1719072" cy="4206240"/>
+            <a:ext cx="2084831" cy="4206240"/>
           </a:xfrm>
           <a:prstGeom prst="roundRect">
             <a:avLst>
@@ -12741,7 +12730,7 @@
         <p:spPr>
           <a:xfrm>
             <a:off x="722376" y="2011680"/>
-            <a:ext cx="1371600" cy="274320"/>
+            <a:ext cx="1737360" cy="274320"/>
           </a:xfrm>
           <a:prstGeom prst="rect">
             <a:avLst/>
@@ -12776,7 +12765,7 @@
         <p:spPr>
           <a:xfrm>
             <a:off x="722376" y="2331720"/>
-            <a:ext cx="1371600" cy="822960"/>
+            <a:ext cx="1737360" cy="822960"/>
           </a:xfrm>
           <a:prstGeom prst="rect">
             <a:avLst/>
@@ -12811,7 +12800,7 @@
         <p:spPr>
           <a:xfrm>
             <a:off x="722376" y="3200400"/>
-            <a:ext cx="1371600" cy="1280160"/>
+            <a:ext cx="1737360" cy="1280160"/>
           </a:xfrm>
           <a:prstGeom prst="rect">
             <a:avLst/>
@@ -12846,7 +12835,7 @@
         <p:spPr>
           <a:xfrm>
             <a:off x="722376" y="4572000"/>
-            <a:ext cx="1371600" cy="1188720"/>
+            <a:ext cx="1737360" cy="1188720"/>
           </a:xfrm>
           <a:prstGeom prst="rect">
             <a:avLst/>
@@ -12880,8 +12869,8 @@
         </p:nvSpPr>
         <p:spPr>
           <a:xfrm>
-            <a:off x="2423160" y="1783080"/>
-            <a:ext cx="1719072" cy="4206240"/>
+            <a:off x="2788920" y="1783080"/>
+            <a:ext cx="2084831" cy="4206240"/>
           </a:xfrm>
           <a:prstGeom prst="roundRect">
             <a:avLst>
@@ -12926,8 +12915,8 @@
         </p:nvSpPr>
         <p:spPr>
           <a:xfrm>
-            <a:off x="2596896" y="2011680"/>
-            <a:ext cx="1371600" cy="274320"/>
+            <a:off x="2962656" y="2011680"/>
+            <a:ext cx="1737360" cy="274320"/>
           </a:xfrm>
           <a:prstGeom prst="rect">
             <a:avLst/>
@@ -12961,8 +12950,8 @@
         </p:nvSpPr>
         <p:spPr>
           <a:xfrm>
-            <a:off x="2596896" y="2331720"/>
-            <a:ext cx="1371600" cy="822960"/>
+            <a:off x="2962656" y="2331720"/>
+            <a:ext cx="1737360" cy="822960"/>
           </a:xfrm>
           <a:prstGeom prst="rect">
             <a:avLst/>
@@ -12996,8 +12985,8 @@
         </p:nvSpPr>
         <p:spPr>
           <a:xfrm>
-            <a:off x="2596896" y="3200400"/>
-            <a:ext cx="1371600" cy="1280160"/>
+            <a:off x="2962656" y="3200400"/>
+            <a:ext cx="1737360" cy="1280160"/>
           </a:xfrm>
           <a:prstGeom prst="rect">
             <a:avLst/>
@@ -13031,8 +13020,8 @@
         </p:nvSpPr>
         <p:spPr>
           <a:xfrm>
-            <a:off x="2596896" y="4572000"/>
-            <a:ext cx="1371600" cy="1188720"/>
+            <a:off x="2962656" y="4572000"/>
+            <a:ext cx="1737360" cy="1188720"/>
           </a:xfrm>
           <a:prstGeom prst="rect">
             <a:avLst/>
@@ -13066,8 +13055,8 @@
         </p:nvSpPr>
         <p:spPr>
           <a:xfrm>
-            <a:off x="4297679" y="1783080"/>
-            <a:ext cx="1719072" cy="4206240"/>
+            <a:off x="5029200" y="1783080"/>
+            <a:ext cx="2084831" cy="4206240"/>
           </a:xfrm>
           <a:prstGeom prst="roundRect">
             <a:avLst>
@@ -13112,8 +13101,8 @@
         </p:nvSpPr>
         <p:spPr>
           <a:xfrm>
-            <a:off x="4471416" y="2011680"/>
-            <a:ext cx="1371600" cy="274320"/>
+            <a:off x="5202936" y="2011680"/>
+            <a:ext cx="1737360" cy="274320"/>
           </a:xfrm>
           <a:prstGeom prst="rect">
             <a:avLst/>
@@ -13147,8 +13136,8 @@
         </p:nvSpPr>
         <p:spPr>
           <a:xfrm>
-            <a:off x="4471416" y="2331720"/>
-            <a:ext cx="1371600" cy="822960"/>
+            <a:off x="5202936" y="2331720"/>
+            <a:ext cx="1737360" cy="822960"/>
           </a:xfrm>
           <a:prstGeom prst="rect">
             <a:avLst/>
@@ -13182,8 +13171,8 @@
         </p:nvSpPr>
         <p:spPr>
           <a:xfrm>
-            <a:off x="4471416" y="3200400"/>
-            <a:ext cx="1371600" cy="1280160"/>
+            <a:off x="5202936" y="3200400"/>
+            <a:ext cx="1737360" cy="1280160"/>
           </a:xfrm>
           <a:prstGeom prst="rect">
             <a:avLst/>
@@ -13217,8 +13206,8 @@
         </p:nvSpPr>
         <p:spPr>
           <a:xfrm>
-            <a:off x="4471416" y="4572000"/>
-            <a:ext cx="1371600" cy="1188720"/>
+            <a:off x="5202936" y="4572000"/>
+            <a:ext cx="1737360" cy="1188720"/>
           </a:xfrm>
           <a:prstGeom prst="rect">
             <a:avLst/>
@@ -13252,8 +13241,8 @@
         </p:nvSpPr>
         <p:spPr>
           <a:xfrm>
-            <a:off x="6172199" y="1783080"/>
-            <a:ext cx="1719072" cy="4206240"/>
+            <a:off x="7269480" y="1783080"/>
+            <a:ext cx="2084831" cy="4206240"/>
           </a:xfrm>
           <a:prstGeom prst="roundRect">
             <a:avLst>
@@ -13298,8 +13287,8 @@
         </p:nvSpPr>
         <p:spPr>
           <a:xfrm>
-            <a:off x="6345936" y="2011680"/>
-            <a:ext cx="1371600" cy="274320"/>
+            <a:off x="7443216" y="2011680"/>
+            <a:ext cx="1737360" cy="274320"/>
           </a:xfrm>
           <a:prstGeom prst="rect">
             <a:avLst/>
@@ -13333,8 +13322,8 @@
         </p:nvSpPr>
         <p:spPr>
           <a:xfrm>
-            <a:off x="6345936" y="2331720"/>
-            <a:ext cx="1371600" cy="822960"/>
+            <a:off x="7443216" y="2331720"/>
+            <a:ext cx="1737360" cy="822960"/>
           </a:xfrm>
           <a:prstGeom prst="rect">
             <a:avLst/>
@@ -13368,8 +13357,8 @@
         </p:nvSpPr>
         <p:spPr>
           <a:xfrm>
-            <a:off x="6345936" y="3200400"/>
-            <a:ext cx="1371600" cy="1280160"/>
+            <a:off x="7443216" y="3200400"/>
+            <a:ext cx="1737360" cy="1280160"/>
           </a:xfrm>
           <a:prstGeom prst="rect">
             <a:avLst/>
@@ -13403,8 +13392,8 @@
         </p:nvSpPr>
         <p:spPr>
           <a:xfrm>
-            <a:off x="6345936" y="4572000"/>
-            <a:ext cx="1371600" cy="1188720"/>
+            <a:off x="7443216" y="4572000"/>
+            <a:ext cx="1737360" cy="1188720"/>
           </a:xfrm>
           <a:prstGeom prst="rect">
             <a:avLst/>
@@ -13438,8 +13427,8 @@
         </p:nvSpPr>
         <p:spPr>
           <a:xfrm>
-            <a:off x="8046719" y="1783080"/>
-            <a:ext cx="1719072" cy="4206240"/>
+            <a:off x="9509760" y="1783080"/>
+            <a:ext cx="2084831" cy="4206240"/>
           </a:xfrm>
           <a:prstGeom prst="roundRect">
             <a:avLst>
@@ -13484,8 +13473,8 @@
         </p:nvSpPr>
         <p:spPr>
           <a:xfrm>
-            <a:off x="8220455" y="2011680"/>
-            <a:ext cx="1371600" cy="274320"/>
+            <a:off x="9683496" y="2011680"/>
+            <a:ext cx="1737360" cy="274320"/>
           </a:xfrm>
           <a:prstGeom prst="rect">
             <a:avLst/>
@@ -13519,8 +13508,8 @@
         </p:nvSpPr>
         <p:spPr>
           <a:xfrm>
-            <a:off x="8220455" y="2331720"/>
-            <a:ext cx="1371600" cy="822960"/>
+            <a:off x="9683496" y="2331720"/>
+            <a:ext cx="1737360" cy="822960"/>
           </a:xfrm>
           <a:prstGeom prst="rect">
             <a:avLst/>
@@ -13554,8 +13543,8 @@
         </p:nvSpPr>
         <p:spPr>
           <a:xfrm>
-            <a:off x="8220455" y="3200400"/>
-            <a:ext cx="1371600" cy="1280160"/>
+            <a:off x="9683496" y="3200400"/>
+            <a:ext cx="1737360" cy="1280160"/>
           </a:xfrm>
           <a:prstGeom prst="rect">
             <a:avLst/>
@@ -13589,8 +13578,8 @@
         </p:nvSpPr>
         <p:spPr>
           <a:xfrm>
-            <a:off x="8220455" y="4572000"/>
-            <a:ext cx="1371600" cy="1188720"/>
+            <a:off x="9683496" y="4572000"/>
+            <a:ext cx="1737360" cy="1188720"/>
           </a:xfrm>
           <a:prstGeom prst="rect">
             <a:avLst/>
@@ -13612,192 +13601,6 @@
                 <a:latin typeface="Calibri"/>
               </a:rPr>
               <a:t>Tuned: all-zero in 2 of 5 folds</a:t>
-            </a:r>
-          </a:p>
-        </p:txBody>
-      </p:sp>
-      <p:sp>
-        <p:nvSpPr>
-          <p:cNvPr id="31" name="Model card Logistic"/>
-          <p:cNvSpPr/>
-          <p:nvPr/>
-        </p:nvSpPr>
-        <p:spPr>
-          <a:xfrm>
-            <a:off x="9921240" y="1783080"/>
-            <a:ext cx="1719072" cy="4206240"/>
-          </a:xfrm>
-          <a:prstGeom prst="roundRect">
-            <a:avLst>
-              <a:gd name="adj" fmla="val 8000"/>
-            </a:avLst>
-          </a:prstGeom>
-          <a:solidFill>
-            <a:srgbClr val="141B2D"/>
-          </a:solidFill>
-          <a:ln>
-            <a:noFill/>
-          </a:ln>
-          <a:effectLst/>
-        </p:spPr>
-        <p:style>
-          <a:lnRef idx="1">
-            <a:schemeClr val="accent1"/>
-          </a:lnRef>
-          <a:fillRef idx="3">
-            <a:schemeClr val="accent1"/>
-          </a:fillRef>
-          <a:effectRef idx="2">
-            <a:schemeClr val="accent1"/>
-          </a:effectRef>
-          <a:fontRef idx="minor">
-            <a:schemeClr val="lt1"/>
-          </a:fontRef>
-        </p:style>
-        <p:txBody>
-          <a:bodyPr rtlCol="0" anchor="ctr"/>
-          <a:lstStyle/>
-          <a:p>
-            <a:pPr algn="ctr"/>
-          </a:p>
-        </p:txBody>
-      </p:sp>
-      <p:sp>
-        <p:nvSpPr>
-          <p:cNvPr id="32" name="TextBox 31"/>
-          <p:cNvSpPr txBox="1"/>
-          <p:nvPr/>
-        </p:nvSpPr>
-        <p:spPr>
-          <a:xfrm>
-            <a:off x="10094976" y="2011680"/>
-            <a:ext cx="1371600" cy="274320"/>
-          </a:xfrm>
-          <a:prstGeom prst="rect">
-            <a:avLst/>
-          </a:prstGeom>
-          <a:noFill/>
-        </p:spPr>
-        <p:txBody>
-          <a:bodyPr wrap="square" lIns="0" rIns="0" tIns="0" bIns="0" anchor="t">
-            <a:spAutoFit/>
-          </a:bodyPr>
-          <a:lstStyle/>
-          <a:p>
-            <a:pPr algn="l"/>
-            <a:r>
-              <a:rPr sz="1100" b="1" i="0">
-                <a:solidFill>
-                  <a:srgbClr val="EB6A35"/>
-                </a:solidFill>
-                <a:latin typeface="Calibri"/>
-              </a:rPr>
-              <a:t>CLASSIFICATION</a:t>
-            </a:r>
-          </a:p>
-        </p:txBody>
-      </p:sp>
-      <p:sp>
-        <p:nvSpPr>
-          <p:cNvPr id="33" name="TextBox 32"/>
-          <p:cNvSpPr txBox="1"/>
-          <p:nvPr/>
-        </p:nvSpPr>
-        <p:spPr>
-          <a:xfrm>
-            <a:off x="10094976" y="2331720"/>
-            <a:ext cx="1371600" cy="822960"/>
-          </a:xfrm>
-          <a:prstGeom prst="rect">
-            <a:avLst/>
-          </a:prstGeom>
-          <a:noFill/>
-        </p:spPr>
-        <p:txBody>
-          <a:bodyPr wrap="square" lIns="0" rIns="0" tIns="0" bIns="0" anchor="t">
-            <a:spAutoFit/>
-          </a:bodyPr>
-          <a:lstStyle/>
-          <a:p>
-            <a:pPr algn="l"/>
-            <a:r>
-              <a:rPr sz="2000" b="1" i="0">
-                <a:solidFill>
-                  <a:srgbClr val="FFFFFF"/>
-                </a:solidFill>
-                <a:latin typeface="Cambria"/>
-              </a:rPr>
-              <a:t>Logistic</a:t>
-            </a:r>
-          </a:p>
-        </p:txBody>
-      </p:sp>
-      <p:sp>
-        <p:nvSpPr>
-          <p:cNvPr id="34" name="TextBox 33"/>
-          <p:cNvSpPr txBox="1"/>
-          <p:nvPr/>
-        </p:nvSpPr>
-        <p:spPr>
-          <a:xfrm>
-            <a:off x="10094976" y="3200400"/>
-            <a:ext cx="1371600" cy="1280160"/>
-          </a:xfrm>
-          <a:prstGeom prst="rect">
-            <a:avLst/>
-          </a:prstGeom>
-          <a:noFill/>
-        </p:spPr>
-        <p:txBody>
-          <a:bodyPr wrap="square" lIns="0" rIns="0" tIns="0" bIns="0" anchor="t">
-            <a:spAutoFit/>
-          </a:bodyPr>
-          <a:lstStyle/>
-          <a:p>
-            <a:pPr algn="l"/>
-            <a:r>
-              <a:rPr sz="1400" b="0" i="0">
-                <a:solidFill>
-                  <a:srgbClr val="C9D3E6"/>
-                </a:solidFill>
-                <a:latin typeface="Calibri"/>
-              </a:rPr>
-              <a:t>L2; C from 10⁻⁵ to 10, log-loss tuning</a:t>
-            </a:r>
-          </a:p>
-        </p:txBody>
-      </p:sp>
-      <p:sp>
-        <p:nvSpPr>
-          <p:cNvPr id="35" name="TextBox 34"/>
-          <p:cNvSpPr txBox="1"/>
-          <p:nvPr/>
-        </p:nvSpPr>
-        <p:spPr>
-          <a:xfrm>
-            <a:off x="10094976" y="4572000"/>
-            <a:ext cx="1371600" cy="1188720"/>
-          </a:xfrm>
-          <a:prstGeom prst="rect">
-            <a:avLst/>
-          </a:prstGeom>
-          <a:noFill/>
-        </p:spPr>
-        <p:txBody>
-          <a:bodyPr wrap="square" lIns="0" rIns="0" tIns="0" bIns="0" anchor="t">
-            <a:spAutoFit/>
-          </a:bodyPr>
-          <a:lstStyle/>
-          <a:p>
-            <a:pPr algn="l"/>
-            <a:r>
-              <a:rPr sz="1400" b="1" i="0">
-                <a:solidFill>
-                  <a:srgbClr val="FFFFFF"/>
-                </a:solidFill>
-                <a:latin typeface="Calibri"/>
-              </a:rPr>
-              <a:t>Events: top-20% vol, 1.5× spike</a:t>
             </a:r>
           </a:p>
         </p:txBody>

</xml_diff>